<commit_message>
Update presentation file with latest project insights and data
</commit_message>
<xml_diff>
--- a/presi.pptx
+++ b/presi.pptx
@@ -4,9 +4,14 @@
   <p:sldMasterIdLst>
     <p:sldMasterId id="2147483648" r:id="rId1"/>
   </p:sldMasterIdLst>
+  <p:notesMasterIdLst>
+    <p:notesMasterId r:id="rId6"/>
+  </p:notesMasterIdLst>
   <p:sldIdLst>
-    <p:sldId id="256" r:id="rId2"/>
-    <p:sldId id="257" r:id="rId3"/>
+    <p:sldId id="259" r:id="rId2"/>
+    <p:sldId id="258" r:id="rId3"/>
+    <p:sldId id="261" r:id="rId4"/>
+    <p:sldId id="260" r:id="rId5"/>
   </p:sldIdLst>
   <p:sldSz cx="12192000" cy="6858000"/>
   <p:notesSz cx="6858000" cy="9144000"/>
@@ -113,6 +118,1109 @@
 </p:presentation>
 </file>
 
+<file path=ppt/notesMasters/notesMaster1.xml><?xml version="1.0" encoding="utf-8"?>
+<p:notesMaster xmlns:a="http://schemas.openxmlformats.org/drawingml/2006/main" xmlns:r="http://schemas.openxmlformats.org/officeDocument/2006/relationships" xmlns:p="http://schemas.openxmlformats.org/presentationml/2006/main">
+  <p:cSld>
+    <p:bg>
+      <p:bgRef idx="1001">
+        <a:schemeClr val="bg1"/>
+      </p:bgRef>
+    </p:bg>
+    <p:spTree>
+      <p:nvGrpSpPr>
+        <p:cNvPr id="1" name=""/>
+        <p:cNvGrpSpPr/>
+        <p:nvPr/>
+      </p:nvGrpSpPr>
+      <p:grpSpPr>
+        <a:xfrm>
+          <a:off x="0" y="0"/>
+          <a:ext cx="0" cy="0"/>
+          <a:chOff x="0" y="0"/>
+          <a:chExt cx="0" cy="0"/>
+        </a:xfrm>
+      </p:grpSpPr>
+      <p:sp>
+        <p:nvSpPr>
+          <p:cNvPr id="2" name="Kopfzeilenplatzhalter 1"/>
+          <p:cNvSpPr>
+            <a:spLocks noGrp="1"/>
+          </p:cNvSpPr>
+          <p:nvPr>
+            <p:ph type="hdr" sz="quarter"/>
+          </p:nvPr>
+        </p:nvSpPr>
+        <p:spPr>
+          <a:xfrm>
+            <a:off x="0" y="0"/>
+            <a:ext cx="2971800" cy="458788"/>
+          </a:xfrm>
+          <a:prstGeom prst="rect">
+            <a:avLst/>
+          </a:prstGeom>
+        </p:spPr>
+        <p:txBody>
+          <a:bodyPr vert="horz" lIns="91440" tIns="45720" rIns="91440" bIns="45720" rtlCol="0"/>
+          <a:lstStyle>
+            <a:lvl1pPr algn="l">
+              <a:defRPr sz="1200"/>
+            </a:lvl1pPr>
+          </a:lstStyle>
+          <a:p>
+            <a:endParaRPr lang="de-DE"/>
+          </a:p>
+        </p:txBody>
+      </p:sp>
+      <p:sp>
+        <p:nvSpPr>
+          <p:cNvPr id="3" name="Datumsplatzhalter 2"/>
+          <p:cNvSpPr>
+            <a:spLocks noGrp="1"/>
+          </p:cNvSpPr>
+          <p:nvPr>
+            <p:ph type="dt" idx="1"/>
+          </p:nvPr>
+        </p:nvSpPr>
+        <p:spPr>
+          <a:xfrm>
+            <a:off x="3884613" y="0"/>
+            <a:ext cx="2971800" cy="458788"/>
+          </a:xfrm>
+          <a:prstGeom prst="rect">
+            <a:avLst/>
+          </a:prstGeom>
+        </p:spPr>
+        <p:txBody>
+          <a:bodyPr vert="horz" lIns="91440" tIns="45720" rIns="91440" bIns="45720" rtlCol="0"/>
+          <a:lstStyle>
+            <a:lvl1pPr algn="r">
+              <a:defRPr sz="1200"/>
+            </a:lvl1pPr>
+          </a:lstStyle>
+          <a:p>
+            <a:fld id="{A0EE3C2C-F415-442F-AC6B-682E5D6A856C}" type="datetimeFigureOut">
+              <a:rPr lang="de-DE" smtClean="0"/>
+              <a:t>24.10.2026</a:t>
+            </a:fld>
+            <a:endParaRPr lang="de-DE"/>
+          </a:p>
+        </p:txBody>
+      </p:sp>
+      <p:sp>
+        <p:nvSpPr>
+          <p:cNvPr id="4" name="Folienbildplatzhalter 3"/>
+          <p:cNvSpPr>
+            <a:spLocks noGrp="1" noRot="1" noChangeAspect="1"/>
+          </p:cNvSpPr>
+          <p:nvPr>
+            <p:ph type="sldImg" idx="2"/>
+          </p:nvPr>
+        </p:nvSpPr>
+        <p:spPr>
+          <a:xfrm>
+            <a:off x="685800" y="1143000"/>
+            <a:ext cx="5486400" cy="3086100"/>
+          </a:xfrm>
+          <a:prstGeom prst="rect">
+            <a:avLst/>
+          </a:prstGeom>
+          <a:noFill/>
+          <a:ln w="12700">
+            <a:solidFill>
+              <a:prstClr val="black"/>
+            </a:solidFill>
+          </a:ln>
+        </p:spPr>
+        <p:txBody>
+          <a:bodyPr vert="horz" lIns="91440" tIns="45720" rIns="91440" bIns="45720" rtlCol="0" anchor="ctr"/>
+          <a:lstStyle/>
+          <a:p>
+            <a:endParaRPr lang="de-DE"/>
+          </a:p>
+        </p:txBody>
+      </p:sp>
+      <p:sp>
+        <p:nvSpPr>
+          <p:cNvPr id="5" name="Notizenplatzhalter 4"/>
+          <p:cNvSpPr>
+            <a:spLocks noGrp="1"/>
+          </p:cNvSpPr>
+          <p:nvPr>
+            <p:ph type="body" sz="quarter" idx="3"/>
+          </p:nvPr>
+        </p:nvSpPr>
+        <p:spPr>
+          <a:xfrm>
+            <a:off x="685800" y="4400550"/>
+            <a:ext cx="5486400" cy="3600450"/>
+          </a:xfrm>
+          <a:prstGeom prst="rect">
+            <a:avLst/>
+          </a:prstGeom>
+        </p:spPr>
+        <p:txBody>
+          <a:bodyPr vert="horz" lIns="91440" tIns="45720" rIns="91440" bIns="45720" rtlCol="0"/>
+          <a:lstStyle/>
+          <a:p>
+            <a:pPr lvl="0"/>
+            <a:r>
+              <a:rPr lang="de-DE"/>
+              <a:t>Mastertextformat bearbeiten</a:t>
+            </a:r>
+          </a:p>
+          <a:p>
+            <a:pPr lvl="1"/>
+            <a:r>
+              <a:rPr lang="de-DE"/>
+              <a:t>Zweite Ebene</a:t>
+            </a:r>
+          </a:p>
+          <a:p>
+            <a:pPr lvl="2"/>
+            <a:r>
+              <a:rPr lang="de-DE"/>
+              <a:t>Dritte Ebene</a:t>
+            </a:r>
+          </a:p>
+          <a:p>
+            <a:pPr lvl="3"/>
+            <a:r>
+              <a:rPr lang="de-DE"/>
+              <a:t>Vierte Ebene</a:t>
+            </a:r>
+          </a:p>
+          <a:p>
+            <a:pPr lvl="4"/>
+            <a:r>
+              <a:rPr lang="de-DE"/>
+              <a:t>Fünfte Ebene</a:t>
+            </a:r>
+          </a:p>
+        </p:txBody>
+      </p:sp>
+      <p:sp>
+        <p:nvSpPr>
+          <p:cNvPr id="6" name="Fußzeilenplatzhalter 5"/>
+          <p:cNvSpPr>
+            <a:spLocks noGrp="1"/>
+          </p:cNvSpPr>
+          <p:nvPr>
+            <p:ph type="ftr" sz="quarter" idx="4"/>
+          </p:nvPr>
+        </p:nvSpPr>
+        <p:spPr>
+          <a:xfrm>
+            <a:off x="0" y="8685213"/>
+            <a:ext cx="2971800" cy="458787"/>
+          </a:xfrm>
+          <a:prstGeom prst="rect">
+            <a:avLst/>
+          </a:prstGeom>
+        </p:spPr>
+        <p:txBody>
+          <a:bodyPr vert="horz" lIns="91440" tIns="45720" rIns="91440" bIns="45720" rtlCol="0" anchor="b"/>
+          <a:lstStyle>
+            <a:lvl1pPr algn="l">
+              <a:defRPr sz="1200"/>
+            </a:lvl1pPr>
+          </a:lstStyle>
+          <a:p>
+            <a:endParaRPr lang="de-DE"/>
+          </a:p>
+        </p:txBody>
+      </p:sp>
+      <p:sp>
+        <p:nvSpPr>
+          <p:cNvPr id="7" name="Foliennummernplatzhalter 6"/>
+          <p:cNvSpPr>
+            <a:spLocks noGrp="1"/>
+          </p:cNvSpPr>
+          <p:nvPr>
+            <p:ph type="sldNum" sz="quarter" idx="5"/>
+          </p:nvPr>
+        </p:nvSpPr>
+        <p:spPr>
+          <a:xfrm>
+            <a:off x="3884613" y="8685213"/>
+            <a:ext cx="2971800" cy="458787"/>
+          </a:xfrm>
+          <a:prstGeom prst="rect">
+            <a:avLst/>
+          </a:prstGeom>
+        </p:spPr>
+        <p:txBody>
+          <a:bodyPr vert="horz" lIns="91440" tIns="45720" rIns="91440" bIns="45720" rtlCol="0" anchor="b"/>
+          <a:lstStyle>
+            <a:lvl1pPr algn="r">
+              <a:defRPr sz="1200"/>
+            </a:lvl1pPr>
+          </a:lstStyle>
+          <a:p>
+            <a:fld id="{5AB691D1-3BB7-4244-B7AD-11AA4C00049C}" type="slidenum">
+              <a:rPr lang="de-DE" smtClean="0"/>
+              <a:t>‹Nr.›</a:t>
+            </a:fld>
+            <a:endParaRPr lang="de-DE"/>
+          </a:p>
+        </p:txBody>
+      </p:sp>
+    </p:spTree>
+    <p:extLst>
+      <p:ext uri="{BB962C8B-B14F-4D97-AF65-F5344CB8AC3E}">
+        <p14:creationId xmlns:p14="http://schemas.microsoft.com/office/powerpoint/2010/main" val="2429926214"/>
+      </p:ext>
+    </p:extLst>
+  </p:cSld>
+  <p:clrMap bg1="lt1" tx1="dk1" bg2="lt2" tx2="dk2" accent1="accent1" accent2="accent2" accent3="accent3" accent4="accent4" accent5="accent5" accent6="accent6" hlink="hlink" folHlink="folHlink"/>
+  <p:notesStyle>
+    <a:lvl1pPr marL="0" algn="l" defTabSz="914400" rtl="0" eaLnBrk="1" latinLnBrk="0" hangingPunct="1">
+      <a:defRPr sz="1200" kern="1200">
+        <a:solidFill>
+          <a:schemeClr val="tx1"/>
+        </a:solidFill>
+        <a:latin typeface="+mn-lt"/>
+        <a:ea typeface="+mn-ea"/>
+        <a:cs typeface="+mn-cs"/>
+      </a:defRPr>
+    </a:lvl1pPr>
+    <a:lvl2pPr marL="457200" algn="l" defTabSz="914400" rtl="0" eaLnBrk="1" latinLnBrk="0" hangingPunct="1">
+      <a:defRPr sz="1200" kern="1200">
+        <a:solidFill>
+          <a:schemeClr val="tx1"/>
+        </a:solidFill>
+        <a:latin typeface="+mn-lt"/>
+        <a:ea typeface="+mn-ea"/>
+        <a:cs typeface="+mn-cs"/>
+      </a:defRPr>
+    </a:lvl2pPr>
+    <a:lvl3pPr marL="914400" algn="l" defTabSz="914400" rtl="0" eaLnBrk="1" latinLnBrk="0" hangingPunct="1">
+      <a:defRPr sz="1200" kern="1200">
+        <a:solidFill>
+          <a:schemeClr val="tx1"/>
+        </a:solidFill>
+        <a:latin typeface="+mn-lt"/>
+        <a:ea typeface="+mn-ea"/>
+        <a:cs typeface="+mn-cs"/>
+      </a:defRPr>
+    </a:lvl3pPr>
+    <a:lvl4pPr marL="1371600" algn="l" defTabSz="914400" rtl="0" eaLnBrk="1" latinLnBrk="0" hangingPunct="1">
+      <a:defRPr sz="1200" kern="1200">
+        <a:solidFill>
+          <a:schemeClr val="tx1"/>
+        </a:solidFill>
+        <a:latin typeface="+mn-lt"/>
+        <a:ea typeface="+mn-ea"/>
+        <a:cs typeface="+mn-cs"/>
+      </a:defRPr>
+    </a:lvl4pPr>
+    <a:lvl5pPr marL="1828800" algn="l" defTabSz="914400" rtl="0" eaLnBrk="1" latinLnBrk="0" hangingPunct="1">
+      <a:defRPr sz="1200" kern="1200">
+        <a:solidFill>
+          <a:schemeClr val="tx1"/>
+        </a:solidFill>
+        <a:latin typeface="+mn-lt"/>
+        <a:ea typeface="+mn-ea"/>
+        <a:cs typeface="+mn-cs"/>
+      </a:defRPr>
+    </a:lvl5pPr>
+    <a:lvl6pPr marL="2286000" algn="l" defTabSz="914400" rtl="0" eaLnBrk="1" latinLnBrk="0" hangingPunct="1">
+      <a:defRPr sz="1200" kern="1200">
+        <a:solidFill>
+          <a:schemeClr val="tx1"/>
+        </a:solidFill>
+        <a:latin typeface="+mn-lt"/>
+        <a:ea typeface="+mn-ea"/>
+        <a:cs typeface="+mn-cs"/>
+      </a:defRPr>
+    </a:lvl6pPr>
+    <a:lvl7pPr marL="2743200" algn="l" defTabSz="914400" rtl="0" eaLnBrk="1" latinLnBrk="0" hangingPunct="1">
+      <a:defRPr sz="1200" kern="1200">
+        <a:solidFill>
+          <a:schemeClr val="tx1"/>
+        </a:solidFill>
+        <a:latin typeface="+mn-lt"/>
+        <a:ea typeface="+mn-ea"/>
+        <a:cs typeface="+mn-cs"/>
+      </a:defRPr>
+    </a:lvl7pPr>
+    <a:lvl8pPr marL="3200400" algn="l" defTabSz="914400" rtl="0" eaLnBrk="1" latinLnBrk="0" hangingPunct="1">
+      <a:defRPr sz="1200" kern="1200">
+        <a:solidFill>
+          <a:schemeClr val="tx1"/>
+        </a:solidFill>
+        <a:latin typeface="+mn-lt"/>
+        <a:ea typeface="+mn-ea"/>
+        <a:cs typeface="+mn-cs"/>
+      </a:defRPr>
+    </a:lvl8pPr>
+    <a:lvl9pPr marL="3657600" algn="l" defTabSz="914400" rtl="0" eaLnBrk="1" latinLnBrk="0" hangingPunct="1">
+      <a:defRPr sz="1200" kern="1200">
+        <a:solidFill>
+          <a:schemeClr val="tx1"/>
+        </a:solidFill>
+        <a:latin typeface="+mn-lt"/>
+        <a:ea typeface="+mn-ea"/>
+        <a:cs typeface="+mn-cs"/>
+      </a:defRPr>
+    </a:lvl9pPr>
+  </p:notesStyle>
+</p:notesMaster>
+</file>
+
+<file path=ppt/notesSlides/notesSlide1.xml><?xml version="1.0" encoding="utf-8"?>
+<p:notes xmlns:a="http://schemas.openxmlformats.org/drawingml/2006/main" xmlns:r="http://schemas.openxmlformats.org/officeDocument/2006/relationships" xmlns:p="http://schemas.openxmlformats.org/presentationml/2006/main">
+  <p:cSld>
+    <p:spTree>
+      <p:nvGrpSpPr>
+        <p:cNvPr id="1" name=""/>
+        <p:cNvGrpSpPr/>
+        <p:nvPr/>
+      </p:nvGrpSpPr>
+      <p:grpSpPr>
+        <a:xfrm>
+          <a:off x="0" y="0"/>
+          <a:ext cx="0" cy="0"/>
+          <a:chOff x="0" y="0"/>
+          <a:chExt cx="0" cy="0"/>
+        </a:xfrm>
+      </p:grpSpPr>
+      <p:sp>
+        <p:nvSpPr>
+          <p:cNvPr id="2" name="Folienbildplatzhalter 1"/>
+          <p:cNvSpPr>
+            <a:spLocks noGrp="1" noRot="1" noChangeAspect="1"/>
+          </p:cNvSpPr>
+          <p:nvPr>
+            <p:ph type="sldImg"/>
+          </p:nvPr>
+        </p:nvSpPr>
+        <p:spPr/>
+      </p:sp>
+      <p:sp>
+        <p:nvSpPr>
+          <p:cNvPr id="3" name="Notizenplatzhalter 2"/>
+          <p:cNvSpPr>
+            <a:spLocks noGrp="1"/>
+          </p:cNvSpPr>
+          <p:nvPr>
+            <p:ph type="body" idx="1"/>
+          </p:nvPr>
+        </p:nvSpPr>
+        <p:spPr/>
+        <p:txBody>
+          <a:bodyPr/>
+          <a:lstStyle/>
+          <a:p>
+            <a:r>
+              <a:rPr lang="de-DE" dirty="0"/>
+              <a:t>Features: 10 min </a:t>
+            </a:r>
+            <a:r>
+              <a:rPr lang="de-DE" dirty="0" err="1"/>
+              <a:t>avg</a:t>
+            </a:r>
+            <a:r>
+              <a:rPr lang="de-DE" dirty="0"/>
+              <a:t> wind </a:t>
+            </a:r>
+            <a:r>
+              <a:rPr lang="de-DE" dirty="0" err="1"/>
+              <a:t>speed</a:t>
+            </a:r>
+            <a:r>
+              <a:rPr lang="de-DE" dirty="0"/>
+              <a:t> as </a:t>
+            </a:r>
+            <a:r>
+              <a:rPr lang="de-DE" dirty="0" err="1"/>
+              <a:t>provided</a:t>
+            </a:r>
+            <a:endParaRPr lang="de-DE" dirty="0"/>
+          </a:p>
+          <a:p>
+            <a:r>
+              <a:rPr lang="de-DE" dirty="0"/>
+              <a:t>60 min </a:t>
+            </a:r>
+            <a:r>
+              <a:rPr lang="de-DE" dirty="0" err="1"/>
+              <a:t>averaged</a:t>
+            </a:r>
+            <a:r>
+              <a:rPr lang="de-DE" dirty="0"/>
+              <a:t> wind </a:t>
+            </a:r>
+            <a:r>
+              <a:rPr lang="de-DE" dirty="0" err="1"/>
+              <a:t>speed</a:t>
+            </a:r>
+            <a:endParaRPr lang="de-DE" dirty="0"/>
+          </a:p>
+          <a:p>
+            <a:r>
+              <a:rPr lang="de-DE" dirty="0"/>
+              <a:t>8 wind </a:t>
+            </a:r>
+            <a:r>
+              <a:rPr lang="de-DE" dirty="0" err="1"/>
+              <a:t>direction</a:t>
+            </a:r>
+            <a:r>
+              <a:rPr lang="de-DE" dirty="0"/>
+              <a:t> </a:t>
+            </a:r>
+            <a:r>
+              <a:rPr lang="de-DE" dirty="0" err="1"/>
+              <a:t>sections</a:t>
+            </a:r>
+            <a:endParaRPr lang="de-DE" dirty="0"/>
+          </a:p>
+          <a:p>
+            <a:endParaRPr lang="de-DE" dirty="0"/>
+          </a:p>
+          <a:p>
+            <a:r>
+              <a:rPr lang="de-DE" dirty="0" err="1"/>
+              <a:t>learned</a:t>
+            </a:r>
+            <a:r>
+              <a:rPr lang="de-DE" dirty="0"/>
+              <a:t> the </a:t>
+            </a:r>
+            <a:r>
+              <a:rPr lang="de-DE" dirty="0" err="1"/>
+              <a:t>weights</a:t>
+            </a:r>
+            <a:r>
+              <a:rPr lang="de-DE" dirty="0"/>
+              <a:t> for </a:t>
+            </a:r>
+            <a:r>
+              <a:rPr lang="de-DE" dirty="0" err="1"/>
+              <a:t>summing</a:t>
+            </a:r>
+            <a:r>
+              <a:rPr lang="de-DE" dirty="0"/>
+              <a:t> </a:t>
+            </a:r>
+            <a:r>
+              <a:rPr lang="de-DE" dirty="0" err="1"/>
+              <a:t>up</a:t>
+            </a:r>
+            <a:r>
+              <a:rPr lang="de-DE" dirty="0"/>
+              <a:t>: </a:t>
+            </a:r>
+            <a:r>
+              <a:rPr lang="de-DE" dirty="0" err="1"/>
+              <a:t>we</a:t>
+            </a:r>
+            <a:r>
+              <a:rPr lang="de-DE" dirty="0"/>
+              <a:t> </a:t>
+            </a:r>
+            <a:r>
+              <a:rPr lang="de-DE" dirty="0" err="1"/>
+              <a:t>get</a:t>
+            </a:r>
+            <a:r>
+              <a:rPr lang="de-DE" dirty="0"/>
+              <a:t> a </a:t>
+            </a:r>
+            <a:r>
+              <a:rPr lang="de-DE" dirty="0" err="1"/>
+              <a:t>confidence</a:t>
+            </a:r>
+            <a:r>
+              <a:rPr lang="de-DE" dirty="0"/>
+              <a:t> score in </a:t>
+            </a:r>
+            <a:r>
+              <a:rPr lang="de-DE" dirty="0" err="1"/>
+              <a:t>which</a:t>
+            </a:r>
+            <a:r>
+              <a:rPr lang="de-DE" dirty="0"/>
+              <a:t> the </a:t>
+            </a:r>
+            <a:r>
+              <a:rPr lang="de-DE" dirty="0" err="1"/>
+              <a:t>windspeed</a:t>
+            </a:r>
+            <a:r>
+              <a:rPr lang="de-DE" dirty="0"/>
+              <a:t> </a:t>
+            </a:r>
+            <a:r>
+              <a:rPr lang="de-DE" dirty="0" err="1"/>
+              <a:t>probably</a:t>
+            </a:r>
+            <a:r>
+              <a:rPr lang="de-DE" dirty="0"/>
+              <a:t> lies</a:t>
+            </a:r>
+          </a:p>
+          <a:p>
+            <a:r>
+              <a:rPr lang="de-DE" dirty="0" err="1"/>
+              <a:t>we</a:t>
+            </a:r>
+            <a:r>
+              <a:rPr lang="de-DE" dirty="0"/>
+              <a:t> </a:t>
+            </a:r>
+            <a:r>
+              <a:rPr lang="de-DE" dirty="0" err="1"/>
+              <a:t>tried</a:t>
+            </a:r>
+            <a:r>
+              <a:rPr lang="de-DE" dirty="0"/>
+              <a:t> </a:t>
+            </a:r>
+            <a:r>
+              <a:rPr lang="de-DE" dirty="0" err="1"/>
+              <a:t>more</a:t>
+            </a:r>
+            <a:r>
+              <a:rPr lang="de-DE" dirty="0"/>
+              <a:t> </a:t>
+            </a:r>
+            <a:r>
+              <a:rPr lang="de-DE" dirty="0" err="1"/>
+              <a:t>complex</a:t>
+            </a:r>
+            <a:r>
+              <a:rPr lang="de-DE" dirty="0"/>
+              <a:t> </a:t>
+            </a:r>
+            <a:r>
+              <a:rPr lang="de-DE" dirty="0" err="1"/>
+              <a:t>models</a:t>
+            </a:r>
+            <a:r>
+              <a:rPr lang="de-DE" dirty="0"/>
+              <a:t> and also different </a:t>
+            </a:r>
+            <a:r>
+              <a:rPr lang="de-DE" dirty="0" err="1"/>
+              <a:t>features</a:t>
+            </a:r>
+            <a:r>
+              <a:rPr lang="de-DE" dirty="0"/>
+              <a:t> </a:t>
+            </a:r>
+            <a:r>
+              <a:rPr lang="de-DE" dirty="0" err="1"/>
+              <a:t>that</a:t>
+            </a:r>
+            <a:r>
+              <a:rPr lang="de-DE" dirty="0"/>
+              <a:t> </a:t>
+            </a:r>
+            <a:r>
+              <a:rPr lang="de-DE" dirty="0" err="1"/>
+              <a:t>didnt</a:t>
+            </a:r>
+            <a:r>
+              <a:rPr lang="de-DE" dirty="0"/>
+              <a:t> </a:t>
+            </a:r>
+            <a:r>
+              <a:rPr lang="de-DE" dirty="0" err="1"/>
+              <a:t>improve</a:t>
+            </a:r>
+            <a:r>
+              <a:rPr lang="de-DE" dirty="0"/>
+              <a:t> and </a:t>
+            </a:r>
+            <a:r>
+              <a:rPr lang="de-DE" dirty="0" err="1"/>
+              <a:t>therefore</a:t>
+            </a:r>
+            <a:r>
+              <a:rPr lang="de-DE" dirty="0"/>
+              <a:t> </a:t>
+            </a:r>
+            <a:r>
+              <a:rPr lang="de-DE" dirty="0" err="1"/>
+              <a:t>chose</a:t>
+            </a:r>
+            <a:r>
+              <a:rPr lang="de-DE" dirty="0"/>
+              <a:t> </a:t>
+            </a:r>
+            <a:r>
+              <a:rPr lang="de-DE" dirty="0" err="1"/>
+              <a:t>explainability</a:t>
+            </a:r>
+            <a:endParaRPr lang="de-DE" dirty="0"/>
+          </a:p>
+          <a:p>
+            <a:endParaRPr lang="de-DE" dirty="0"/>
+          </a:p>
+          <a:p>
+            <a:endParaRPr lang="de-DE" dirty="0"/>
+          </a:p>
+          <a:p>
+            <a:r>
+              <a:rPr lang="de-DE" dirty="0" err="1"/>
+              <a:t>windspeed</a:t>
+            </a:r>
+            <a:r>
+              <a:rPr lang="de-DE" dirty="0"/>
+              <a:t> to power </a:t>
+            </a:r>
+            <a:r>
+              <a:rPr lang="de-DE" dirty="0" err="1"/>
+              <a:t>curve</a:t>
+            </a:r>
+            <a:r>
+              <a:rPr lang="de-DE" dirty="0"/>
+              <a:t> </a:t>
+            </a:r>
+            <a:r>
+              <a:rPr lang="de-DE" dirty="0" err="1"/>
+              <a:t>is</a:t>
+            </a:r>
+            <a:r>
+              <a:rPr lang="de-DE" dirty="0"/>
+              <a:t> non linear and </a:t>
+            </a:r>
+            <a:r>
+              <a:rPr lang="de-DE" dirty="0" err="1"/>
+              <a:t>average</a:t>
+            </a:r>
+            <a:r>
+              <a:rPr lang="de-DE" dirty="0"/>
+              <a:t> wind </a:t>
+            </a:r>
+            <a:r>
+              <a:rPr lang="de-DE" dirty="0" err="1"/>
+              <a:t>speeds</a:t>
+            </a:r>
+            <a:r>
+              <a:rPr lang="de-DE" dirty="0"/>
+              <a:t> </a:t>
+            </a:r>
+            <a:r>
+              <a:rPr lang="de-DE" dirty="0" err="1"/>
+              <a:t>are</a:t>
+            </a:r>
+            <a:r>
+              <a:rPr lang="de-DE" dirty="0"/>
+              <a:t> </a:t>
+            </a:r>
+            <a:r>
+              <a:rPr lang="de-DE" dirty="0" err="1"/>
+              <a:t>around</a:t>
+            </a:r>
+            <a:r>
+              <a:rPr lang="de-DE" dirty="0"/>
+              <a:t> </a:t>
+            </a:r>
+            <a:r>
+              <a:rPr lang="de-DE" dirty="0" err="1"/>
+              <a:t>steepest</a:t>
+            </a:r>
+            <a:r>
+              <a:rPr lang="de-DE" dirty="0"/>
+              <a:t> </a:t>
+            </a:r>
+            <a:r>
+              <a:rPr lang="de-DE" dirty="0" err="1"/>
+              <a:t>point</a:t>
+            </a:r>
+            <a:r>
+              <a:rPr lang="de-DE" dirty="0"/>
+              <a:t> -&gt; small wind </a:t>
+            </a:r>
+            <a:r>
+              <a:rPr lang="de-DE" dirty="0" err="1"/>
+              <a:t>speed</a:t>
+            </a:r>
+            <a:r>
+              <a:rPr lang="de-DE" dirty="0"/>
+              <a:t> </a:t>
+            </a:r>
+            <a:r>
+              <a:rPr lang="de-DE" dirty="0" err="1"/>
+              <a:t>estimation</a:t>
+            </a:r>
+            <a:r>
+              <a:rPr lang="de-DE" dirty="0"/>
+              <a:t> </a:t>
+            </a:r>
+            <a:r>
+              <a:rPr lang="de-DE" dirty="0" err="1"/>
+              <a:t>error</a:t>
+            </a:r>
+            <a:r>
+              <a:rPr lang="de-DE" dirty="0"/>
+              <a:t> </a:t>
+            </a:r>
+            <a:r>
+              <a:rPr lang="de-DE" dirty="0" err="1"/>
+              <a:t>results</a:t>
+            </a:r>
+            <a:r>
+              <a:rPr lang="de-DE" dirty="0"/>
+              <a:t> in </a:t>
+            </a:r>
+            <a:r>
+              <a:rPr lang="de-DE" dirty="0" err="1"/>
+              <a:t>huge</a:t>
+            </a:r>
+            <a:r>
+              <a:rPr lang="de-DE" dirty="0"/>
+              <a:t> power </a:t>
+            </a:r>
+            <a:r>
+              <a:rPr lang="de-DE" dirty="0" err="1"/>
+              <a:t>estimation</a:t>
+            </a:r>
+            <a:r>
+              <a:rPr lang="de-DE" dirty="0"/>
+              <a:t> </a:t>
+            </a:r>
+            <a:r>
+              <a:rPr lang="de-DE" dirty="0" err="1"/>
+              <a:t>error</a:t>
+            </a:r>
+            <a:r>
+              <a:rPr lang="de-DE" dirty="0"/>
+              <a:t> -&gt; </a:t>
+            </a:r>
+            <a:r>
+              <a:rPr lang="de-DE" dirty="0" err="1"/>
+              <a:t>optimize</a:t>
+            </a:r>
+            <a:r>
+              <a:rPr lang="de-DE" dirty="0"/>
+              <a:t> for </a:t>
+            </a:r>
+            <a:r>
+              <a:rPr lang="de-DE" dirty="0" err="1"/>
+              <a:t>correct</a:t>
+            </a:r>
+            <a:r>
+              <a:rPr lang="de-DE" dirty="0"/>
+              <a:t> </a:t>
+            </a:r>
+            <a:r>
+              <a:rPr lang="de-DE" dirty="0" err="1"/>
+              <a:t>energy</a:t>
+            </a:r>
+            <a:r>
+              <a:rPr lang="de-DE" dirty="0"/>
+              <a:t> </a:t>
+            </a:r>
+            <a:r>
+              <a:rPr lang="de-DE" dirty="0" err="1"/>
+              <a:t>loss</a:t>
+            </a:r>
+            <a:r>
+              <a:rPr lang="de-DE" dirty="0"/>
+              <a:t> </a:t>
+            </a:r>
+            <a:r>
+              <a:rPr lang="de-DE" dirty="0" err="1"/>
+              <a:t>estimation</a:t>
+            </a:r>
+            <a:r>
+              <a:rPr lang="de-DE" dirty="0"/>
+              <a:t> by </a:t>
+            </a:r>
+            <a:r>
+              <a:rPr lang="de-DE" dirty="0" err="1"/>
+              <a:t>using</a:t>
+            </a:r>
+            <a:r>
+              <a:rPr lang="de-DE" dirty="0"/>
+              <a:t> a </a:t>
+            </a:r>
+            <a:r>
+              <a:rPr lang="de-DE" dirty="0" err="1"/>
+              <a:t>statistical</a:t>
+            </a:r>
+            <a:r>
+              <a:rPr lang="de-DE" dirty="0"/>
+              <a:t> </a:t>
+            </a:r>
+            <a:r>
+              <a:rPr lang="de-DE" dirty="0" err="1"/>
+              <a:t>model</a:t>
+            </a:r>
+            <a:r>
+              <a:rPr lang="de-DE" dirty="0"/>
+              <a:t>: sample </a:t>
+            </a:r>
+            <a:r>
+              <a:rPr lang="de-DE" dirty="0" err="1"/>
+              <a:t>gaussian</a:t>
+            </a:r>
+            <a:r>
+              <a:rPr lang="de-DE" dirty="0"/>
+              <a:t> </a:t>
+            </a:r>
+            <a:r>
+              <a:rPr lang="de-DE" dirty="0" err="1"/>
+              <a:t>distributed</a:t>
+            </a:r>
+            <a:r>
+              <a:rPr lang="de-DE" dirty="0"/>
+              <a:t> </a:t>
+            </a:r>
+            <a:r>
+              <a:rPr lang="de-DE" dirty="0" err="1"/>
+              <a:t>from</a:t>
+            </a:r>
+            <a:r>
+              <a:rPr lang="de-DE" dirty="0"/>
+              <a:t> power </a:t>
+            </a:r>
+            <a:r>
+              <a:rPr lang="de-DE" dirty="0" err="1"/>
+              <a:t>curve</a:t>
+            </a:r>
+            <a:endParaRPr lang="de-DE" dirty="0"/>
+          </a:p>
+        </p:txBody>
+      </p:sp>
+      <p:sp>
+        <p:nvSpPr>
+          <p:cNvPr id="4" name="Foliennummernplatzhalter 3"/>
+          <p:cNvSpPr>
+            <a:spLocks noGrp="1"/>
+          </p:cNvSpPr>
+          <p:nvPr>
+            <p:ph type="sldNum" sz="quarter" idx="5"/>
+          </p:nvPr>
+        </p:nvSpPr>
+        <p:spPr/>
+        <p:txBody>
+          <a:bodyPr/>
+          <a:lstStyle/>
+          <a:p>
+            <a:fld id="{5AB691D1-3BB7-4244-B7AD-11AA4C00049C}" type="slidenum">
+              <a:rPr lang="de-DE" smtClean="0"/>
+              <a:t>2</a:t>
+            </a:fld>
+            <a:endParaRPr lang="de-DE"/>
+          </a:p>
+        </p:txBody>
+      </p:sp>
+    </p:spTree>
+    <p:extLst>
+      <p:ext uri="{BB962C8B-B14F-4D97-AF65-F5344CB8AC3E}">
+        <p14:creationId xmlns:p14="http://schemas.microsoft.com/office/powerpoint/2010/main" val="1688177976"/>
+      </p:ext>
+    </p:extLst>
+  </p:cSld>
+  <p:clrMapOvr>
+    <a:masterClrMapping/>
+  </p:clrMapOvr>
+</p:notes>
+</file>
+
+<file path=ppt/notesSlides/notesSlide2.xml><?xml version="1.0" encoding="utf-8"?>
+<p:notes xmlns:a="http://schemas.openxmlformats.org/drawingml/2006/main" xmlns:r="http://schemas.openxmlformats.org/officeDocument/2006/relationships" xmlns:p="http://schemas.openxmlformats.org/presentationml/2006/main">
+  <p:cSld>
+    <p:spTree>
+      <p:nvGrpSpPr>
+        <p:cNvPr id="1" name=""/>
+        <p:cNvGrpSpPr/>
+        <p:nvPr/>
+      </p:nvGrpSpPr>
+      <p:grpSpPr>
+        <a:xfrm>
+          <a:off x="0" y="0"/>
+          <a:ext cx="0" cy="0"/>
+          <a:chOff x="0" y="0"/>
+          <a:chExt cx="0" cy="0"/>
+        </a:xfrm>
+      </p:grpSpPr>
+      <p:sp>
+        <p:nvSpPr>
+          <p:cNvPr id="2" name="Folienbildplatzhalter 1"/>
+          <p:cNvSpPr>
+            <a:spLocks noGrp="1" noRot="1" noChangeAspect="1"/>
+          </p:cNvSpPr>
+          <p:nvPr>
+            <p:ph type="sldImg"/>
+          </p:nvPr>
+        </p:nvSpPr>
+        <p:spPr/>
+      </p:sp>
+      <p:sp>
+        <p:nvSpPr>
+          <p:cNvPr id="3" name="Notizenplatzhalter 2"/>
+          <p:cNvSpPr>
+            <a:spLocks noGrp="1"/>
+          </p:cNvSpPr>
+          <p:nvPr>
+            <p:ph type="body" idx="1"/>
+          </p:nvPr>
+        </p:nvSpPr>
+        <p:spPr/>
+        <p:txBody>
+          <a:bodyPr/>
+          <a:lstStyle/>
+          <a:p>
+            <a:endParaRPr lang="de-DE" dirty="0"/>
+          </a:p>
+        </p:txBody>
+      </p:sp>
+      <p:sp>
+        <p:nvSpPr>
+          <p:cNvPr id="4" name="Foliennummernplatzhalter 3"/>
+          <p:cNvSpPr>
+            <a:spLocks noGrp="1"/>
+          </p:cNvSpPr>
+          <p:nvPr>
+            <p:ph type="sldNum" sz="quarter" idx="5"/>
+          </p:nvPr>
+        </p:nvSpPr>
+        <p:spPr/>
+        <p:txBody>
+          <a:bodyPr/>
+          <a:lstStyle/>
+          <a:p>
+            <a:fld id="{5AB691D1-3BB7-4244-B7AD-11AA4C00049C}" type="slidenum">
+              <a:rPr lang="de-DE" smtClean="0"/>
+              <a:t>3</a:t>
+            </a:fld>
+            <a:endParaRPr lang="de-DE"/>
+          </a:p>
+        </p:txBody>
+      </p:sp>
+    </p:spTree>
+    <p:extLst>
+      <p:ext uri="{BB962C8B-B14F-4D97-AF65-F5344CB8AC3E}">
+        <p14:creationId xmlns:p14="http://schemas.microsoft.com/office/powerpoint/2010/main" val="373769657"/>
+      </p:ext>
+    </p:extLst>
+  </p:cSld>
+  <p:clrMapOvr>
+    <a:masterClrMapping/>
+  </p:clrMapOvr>
+</p:notes>
+</file>
+
+<file path=ppt/notesSlides/notesSlide3.xml><?xml version="1.0" encoding="utf-8"?>
+<p:notes xmlns:a="http://schemas.openxmlformats.org/drawingml/2006/main" xmlns:r="http://schemas.openxmlformats.org/officeDocument/2006/relationships" xmlns:p="http://schemas.openxmlformats.org/presentationml/2006/main">
+  <p:cSld>
+    <p:spTree>
+      <p:nvGrpSpPr>
+        <p:cNvPr id="1" name=""/>
+        <p:cNvGrpSpPr/>
+        <p:nvPr/>
+      </p:nvGrpSpPr>
+      <p:grpSpPr>
+        <a:xfrm>
+          <a:off x="0" y="0"/>
+          <a:ext cx="0" cy="0"/>
+          <a:chOff x="0" y="0"/>
+          <a:chExt cx="0" cy="0"/>
+        </a:xfrm>
+      </p:grpSpPr>
+      <p:sp>
+        <p:nvSpPr>
+          <p:cNvPr id="2" name="Folienbildplatzhalter 1"/>
+          <p:cNvSpPr>
+            <a:spLocks noGrp="1" noRot="1" noChangeAspect="1"/>
+          </p:cNvSpPr>
+          <p:nvPr>
+            <p:ph type="sldImg"/>
+          </p:nvPr>
+        </p:nvSpPr>
+        <p:spPr/>
+      </p:sp>
+      <p:sp>
+        <p:nvSpPr>
+          <p:cNvPr id="3" name="Notizenplatzhalter 2"/>
+          <p:cNvSpPr>
+            <a:spLocks noGrp="1"/>
+          </p:cNvSpPr>
+          <p:nvPr>
+            <p:ph type="body" idx="1"/>
+          </p:nvPr>
+        </p:nvSpPr>
+        <p:spPr/>
+        <p:txBody>
+          <a:bodyPr/>
+          <a:lstStyle/>
+          <a:p>
+            <a:pPr marL="0" marR="0" lvl="0" indent="0" algn="l" defTabSz="914400" rtl="0" eaLnBrk="1" fontAlgn="auto" latinLnBrk="0" hangingPunct="1">
+              <a:lnSpc>
+                <a:spcPct val="100000"/>
+              </a:lnSpc>
+              <a:spcBef>
+                <a:spcPts val="0"/>
+              </a:spcBef>
+              <a:spcAft>
+                <a:spcPts val="0"/>
+              </a:spcAft>
+              <a:buClrTx/>
+              <a:buSzTx/>
+              <a:buFontTx/>
+              <a:buNone/>
+              <a:tabLst/>
+              <a:defRPr/>
+            </a:pPr>
+            <a:r>
+              <a:rPr lang="en-US" sz="1200" b="1" i="0" dirty="0">
+                <a:solidFill>
+                  <a:srgbClr val="14261E"/>
+                </a:solidFill>
+                <a:latin typeface="Arial" pitchFamily="34" charset="0"/>
+                <a:ea typeface="Arial" pitchFamily="34" charset="-122"/>
+                <a:cs typeface="Arial" pitchFamily="34" charset="-120"/>
+              </a:rPr>
+              <a:t>Tested on 28 simulated outages, not one lucky week</a:t>
+            </a:r>
+            <a:endParaRPr lang="en-US" sz="1200" dirty="0"/>
+          </a:p>
+          <a:p>
+            <a:endParaRPr lang="de-DE" dirty="0"/>
+          </a:p>
+        </p:txBody>
+      </p:sp>
+      <p:sp>
+        <p:nvSpPr>
+          <p:cNvPr id="4" name="Foliennummernplatzhalter 3"/>
+          <p:cNvSpPr>
+            <a:spLocks noGrp="1"/>
+          </p:cNvSpPr>
+          <p:nvPr>
+            <p:ph type="sldNum" sz="quarter" idx="5"/>
+          </p:nvPr>
+        </p:nvSpPr>
+        <p:spPr/>
+        <p:txBody>
+          <a:bodyPr/>
+          <a:lstStyle/>
+          <a:p>
+            <a:fld id="{5AB691D1-3BB7-4244-B7AD-11AA4C00049C}" type="slidenum">
+              <a:rPr lang="de-DE" smtClean="0"/>
+              <a:t>4</a:t>
+            </a:fld>
+            <a:endParaRPr lang="de-DE"/>
+          </a:p>
+        </p:txBody>
+      </p:sp>
+    </p:spTree>
+    <p:extLst>
+      <p:ext uri="{BB962C8B-B14F-4D97-AF65-F5344CB8AC3E}">
+        <p14:creationId xmlns:p14="http://schemas.microsoft.com/office/powerpoint/2010/main" val="3701942101"/>
+      </p:ext>
+    </p:extLst>
+  </p:cSld>
+  <p:clrMapOvr>
+    <a:masterClrMapping/>
+  </p:clrMapOvr>
+</p:notes>
+</file>
+
 <file path=ppt/slideLayouts/slideLayout1.xml><?xml version="1.0" encoding="utf-8"?>
 <p:sldLayout xmlns:a="http://schemas.openxmlformats.org/drawingml/2006/main" xmlns:r="http://schemas.openxmlformats.org/officeDocument/2006/relationships" xmlns:p="http://schemas.openxmlformats.org/presentationml/2006/main" type="title" preserve="1">
   <p:cSld name="Titelfolie">
@@ -258,7 +1366,7 @@
           <a:bodyPr/>
           <a:lstStyle/>
           <a:p>
-            <a:fld id="{90B78C95-90DC-4A19-A6CD-7835680F4A89}" type="datetimeFigureOut">
+            <a:fld id="{1A06FF31-542E-488B-B51B-7E258DD3A14D}" type="datetime1">
               <a:rPr lang="de-DE" smtClean="0"/>
               <a:t>24.10.2026</a:t>
             </a:fld>
@@ -287,7 +1395,10 @@
           <a:bodyPr/>
           <a:lstStyle/>
           <a:p>
-            <a:endParaRPr lang="de-DE"/>
+            <a:r>
+              <a:rPr lang="de-DE"/>
+              <a:t>Munich Climate Week Hackathon - BayWa r.e. challenge - Lino &amp; Philip &amp; Thalea</a:t>
+            </a:r>
           </a:p>
         </p:txBody>
       </p:sp>
@@ -456,7 +1567,7 @@
           <a:bodyPr/>
           <a:lstStyle/>
           <a:p>
-            <a:fld id="{90B78C95-90DC-4A19-A6CD-7835680F4A89}" type="datetimeFigureOut">
+            <a:fld id="{89DA4D3E-38B8-480A-8F4A-0906651458A4}" type="datetime1">
               <a:rPr lang="de-DE" smtClean="0"/>
               <a:t>24.10.2026</a:t>
             </a:fld>
@@ -485,7 +1596,10 @@
           <a:bodyPr/>
           <a:lstStyle/>
           <a:p>
-            <a:endParaRPr lang="de-DE"/>
+            <a:r>
+              <a:rPr lang="de-DE"/>
+              <a:t>Munich Climate Week Hackathon - BayWa r.e. challenge - Lino &amp; Philip &amp; Thalea</a:t>
+            </a:r>
           </a:p>
         </p:txBody>
       </p:sp>
@@ -664,7 +1778,7 @@
           <a:bodyPr/>
           <a:lstStyle/>
           <a:p>
-            <a:fld id="{90B78C95-90DC-4A19-A6CD-7835680F4A89}" type="datetimeFigureOut">
+            <a:fld id="{C73DCCFE-9F96-4605-86BC-85C44D051153}" type="datetime1">
               <a:rPr lang="de-DE" smtClean="0"/>
               <a:t>24.10.2026</a:t>
             </a:fld>
@@ -693,7 +1807,10 @@
           <a:bodyPr/>
           <a:lstStyle/>
           <a:p>
-            <a:endParaRPr lang="de-DE"/>
+            <a:r>
+              <a:rPr lang="de-DE"/>
+              <a:t>Munich Climate Week Hackathon - BayWa r.e. challenge - Lino &amp; Philip &amp; Thalea</a:t>
+            </a:r>
           </a:p>
         </p:txBody>
       </p:sp>
@@ -862,7 +1979,7 @@
           <a:bodyPr/>
           <a:lstStyle/>
           <a:p>
-            <a:fld id="{90B78C95-90DC-4A19-A6CD-7835680F4A89}" type="datetimeFigureOut">
+            <a:fld id="{F1DBF686-17EF-4B2F-B320-FDA5A791E320}" type="datetime1">
               <a:rPr lang="de-DE" smtClean="0"/>
               <a:t>24.10.2026</a:t>
             </a:fld>
@@ -891,7 +2008,10 @@
           <a:bodyPr/>
           <a:lstStyle/>
           <a:p>
-            <a:endParaRPr lang="de-DE"/>
+            <a:r>
+              <a:rPr lang="de-DE"/>
+              <a:t>Munich Climate Week Hackathon - BayWa r.e. challenge - Lino &amp; Philip &amp; Thalea</a:t>
+            </a:r>
           </a:p>
         </p:txBody>
       </p:sp>
@@ -1137,7 +2257,7 @@
           <a:bodyPr/>
           <a:lstStyle/>
           <a:p>
-            <a:fld id="{90B78C95-90DC-4A19-A6CD-7835680F4A89}" type="datetimeFigureOut">
+            <a:fld id="{5632EF16-53AE-4207-B5D7-4927C6099152}" type="datetime1">
               <a:rPr lang="de-DE" smtClean="0"/>
               <a:t>24.10.2026</a:t>
             </a:fld>
@@ -1166,7 +2286,10 @@
           <a:bodyPr/>
           <a:lstStyle/>
           <a:p>
-            <a:endParaRPr lang="de-DE"/>
+            <a:r>
+              <a:rPr lang="de-DE"/>
+              <a:t>Munich Climate Week Hackathon - BayWa r.e. challenge - Lino &amp; Philip &amp; Thalea</a:t>
+            </a:r>
           </a:p>
         </p:txBody>
       </p:sp>
@@ -1402,7 +2525,7 @@
           <a:bodyPr/>
           <a:lstStyle/>
           <a:p>
-            <a:fld id="{90B78C95-90DC-4A19-A6CD-7835680F4A89}" type="datetimeFigureOut">
+            <a:fld id="{4F82F9AD-0D68-4148-9497-626A62D1E3E4}" type="datetime1">
               <a:rPr lang="de-DE" smtClean="0"/>
               <a:t>24.10.2026</a:t>
             </a:fld>
@@ -1431,7 +2554,10 @@
           <a:bodyPr/>
           <a:lstStyle/>
           <a:p>
-            <a:endParaRPr lang="de-DE"/>
+            <a:r>
+              <a:rPr lang="de-DE"/>
+              <a:t>Munich Climate Week Hackathon - BayWa r.e. challenge - Lino &amp; Philip &amp; Thalea</a:t>
+            </a:r>
           </a:p>
         </p:txBody>
       </p:sp>
@@ -1814,7 +2940,7 @@
           <a:bodyPr/>
           <a:lstStyle/>
           <a:p>
-            <a:fld id="{90B78C95-90DC-4A19-A6CD-7835680F4A89}" type="datetimeFigureOut">
+            <a:fld id="{B750583B-996E-43A3-BE9A-3D4E095FD3BA}" type="datetime1">
               <a:rPr lang="de-DE" smtClean="0"/>
               <a:t>24.10.2026</a:t>
             </a:fld>
@@ -1843,7 +2969,10 @@
           <a:bodyPr/>
           <a:lstStyle/>
           <a:p>
-            <a:endParaRPr lang="de-DE"/>
+            <a:r>
+              <a:rPr lang="de-DE"/>
+              <a:t>Munich Climate Week Hackathon - BayWa r.e. challenge - Lino &amp; Philip &amp; Thalea</a:t>
+            </a:r>
           </a:p>
         </p:txBody>
       </p:sp>
@@ -1955,7 +3084,7 @@
           <a:bodyPr/>
           <a:lstStyle/>
           <a:p>
-            <a:fld id="{90B78C95-90DC-4A19-A6CD-7835680F4A89}" type="datetimeFigureOut">
+            <a:fld id="{4F63C787-BB14-44F5-B62B-6C4CE8B46892}" type="datetime1">
               <a:rPr lang="de-DE" smtClean="0"/>
               <a:t>24.10.2026</a:t>
             </a:fld>
@@ -1984,7 +3113,10 @@
           <a:bodyPr/>
           <a:lstStyle/>
           <a:p>
-            <a:endParaRPr lang="de-DE"/>
+            <a:r>
+              <a:rPr lang="de-DE"/>
+              <a:t>Munich Climate Week Hackathon - BayWa r.e. challenge - Lino &amp; Philip &amp; Thalea</a:t>
+            </a:r>
           </a:p>
         </p:txBody>
       </p:sp>
@@ -2068,7 +3200,7 @@
           <a:bodyPr/>
           <a:lstStyle/>
           <a:p>
-            <a:fld id="{90B78C95-90DC-4A19-A6CD-7835680F4A89}" type="datetimeFigureOut">
+            <a:fld id="{124730CB-00E9-46EA-B39F-E6FA8C1CF8B7}" type="datetime1">
               <a:rPr lang="de-DE" smtClean="0"/>
               <a:t>24.10.2026</a:t>
             </a:fld>
@@ -2097,7 +3229,10 @@
           <a:bodyPr/>
           <a:lstStyle/>
           <a:p>
-            <a:endParaRPr lang="de-DE"/>
+            <a:r>
+              <a:rPr lang="de-DE"/>
+              <a:t>Munich Climate Week Hackathon - BayWa r.e. challenge - Lino &amp; Philip &amp; Thalea</a:t>
+            </a:r>
           </a:p>
         </p:txBody>
       </p:sp>
@@ -2379,7 +3514,7 @@
           <a:bodyPr/>
           <a:lstStyle/>
           <a:p>
-            <a:fld id="{90B78C95-90DC-4A19-A6CD-7835680F4A89}" type="datetimeFigureOut">
+            <a:fld id="{5D91541D-3A37-431E-876F-21DE6A224A14}" type="datetime1">
               <a:rPr lang="de-DE" smtClean="0"/>
               <a:t>24.10.2026</a:t>
             </a:fld>
@@ -2408,7 +3543,10 @@
           <a:bodyPr/>
           <a:lstStyle/>
           <a:p>
-            <a:endParaRPr lang="de-DE"/>
+            <a:r>
+              <a:rPr lang="de-DE"/>
+              <a:t>Munich Climate Week Hackathon - BayWa r.e. challenge - Lino &amp; Philip &amp; Thalea</a:t>
+            </a:r>
           </a:p>
         </p:txBody>
       </p:sp>
@@ -2667,7 +3805,7 @@
           <a:bodyPr/>
           <a:lstStyle/>
           <a:p>
-            <a:fld id="{90B78C95-90DC-4A19-A6CD-7835680F4A89}" type="datetimeFigureOut">
+            <a:fld id="{00B2120D-39BF-42AA-954A-4FCE746D60A8}" type="datetime1">
               <a:rPr lang="de-DE" smtClean="0"/>
               <a:t>24.10.2026</a:t>
             </a:fld>
@@ -2696,7 +3834,10 @@
           <a:bodyPr/>
           <a:lstStyle/>
           <a:p>
-            <a:endParaRPr lang="de-DE"/>
+            <a:r>
+              <a:rPr lang="de-DE"/>
+              <a:t>Munich Climate Week Hackathon - BayWa r.e. challenge - Lino &amp; Philip &amp; Thalea</a:t>
+            </a:r>
           </a:p>
         </p:txBody>
       </p:sp>
@@ -2908,7 +4049,7 @@
             </a:lvl1pPr>
           </a:lstStyle>
           <a:p>
-            <a:fld id="{90B78C95-90DC-4A19-A6CD-7835680F4A89}" type="datetimeFigureOut">
+            <a:fld id="{37A055C4-E4DF-4CA5-809E-E41EC8EE1B7B}" type="datetime1">
               <a:rPr lang="de-DE" smtClean="0"/>
               <a:t>24.10.2026</a:t>
             </a:fld>
@@ -2956,25 +4097,10 @@
           </a:lstStyle>
           <a:p>
             <a:r>
-              <a:rPr lang="de-DE" dirty="0"/>
-              <a:t>Watt The Hack - </a:t>
-            </a:r>
-            <a:r>
-              <a:rPr lang="de-DE" dirty="0" err="1"/>
-              <a:t>BayWA</a:t>
-            </a:r>
-            <a:r>
-              <a:rPr lang="de-DE" dirty="0"/>
-              <a:t> </a:t>
-            </a:r>
-            <a:r>
-              <a:rPr lang="de-DE" dirty="0" err="1"/>
-              <a:t>r.e</a:t>
-            </a:r>
-            <a:r>
-              <a:rPr lang="de-DE" dirty="0"/>
-              <a:t>. Challenge - Philip &amp; Thalea</a:t>
-            </a:r>
+              <a:rPr lang="de-DE"/>
+              <a:t>Munich Climate Week Hackathon - BayWa r.e. challenge - Lino &amp; Philip &amp; Thalea</a:t>
+            </a:r>
+            <a:endParaRPr lang="de-DE" dirty="0"/>
           </a:p>
         </p:txBody>
       </p:sp>
@@ -3025,715 +4151,115 @@
           </a:p>
         </p:txBody>
       </p:sp>
-      <p:grpSp>
-        <p:nvGrpSpPr>
-          <p:cNvPr id="7" name="Gruppieren 6">
-            <a:extLst>
-              <a:ext uri="{FF2B5EF4-FFF2-40B4-BE49-F238E27FC236}">
-                <a16:creationId xmlns:a16="http://schemas.microsoft.com/office/drawing/2014/main" id="{27F25279-0C4C-1C18-8991-7017C53F3957}"/>
-              </a:ext>
-            </a:extLst>
-          </p:cNvPr>
-          <p:cNvGrpSpPr/>
+      <p:pic>
+        <p:nvPicPr>
+          <p:cNvPr id="20" name="Grafik 19">
+            <a:extLst>
+              <a:ext uri="{FF2B5EF4-FFF2-40B4-BE49-F238E27FC236}">
+                <a16:creationId xmlns:a16="http://schemas.microsoft.com/office/drawing/2014/main" id="{B4BAF0B5-BCF2-E63F-09E1-310C6E1AF326}"/>
+              </a:ext>
+            </a:extLst>
+          </p:cNvPr>
+          <p:cNvPicPr>
+            <a:picLocks noChangeAspect="1"/>
+          </p:cNvPicPr>
           <p:nvPr userDrawn="1"/>
-        </p:nvGrpSpPr>
-        <p:grpSpPr>
+        </p:nvPicPr>
+        <p:blipFill>
+          <a:blip r:embed="rId13">
+            <a:extLst>
+              <a:ext uri="{28A0092B-C50C-407E-A947-70E740481C1C}">
+                <a14:useLocalDpi xmlns:a14="http://schemas.microsoft.com/office/drawing/2010/main" val="0"/>
+              </a:ext>
+            </a:extLst>
+          </a:blip>
+          <a:srcRect t="24056" r="69524" b="24478"/>
+          <a:stretch>
+            <a:fillRect/>
+          </a:stretch>
+        </p:blipFill>
+        <p:spPr>
           <a:xfrm>
-            <a:off x="10156371" y="365125"/>
-            <a:ext cx="1197429" cy="1170213"/>
-            <a:chOff x="489857" y="315684"/>
-            <a:chExt cx="1197429" cy="1170213"/>
+            <a:off x="10135503" y="196394"/>
+            <a:ext cx="1045028" cy="672123"/>
           </a:xfrm>
-        </p:grpSpPr>
-        <p:sp>
-          <p:nvSpPr>
-            <p:cNvPr id="9" name="Grafik 4" descr="Gummiente mit einfarbiger Füllung">
-              <a:extLst>
-                <a:ext uri="{FF2B5EF4-FFF2-40B4-BE49-F238E27FC236}">
-                  <a16:creationId xmlns:a16="http://schemas.microsoft.com/office/drawing/2014/main" id="{6D587718-9635-418F-5B67-C1EA00947FFD}"/>
-                </a:ext>
-              </a:extLst>
-            </p:cNvPr>
-            <p:cNvSpPr/>
-            <p:nvPr/>
-          </p:nvSpPr>
-          <p:spPr>
-            <a:xfrm>
-              <a:off x="696616" y="602797"/>
-              <a:ext cx="762069" cy="590551"/>
-            </a:xfrm>
-            <a:custGeom>
-              <a:avLst/>
-              <a:gdLst>
-                <a:gd name="csX0" fmla="*/ 684917 w 762069"/>
-                <a:gd name="csY0" fmla="*/ 191452 h 590551"/>
-                <a:gd name="csX1" fmla="*/ 685869 w 762069"/>
-                <a:gd name="csY1" fmla="*/ 171450 h 590551"/>
-                <a:gd name="csX2" fmla="*/ 514419 w 762069"/>
-                <a:gd name="csY2" fmla="*/ 0 h 590551"/>
-                <a:gd name="csX3" fmla="*/ 342969 w 762069"/>
-                <a:gd name="csY3" fmla="*/ 171450 h 590551"/>
-                <a:gd name="csX4" fmla="*/ 383927 w 762069"/>
-                <a:gd name="csY4" fmla="*/ 281940 h 590551"/>
-                <a:gd name="csX5" fmla="*/ 49599 w 762069"/>
-                <a:gd name="csY5" fmla="*/ 247650 h 590551"/>
-                <a:gd name="csX6" fmla="*/ 21024 w 762069"/>
-                <a:gd name="csY6" fmla="*/ 259080 h 590551"/>
-                <a:gd name="csX7" fmla="*/ 37217 w 762069"/>
-                <a:gd name="csY7" fmla="*/ 490538 h 590551"/>
-                <a:gd name="csX8" fmla="*/ 366782 w 762069"/>
-                <a:gd name="csY8" fmla="*/ 590550 h 590551"/>
-                <a:gd name="csX9" fmla="*/ 646817 w 762069"/>
-                <a:gd name="csY9" fmla="*/ 470535 h 590551"/>
-                <a:gd name="csX10" fmla="*/ 591572 w 762069"/>
-                <a:gd name="csY10" fmla="*/ 324803 h 590551"/>
-                <a:gd name="csX11" fmla="*/ 647769 w 762069"/>
-                <a:gd name="csY11" fmla="*/ 275273 h 590551"/>
-                <a:gd name="csX12" fmla="*/ 743019 w 762069"/>
-                <a:gd name="csY12" fmla="*/ 229552 h 590551"/>
-                <a:gd name="csX13" fmla="*/ 762069 w 762069"/>
-                <a:gd name="csY13" fmla="*/ 200977 h 590551"/>
-                <a:gd name="csX14" fmla="*/ 684917 w 762069"/>
-                <a:gd name="csY14" fmla="*/ 191452 h 590551"/>
-                <a:gd name="csX15" fmla="*/ 599192 w 762069"/>
-                <a:gd name="csY15" fmla="*/ 171450 h 590551"/>
-                <a:gd name="csX16" fmla="*/ 570617 w 762069"/>
-                <a:gd name="csY16" fmla="*/ 142875 h 590551"/>
-                <a:gd name="csX17" fmla="*/ 599192 w 762069"/>
-                <a:gd name="csY17" fmla="*/ 114300 h 590551"/>
-                <a:gd name="csX18" fmla="*/ 627767 w 762069"/>
-                <a:gd name="csY18" fmla="*/ 142875 h 590551"/>
-                <a:gd name="csX19" fmla="*/ 599192 w 762069"/>
-                <a:gd name="csY19" fmla="*/ 171450 h 590551"/>
-              </a:gdLst>
-              <a:ahLst/>
-              <a:cxnLst>
-                <a:cxn ang="0">
-                  <a:pos x="csX0" y="csY0"/>
-                </a:cxn>
-                <a:cxn ang="0">
-                  <a:pos x="csX1" y="csY1"/>
-                </a:cxn>
-                <a:cxn ang="0">
-                  <a:pos x="csX2" y="csY2"/>
-                </a:cxn>
-                <a:cxn ang="0">
-                  <a:pos x="csX3" y="csY3"/>
-                </a:cxn>
-                <a:cxn ang="0">
-                  <a:pos x="csX4" y="csY4"/>
-                </a:cxn>
-                <a:cxn ang="0">
-                  <a:pos x="csX5" y="csY5"/>
-                </a:cxn>
-                <a:cxn ang="0">
-                  <a:pos x="csX6" y="csY6"/>
-                </a:cxn>
-                <a:cxn ang="0">
-                  <a:pos x="csX7" y="csY7"/>
-                </a:cxn>
-                <a:cxn ang="0">
-                  <a:pos x="csX8" y="csY8"/>
-                </a:cxn>
-                <a:cxn ang="0">
-                  <a:pos x="csX9" y="csY9"/>
-                </a:cxn>
-                <a:cxn ang="0">
-                  <a:pos x="csX10" y="csY10"/>
-                </a:cxn>
-                <a:cxn ang="0">
-                  <a:pos x="csX11" y="csY11"/>
-                </a:cxn>
-                <a:cxn ang="0">
-                  <a:pos x="csX12" y="csY12"/>
-                </a:cxn>
-                <a:cxn ang="0">
-                  <a:pos x="csX13" y="csY13"/>
-                </a:cxn>
-                <a:cxn ang="0">
-                  <a:pos x="csX14" y="csY14"/>
-                </a:cxn>
-                <a:cxn ang="0">
-                  <a:pos x="csX15" y="csY15"/>
-                </a:cxn>
-                <a:cxn ang="0">
-                  <a:pos x="csX16" y="csY16"/>
-                </a:cxn>
-                <a:cxn ang="0">
-                  <a:pos x="csX17" y="csY17"/>
-                </a:cxn>
-                <a:cxn ang="0">
-                  <a:pos x="csX18" y="csY18"/>
-                </a:cxn>
-                <a:cxn ang="0">
-                  <a:pos x="csX19" y="csY19"/>
-                </a:cxn>
-              </a:cxnLst>
-              <a:rect l="l" t="t" r="r" b="b"/>
-              <a:pathLst>
-                <a:path w="762069" h="590551" fill="none" extrusionOk="0">
-                  <a:moveTo>
-                    <a:pt x="684917" y="191452"/>
-                  </a:moveTo>
-                  <a:cubicBezTo>
-                    <a:pt x="686529" y="183923"/>
-                    <a:pt x="686640" y="178820"/>
-                    <a:pt x="685869" y="171450"/>
-                  </a:cubicBezTo>
-                  <a:cubicBezTo>
-                    <a:pt x="683743" y="84485"/>
-                    <a:pt x="604987" y="4173"/>
-                    <a:pt x="514419" y="0"/>
-                  </a:cubicBezTo>
-                  <a:cubicBezTo>
-                    <a:pt x="423533" y="2635"/>
-                    <a:pt x="354361" y="82566"/>
-                    <a:pt x="342969" y="171450"/>
-                  </a:cubicBezTo>
-                  <a:cubicBezTo>
-                    <a:pt x="340081" y="218790"/>
-                    <a:pt x="356030" y="252217"/>
-                    <a:pt x="383927" y="281940"/>
-                  </a:cubicBezTo>
-                  <a:cubicBezTo>
-                    <a:pt x="294596" y="298712"/>
-                    <a:pt x="238696" y="372406"/>
-                    <a:pt x="49599" y="247650"/>
-                  </a:cubicBezTo>
-                  <a:cubicBezTo>
-                    <a:pt x="37308" y="239355"/>
-                    <a:pt x="22270" y="245237"/>
-                    <a:pt x="21024" y="259080"/>
-                  </a:cubicBezTo>
-                  <a:cubicBezTo>
-                    <a:pt x="-8349" y="361053"/>
-                    <a:pt x="-18213" y="414211"/>
-                    <a:pt x="37217" y="490538"/>
-                  </a:cubicBezTo>
-                  <a:cubicBezTo>
-                    <a:pt x="109571" y="591285"/>
-                    <a:pt x="189170" y="599119"/>
-                    <a:pt x="366782" y="590550"/>
-                  </a:cubicBezTo>
-                  <a:cubicBezTo>
-                    <a:pt x="539277" y="585150"/>
-                    <a:pt x="645092" y="579446"/>
-                    <a:pt x="646817" y="470535"/>
-                  </a:cubicBezTo>
-                  <a:cubicBezTo>
-                    <a:pt x="641261" y="414042"/>
-                    <a:pt x="631389" y="363836"/>
-                    <a:pt x="591572" y="324803"/>
-                  </a:cubicBezTo>
-                  <a:cubicBezTo>
-                    <a:pt x="615092" y="311396"/>
-                    <a:pt x="640154" y="291694"/>
-                    <a:pt x="647769" y="275273"/>
-                  </a:cubicBezTo>
-                  <a:cubicBezTo>
-                    <a:pt x="692646" y="269658"/>
-                    <a:pt x="727531" y="246434"/>
-                    <a:pt x="743019" y="229552"/>
-                  </a:cubicBezTo>
-                  <a:cubicBezTo>
-                    <a:pt x="752399" y="220013"/>
-                    <a:pt x="759358" y="209240"/>
-                    <a:pt x="762069" y="200977"/>
-                  </a:cubicBezTo>
-                  <a:cubicBezTo>
-                    <a:pt x="745627" y="194088"/>
-                    <a:pt x="695688" y="198772"/>
-                    <a:pt x="684917" y="191452"/>
-                  </a:cubicBezTo>
-                  <a:close/>
-                  <a:moveTo>
-                    <a:pt x="599192" y="171450"/>
-                  </a:moveTo>
-                  <a:cubicBezTo>
-                    <a:pt x="583651" y="170782"/>
-                    <a:pt x="570585" y="160921"/>
-                    <a:pt x="570617" y="142875"/>
-                  </a:cubicBezTo>
-                  <a:cubicBezTo>
-                    <a:pt x="572158" y="124498"/>
-                    <a:pt x="585880" y="114364"/>
-                    <a:pt x="599192" y="114300"/>
-                  </a:cubicBezTo>
-                  <a:cubicBezTo>
-                    <a:pt x="615880" y="113919"/>
-                    <a:pt x="629293" y="128891"/>
-                    <a:pt x="627767" y="142875"/>
-                  </a:cubicBezTo>
-                  <a:cubicBezTo>
-                    <a:pt x="626784" y="157065"/>
-                    <a:pt x="613112" y="170781"/>
-                    <a:pt x="599192" y="171450"/>
-                  </a:cubicBezTo>
-                  <a:close/>
-                </a:path>
-                <a:path w="762069" h="590551" stroke="0" extrusionOk="0">
-                  <a:moveTo>
-                    <a:pt x="684917" y="191452"/>
-                  </a:moveTo>
-                  <a:cubicBezTo>
-                    <a:pt x="686415" y="184167"/>
-                    <a:pt x="685524" y="177772"/>
-                    <a:pt x="685869" y="171450"/>
-                  </a:cubicBezTo>
-                  <a:cubicBezTo>
-                    <a:pt x="698343" y="86625"/>
-                    <a:pt x="596259" y="-4113"/>
-                    <a:pt x="514419" y="0"/>
-                  </a:cubicBezTo>
-                  <a:cubicBezTo>
-                    <a:pt x="432977" y="-3073"/>
-                    <a:pt x="345322" y="76670"/>
-                    <a:pt x="342969" y="171450"/>
-                  </a:cubicBezTo>
-                  <a:cubicBezTo>
-                    <a:pt x="349343" y="214656"/>
-                    <a:pt x="354843" y="259063"/>
-                    <a:pt x="383927" y="281940"/>
-                  </a:cubicBezTo>
-                  <a:cubicBezTo>
-                    <a:pt x="305505" y="294551"/>
-                    <a:pt x="225574" y="357193"/>
-                    <a:pt x="49599" y="247650"/>
-                  </a:cubicBezTo>
-                  <a:cubicBezTo>
-                    <a:pt x="40551" y="243064"/>
-                    <a:pt x="24473" y="247875"/>
-                    <a:pt x="21024" y="259080"/>
-                  </a:cubicBezTo>
-                  <a:cubicBezTo>
-                    <a:pt x="-15955" y="361836"/>
-                    <a:pt x="-5372" y="411835"/>
-                    <a:pt x="37217" y="490538"/>
-                  </a:cubicBezTo>
-                  <a:cubicBezTo>
-                    <a:pt x="91752" y="590962"/>
-                    <a:pt x="189913" y="586195"/>
-                    <a:pt x="366782" y="590550"/>
-                  </a:cubicBezTo>
-                  <a:cubicBezTo>
-                    <a:pt x="556555" y="586367"/>
-                    <a:pt x="655777" y="597245"/>
-                    <a:pt x="646817" y="470535"/>
-                  </a:cubicBezTo>
-                  <a:cubicBezTo>
-                    <a:pt x="638907" y="409751"/>
-                    <a:pt x="628036" y="361721"/>
-                    <a:pt x="591572" y="324803"/>
-                  </a:cubicBezTo>
-                  <a:cubicBezTo>
-                    <a:pt x="614395" y="314560"/>
-                    <a:pt x="638206" y="288812"/>
-                    <a:pt x="647769" y="275273"/>
-                  </a:cubicBezTo>
-                  <a:cubicBezTo>
-                    <a:pt x="694334" y="275348"/>
-                    <a:pt x="723847" y="252066"/>
-                    <a:pt x="743019" y="229552"/>
-                  </a:cubicBezTo>
-                  <a:cubicBezTo>
-                    <a:pt x="752688" y="219986"/>
-                    <a:pt x="757311" y="209275"/>
-                    <a:pt x="762069" y="200977"/>
-                  </a:cubicBezTo>
-                  <a:cubicBezTo>
-                    <a:pt x="731883" y="190245"/>
-                    <a:pt x="702367" y="196676"/>
-                    <a:pt x="684917" y="191452"/>
-                  </a:cubicBezTo>
-                  <a:close/>
-                  <a:moveTo>
-                    <a:pt x="599192" y="171450"/>
-                  </a:moveTo>
-                  <a:cubicBezTo>
-                    <a:pt x="582341" y="170547"/>
-                    <a:pt x="570828" y="159674"/>
-                    <a:pt x="570617" y="142875"/>
-                  </a:cubicBezTo>
-                  <a:cubicBezTo>
-                    <a:pt x="569760" y="129104"/>
-                    <a:pt x="585657" y="114555"/>
-                    <a:pt x="599192" y="114300"/>
-                  </a:cubicBezTo>
-                  <a:cubicBezTo>
-                    <a:pt x="614994" y="116178"/>
-                    <a:pt x="628946" y="129355"/>
-                    <a:pt x="627767" y="142875"/>
-                  </a:cubicBezTo>
-                  <a:cubicBezTo>
-                    <a:pt x="625140" y="157645"/>
-                    <a:pt x="616830" y="173302"/>
-                    <a:pt x="599192" y="171450"/>
-                  </a:cubicBezTo>
-                  <a:close/>
-                </a:path>
-              </a:pathLst>
-            </a:custGeom>
-            <a:solidFill>
-              <a:srgbClr val="008C45"/>
-            </a:solidFill>
-            <a:ln w="9525" cap="flat">
-              <a:solidFill>
-                <a:srgbClr val="008C45"/>
-              </a:solidFill>
-              <a:prstDash val="solid"/>
-              <a:miter/>
-              <a:extLst>
-                <a:ext uri="{C807C97D-BFC1-408E-A445-0C87EB9F89A2}">
-                  <ask:lineSketchStyleProps xmlns:ask="http://schemas.microsoft.com/office/drawing/2018/sketchyshapes" sd="198506542">
-                    <a:custGeom>
-                      <a:avLst/>
-                      <a:gdLst>
-                        <a:gd name="csX0" fmla="*/ 684917 w 762069"/>
-                        <a:gd name="csY0" fmla="*/ 191452 h 590551"/>
-                        <a:gd name="csX1" fmla="*/ 685869 w 762069"/>
-                        <a:gd name="csY1" fmla="*/ 171450 h 590551"/>
-                        <a:gd name="csX2" fmla="*/ 514419 w 762069"/>
-                        <a:gd name="csY2" fmla="*/ 0 h 590551"/>
-                        <a:gd name="csX3" fmla="*/ 342969 w 762069"/>
-                        <a:gd name="csY3" fmla="*/ 171450 h 590551"/>
-                        <a:gd name="csX4" fmla="*/ 383927 w 762069"/>
-                        <a:gd name="csY4" fmla="*/ 281940 h 590551"/>
-                        <a:gd name="csX5" fmla="*/ 49599 w 762069"/>
-                        <a:gd name="csY5" fmla="*/ 247650 h 590551"/>
-                        <a:gd name="csX6" fmla="*/ 21024 w 762069"/>
-                        <a:gd name="csY6" fmla="*/ 259080 h 590551"/>
-                        <a:gd name="csX7" fmla="*/ 37217 w 762069"/>
-                        <a:gd name="csY7" fmla="*/ 490538 h 590551"/>
-                        <a:gd name="csX8" fmla="*/ 366782 w 762069"/>
-                        <a:gd name="csY8" fmla="*/ 590550 h 590551"/>
-                        <a:gd name="csX9" fmla="*/ 646817 w 762069"/>
-                        <a:gd name="csY9" fmla="*/ 470535 h 590551"/>
-                        <a:gd name="csX10" fmla="*/ 591572 w 762069"/>
-                        <a:gd name="csY10" fmla="*/ 324803 h 590551"/>
-                        <a:gd name="csX11" fmla="*/ 647769 w 762069"/>
-                        <a:gd name="csY11" fmla="*/ 275273 h 590551"/>
-                        <a:gd name="csX12" fmla="*/ 743019 w 762069"/>
-                        <a:gd name="csY12" fmla="*/ 229552 h 590551"/>
-                        <a:gd name="csX13" fmla="*/ 762069 w 762069"/>
-                        <a:gd name="csY13" fmla="*/ 200977 h 590551"/>
-                        <a:gd name="csX14" fmla="*/ 684917 w 762069"/>
-                        <a:gd name="csY14" fmla="*/ 191452 h 590551"/>
-                        <a:gd name="csX15" fmla="*/ 599192 w 762069"/>
-                        <a:gd name="csY15" fmla="*/ 171450 h 590551"/>
-                        <a:gd name="csX16" fmla="*/ 570617 w 762069"/>
-                        <a:gd name="csY16" fmla="*/ 142875 h 590551"/>
-                        <a:gd name="csX17" fmla="*/ 599192 w 762069"/>
-                        <a:gd name="csY17" fmla="*/ 114300 h 590551"/>
-                        <a:gd name="csX18" fmla="*/ 627767 w 762069"/>
-                        <a:gd name="csY18" fmla="*/ 142875 h 590551"/>
-                        <a:gd name="csX19" fmla="*/ 599192 w 762069"/>
-                        <a:gd name="csY19" fmla="*/ 171450 h 590551"/>
-                      </a:gdLst>
-                      <a:ahLst/>
-                      <a:cxnLst>
-                        <a:cxn ang="0">
-                          <a:pos x="csX0" y="csY0"/>
-                        </a:cxn>
-                        <a:cxn ang="0">
-                          <a:pos x="csX1" y="csY1"/>
-                        </a:cxn>
-                        <a:cxn ang="0">
-                          <a:pos x="csX2" y="csY2"/>
-                        </a:cxn>
-                        <a:cxn ang="0">
-                          <a:pos x="csX3" y="csY3"/>
-                        </a:cxn>
-                        <a:cxn ang="0">
-                          <a:pos x="csX4" y="csY4"/>
-                        </a:cxn>
-                        <a:cxn ang="0">
-                          <a:pos x="csX5" y="csY5"/>
-                        </a:cxn>
-                        <a:cxn ang="0">
-                          <a:pos x="csX6" y="csY6"/>
-                        </a:cxn>
-                        <a:cxn ang="0">
-                          <a:pos x="csX7" y="csY7"/>
-                        </a:cxn>
-                        <a:cxn ang="0">
-                          <a:pos x="csX8" y="csY8"/>
-                        </a:cxn>
-                        <a:cxn ang="0">
-                          <a:pos x="csX9" y="csY9"/>
-                        </a:cxn>
-                        <a:cxn ang="0">
-                          <a:pos x="csX10" y="csY10"/>
-                        </a:cxn>
-                        <a:cxn ang="0">
-                          <a:pos x="csX11" y="csY11"/>
-                        </a:cxn>
-                        <a:cxn ang="0">
-                          <a:pos x="csX12" y="csY12"/>
-                        </a:cxn>
-                        <a:cxn ang="0">
-                          <a:pos x="csX13" y="csY13"/>
-                        </a:cxn>
-                        <a:cxn ang="0">
-                          <a:pos x="csX14" y="csY14"/>
-                        </a:cxn>
-                        <a:cxn ang="0">
-                          <a:pos x="csX15" y="csY15"/>
-                        </a:cxn>
-                        <a:cxn ang="0">
-                          <a:pos x="csX16" y="csY16"/>
-                        </a:cxn>
-                        <a:cxn ang="0">
-                          <a:pos x="csX17" y="csY17"/>
-                        </a:cxn>
-                        <a:cxn ang="0">
-                          <a:pos x="csX18" y="csY18"/>
-                        </a:cxn>
-                        <a:cxn ang="0">
-                          <a:pos x="csX19" y="csY19"/>
-                        </a:cxn>
-                      </a:cxnLst>
-                      <a:rect l="l" t="t" r="r" b="b"/>
-                      <a:pathLst>
-                        <a:path w="762069" h="590551">
-                          <a:moveTo>
-                            <a:pt x="684917" y="191452"/>
-                          </a:moveTo>
-                          <a:cubicBezTo>
-                            <a:pt x="685869" y="184785"/>
-                            <a:pt x="685869" y="178118"/>
-                            <a:pt x="685869" y="171450"/>
-                          </a:cubicBezTo>
-                          <a:cubicBezTo>
-                            <a:pt x="685869" y="77153"/>
-                            <a:pt x="608717" y="0"/>
-                            <a:pt x="514419" y="0"/>
-                          </a:cubicBezTo>
-                          <a:cubicBezTo>
-                            <a:pt x="420122" y="0"/>
-                            <a:pt x="342969" y="77153"/>
-                            <a:pt x="342969" y="171450"/>
-                          </a:cubicBezTo>
-                          <a:cubicBezTo>
-                            <a:pt x="342969" y="213360"/>
-                            <a:pt x="358209" y="252413"/>
-                            <a:pt x="383927" y="281940"/>
-                          </a:cubicBezTo>
-                          <a:cubicBezTo>
-                            <a:pt x="295344" y="293370"/>
-                            <a:pt x="224859" y="359093"/>
-                            <a:pt x="49599" y="247650"/>
-                          </a:cubicBezTo>
-                          <a:cubicBezTo>
-                            <a:pt x="39122" y="240983"/>
-                            <a:pt x="23882" y="246698"/>
-                            <a:pt x="21024" y="259080"/>
-                          </a:cubicBezTo>
-                          <a:cubicBezTo>
-                            <a:pt x="-7551" y="360998"/>
-                            <a:pt x="-11361" y="419100"/>
-                            <a:pt x="37217" y="490538"/>
-                          </a:cubicBezTo>
-                          <a:cubicBezTo>
-                            <a:pt x="105797" y="589598"/>
-                            <a:pt x="179139" y="590550"/>
-                            <a:pt x="366782" y="590550"/>
-                          </a:cubicBezTo>
-                          <a:cubicBezTo>
-                            <a:pt x="554424" y="590550"/>
-                            <a:pt x="646817" y="592455"/>
-                            <a:pt x="646817" y="470535"/>
-                          </a:cubicBezTo>
-                          <a:cubicBezTo>
-                            <a:pt x="646817" y="406718"/>
-                            <a:pt x="632529" y="357188"/>
-                            <a:pt x="591572" y="324803"/>
-                          </a:cubicBezTo>
-                          <a:cubicBezTo>
-                            <a:pt x="614432" y="313373"/>
-                            <a:pt x="638244" y="290513"/>
-                            <a:pt x="647769" y="275273"/>
-                          </a:cubicBezTo>
-                          <a:cubicBezTo>
-                            <a:pt x="692537" y="270510"/>
-                            <a:pt x="724922" y="249555"/>
-                            <a:pt x="743019" y="229552"/>
-                          </a:cubicBezTo>
-                          <a:cubicBezTo>
-                            <a:pt x="752544" y="220027"/>
-                            <a:pt x="758259" y="208598"/>
-                            <a:pt x="762069" y="200977"/>
-                          </a:cubicBezTo>
-                          <a:lnTo>
-                            <a:pt x="684917" y="191452"/>
-                          </a:lnTo>
-                          <a:close/>
-                          <a:moveTo>
-                            <a:pt x="599192" y="171450"/>
-                          </a:moveTo>
-                          <a:cubicBezTo>
-                            <a:pt x="582999" y="171450"/>
-                            <a:pt x="570617" y="159068"/>
-                            <a:pt x="570617" y="142875"/>
-                          </a:cubicBezTo>
-                          <a:cubicBezTo>
-                            <a:pt x="570617" y="126682"/>
-                            <a:pt x="582999" y="114300"/>
-                            <a:pt x="599192" y="114300"/>
-                          </a:cubicBezTo>
-                          <a:cubicBezTo>
-                            <a:pt x="615384" y="114300"/>
-                            <a:pt x="627767" y="126682"/>
-                            <a:pt x="627767" y="142875"/>
-                          </a:cubicBezTo>
-                          <a:cubicBezTo>
-                            <a:pt x="627767" y="159068"/>
-                            <a:pt x="615384" y="171450"/>
-                            <a:pt x="599192" y="171450"/>
-                          </a:cubicBezTo>
-                          <a:close/>
-                        </a:path>
-                      </a:pathLst>
-                    </a:custGeom>
-                    <ask:type>
-                      <ask:lineSketchCurved/>
-                    </ask:type>
-                  </ask:lineSketchStyleProps>
-                </a:ext>
-              </a:extLst>
-            </a:ln>
-          </p:spPr>
-          <p:txBody>
-            <a:bodyPr/>
-            <a:lstStyle/>
-            <a:p>
-              <a:endParaRPr lang="de-DE"/>
-            </a:p>
-          </p:txBody>
-        </p:sp>
-        <p:sp>
-          <p:nvSpPr>
-            <p:cNvPr id="10" name="Ellipse 9">
-              <a:extLst>
-                <a:ext uri="{FF2B5EF4-FFF2-40B4-BE49-F238E27FC236}">
-                  <a16:creationId xmlns:a16="http://schemas.microsoft.com/office/drawing/2014/main" id="{5E6C38FD-3B49-376C-3FAD-AED773B4F097}"/>
-                </a:ext>
-              </a:extLst>
-            </p:cNvPr>
-            <p:cNvSpPr/>
-            <p:nvPr/>
-          </p:nvSpPr>
-          <p:spPr>
-            <a:xfrm rot="16200000">
-              <a:off x="503465" y="302076"/>
-              <a:ext cx="1170213" cy="1197429"/>
-            </a:xfrm>
-            <a:custGeom>
-              <a:avLst/>
-              <a:gdLst>
-                <a:gd name="csX0" fmla="*/ 0 w 1170213"/>
-                <a:gd name="csY0" fmla="*/ 598715 h 1197429"/>
-                <a:gd name="csX1" fmla="*/ 585107 w 1170213"/>
-                <a:gd name="csY1" fmla="*/ 0 h 1197429"/>
-                <a:gd name="csX2" fmla="*/ 1170214 w 1170213"/>
-                <a:gd name="csY2" fmla="*/ 598715 h 1197429"/>
-                <a:gd name="csX3" fmla="*/ 585107 w 1170213"/>
-                <a:gd name="csY3" fmla="*/ 1197430 h 1197429"/>
-                <a:gd name="csX4" fmla="*/ 0 w 1170213"/>
-                <a:gd name="csY4" fmla="*/ 598715 h 1197429"/>
-              </a:gdLst>
-              <a:ahLst/>
-              <a:cxnLst>
-                <a:cxn ang="0">
-                  <a:pos x="csX0" y="csY0"/>
-                </a:cxn>
-                <a:cxn ang="0">
-                  <a:pos x="csX1" y="csY1"/>
-                </a:cxn>
-                <a:cxn ang="0">
-                  <a:pos x="csX2" y="csY2"/>
-                </a:cxn>
-                <a:cxn ang="0">
-                  <a:pos x="csX3" y="csY3"/>
-                </a:cxn>
-                <a:cxn ang="0">
-                  <a:pos x="csX4" y="csY4"/>
-                </a:cxn>
-              </a:cxnLst>
-              <a:rect l="l" t="t" r="r" b="b"/>
-              <a:pathLst>
-                <a:path w="1170213" h="1197429" extrusionOk="0">
-                  <a:moveTo>
-                    <a:pt x="0" y="598715"/>
-                  </a:moveTo>
-                  <a:cubicBezTo>
-                    <a:pt x="-22492" y="224295"/>
-                    <a:pt x="243509" y="19752"/>
-                    <a:pt x="585107" y="0"/>
-                  </a:cubicBezTo>
-                  <a:cubicBezTo>
-                    <a:pt x="974514" y="39891"/>
-                    <a:pt x="1145897" y="221904"/>
-                    <a:pt x="1170214" y="598715"/>
-                  </a:cubicBezTo>
-                  <a:cubicBezTo>
-                    <a:pt x="1156051" y="926400"/>
-                    <a:pt x="911355" y="1172585"/>
-                    <a:pt x="585107" y="1197430"/>
-                  </a:cubicBezTo>
-                  <a:cubicBezTo>
-                    <a:pt x="240532" y="1167894"/>
-                    <a:pt x="10216" y="915390"/>
-                    <a:pt x="0" y="598715"/>
-                  </a:cubicBezTo>
-                  <a:close/>
-                </a:path>
-              </a:pathLst>
-            </a:custGeom>
-            <a:noFill/>
-            <a:ln w="57150">
-              <a:solidFill>
-                <a:srgbClr val="008C45"/>
-              </a:solidFill>
-              <a:extLst>
-                <a:ext uri="{C807C97D-BFC1-408E-A445-0C87EB9F89A2}">
-                  <ask:lineSketchStyleProps xmlns:ask="http://schemas.microsoft.com/office/drawing/2018/sketchyshapes" sd="4172447036">
-                    <a:prstGeom prst="ellipse">
-                      <a:avLst/>
-                    </a:prstGeom>
-                    <ask:type>
-                      <ask:lineSketchFreehand/>
-                    </ask:type>
-                  </ask:lineSketchStyleProps>
-                </a:ext>
-              </a:extLst>
-            </a:ln>
-          </p:spPr>
-          <p:style>
-            <a:lnRef idx="2">
-              <a:schemeClr val="accent1">
-                <a:shade val="15000"/>
-              </a:schemeClr>
-            </a:lnRef>
-            <a:fillRef idx="1">
-              <a:schemeClr val="accent1"/>
-            </a:fillRef>
-            <a:effectRef idx="0">
-              <a:schemeClr val="accent1"/>
-            </a:effectRef>
-            <a:fontRef idx="minor">
-              <a:schemeClr val="lt1"/>
-            </a:fontRef>
-          </p:style>
-          <p:txBody>
-            <a:bodyPr rtlCol="0" anchor="ctr"/>
-            <a:lstStyle/>
-            <a:p>
-              <a:pPr algn="ctr"/>
-              <a:endParaRPr lang="de-DE"/>
-            </a:p>
-          </p:txBody>
-        </p:sp>
-      </p:grpSp>
+          <a:prstGeom prst="rect">
+            <a:avLst/>
+          </a:prstGeom>
+        </p:spPr>
+      </p:pic>
+      <p:pic>
+        <p:nvPicPr>
+          <p:cNvPr id="22" name="Grafik 21">
+            <a:extLst>
+              <a:ext uri="{FF2B5EF4-FFF2-40B4-BE49-F238E27FC236}">
+                <a16:creationId xmlns:a16="http://schemas.microsoft.com/office/drawing/2014/main" id="{A8809A58-8CDF-19C1-48C6-F444E28D09CE}"/>
+              </a:ext>
+            </a:extLst>
+          </p:cNvPr>
+          <p:cNvPicPr>
+            <a:picLocks noChangeAspect="1"/>
+          </p:cNvPicPr>
+          <p:nvPr userDrawn="1"/>
+        </p:nvPicPr>
+        <p:blipFill>
+          <a:blip r:embed="rId14">
+            <a:extLst>
+              <a:ext uri="{28A0092B-C50C-407E-A947-70E740481C1C}">
+                <a14:useLocalDpi xmlns:a14="http://schemas.microsoft.com/office/drawing/2010/main" val="0"/>
+              </a:ext>
+            </a:extLst>
+          </a:blip>
+          <a:stretch>
+            <a:fillRect/>
+          </a:stretch>
+        </p:blipFill>
+        <p:spPr>
+          <a:xfrm>
+            <a:off x="11353800" y="136525"/>
+            <a:ext cx="646926" cy="731992"/>
+          </a:xfrm>
+          <a:prstGeom prst="rect">
+            <a:avLst/>
+          </a:prstGeom>
+        </p:spPr>
+      </p:pic>
+      <p:pic>
+        <p:nvPicPr>
+          <p:cNvPr id="26" name="Grafik 25">
+            <a:extLst>
+              <a:ext uri="{FF2B5EF4-FFF2-40B4-BE49-F238E27FC236}">
+                <a16:creationId xmlns:a16="http://schemas.microsoft.com/office/drawing/2014/main" id="{2FF7DE4F-5E14-5F25-7307-150BC6DA88F7}"/>
+              </a:ext>
+            </a:extLst>
+          </p:cNvPr>
+          <p:cNvPicPr>
+            <a:picLocks noChangeAspect="1"/>
+          </p:cNvPicPr>
+          <p:nvPr userDrawn="1"/>
+        </p:nvPicPr>
+        <p:blipFill>
+          <a:blip r:embed="rId15">
+            <a:extLst>
+              <a:ext uri="{28A0092B-C50C-407E-A947-70E740481C1C}">
+                <a14:useLocalDpi xmlns:a14="http://schemas.microsoft.com/office/drawing/2010/main" val="0"/>
+              </a:ext>
+            </a:extLst>
+          </a:blip>
+          <a:stretch>
+            <a:fillRect/>
+          </a:stretch>
+        </p:blipFill>
+        <p:spPr>
+          <a:xfrm>
+            <a:off x="9488577" y="230188"/>
+            <a:ext cx="748441" cy="731992"/>
+          </a:xfrm>
+          <a:prstGeom prst="rect">
+            <a:avLst/>
+          </a:prstGeom>
+        </p:spPr>
+      </p:pic>
     </p:spTree>
     <p:extLst>
       <p:ext uri="{BB962C8B-B14F-4D97-AF65-F5344CB8AC3E}">
@@ -3755,6 +4281,7 @@
     <p:sldLayoutId id="2147483658" r:id="rId10"/>
     <p:sldLayoutId id="2147483659" r:id="rId11"/>
   </p:sldLayoutIdLst>
+  <p:hf hdr="0"/>
   <p:txStyles>
     <p:titleStyle>
       <a:lvl1pPr algn="l" defTabSz="914400" rtl="0" eaLnBrk="1" latinLnBrk="0" hangingPunct="1">
@@ -4055,721 +4582,151 @@
           <a:chExt cx="0" cy="0"/>
         </a:xfrm>
       </p:grpSpPr>
-      <p:grpSp>
-        <p:nvGrpSpPr>
-          <p:cNvPr id="4" name="Gruppieren 3">
-            <a:extLst>
-              <a:ext uri="{FF2B5EF4-FFF2-40B4-BE49-F238E27FC236}">
-                <a16:creationId xmlns:a16="http://schemas.microsoft.com/office/drawing/2014/main" id="{0F18ED8F-6F2D-4524-03C4-A420B219665F}"/>
-              </a:ext>
-            </a:extLst>
-          </p:cNvPr>
-          <p:cNvGrpSpPr/>
-          <p:nvPr/>
-        </p:nvGrpSpPr>
-        <p:grpSpPr>
+      <p:sp>
+        <p:nvSpPr>
+          <p:cNvPr id="2" name="Titel 1">
+            <a:extLst>
+              <a:ext uri="{FF2B5EF4-FFF2-40B4-BE49-F238E27FC236}">
+                <a16:creationId xmlns:a16="http://schemas.microsoft.com/office/drawing/2014/main" id="{C638D95C-7865-0A2C-B6FF-24C6DD74A18D}"/>
+              </a:ext>
+            </a:extLst>
+          </p:cNvPr>
+          <p:cNvSpPr>
+            <a:spLocks noGrp="1"/>
+          </p:cNvSpPr>
+          <p:nvPr>
+            <p:ph type="title"/>
+          </p:nvPr>
+        </p:nvSpPr>
+        <p:spPr>
           <a:xfrm>
-            <a:off x="489857" y="315684"/>
-            <a:ext cx="1197429" cy="1170213"/>
-            <a:chOff x="489857" y="315684"/>
-            <a:chExt cx="1197429" cy="1170213"/>
+            <a:off x="838200" y="2766218"/>
+            <a:ext cx="10515600" cy="1325563"/>
           </a:xfrm>
-        </p:grpSpPr>
-        <p:sp>
-          <p:nvSpPr>
-            <p:cNvPr id="7" name="Grafik 4" descr="Gummiente mit einfarbiger Füllung">
-              <a:extLst>
-                <a:ext uri="{FF2B5EF4-FFF2-40B4-BE49-F238E27FC236}">
-                  <a16:creationId xmlns:a16="http://schemas.microsoft.com/office/drawing/2014/main" id="{25C7E8E7-535E-8669-9FC8-2AC537D62D25}"/>
-                </a:ext>
-              </a:extLst>
-            </p:cNvPr>
-            <p:cNvSpPr/>
-            <p:nvPr/>
-          </p:nvSpPr>
-          <p:spPr>
-            <a:xfrm>
-              <a:off x="696616" y="602797"/>
-              <a:ext cx="762069" cy="590551"/>
-            </a:xfrm>
-            <a:custGeom>
-              <a:avLst/>
-              <a:gdLst>
-                <a:gd name="csX0" fmla="*/ 684917 w 762069"/>
-                <a:gd name="csY0" fmla="*/ 191452 h 590551"/>
-                <a:gd name="csX1" fmla="*/ 685869 w 762069"/>
-                <a:gd name="csY1" fmla="*/ 171450 h 590551"/>
-                <a:gd name="csX2" fmla="*/ 514419 w 762069"/>
-                <a:gd name="csY2" fmla="*/ 0 h 590551"/>
-                <a:gd name="csX3" fmla="*/ 342969 w 762069"/>
-                <a:gd name="csY3" fmla="*/ 171450 h 590551"/>
-                <a:gd name="csX4" fmla="*/ 383927 w 762069"/>
-                <a:gd name="csY4" fmla="*/ 281940 h 590551"/>
-                <a:gd name="csX5" fmla="*/ 49599 w 762069"/>
-                <a:gd name="csY5" fmla="*/ 247650 h 590551"/>
-                <a:gd name="csX6" fmla="*/ 21024 w 762069"/>
-                <a:gd name="csY6" fmla="*/ 259080 h 590551"/>
-                <a:gd name="csX7" fmla="*/ 37217 w 762069"/>
-                <a:gd name="csY7" fmla="*/ 490538 h 590551"/>
-                <a:gd name="csX8" fmla="*/ 366782 w 762069"/>
-                <a:gd name="csY8" fmla="*/ 590550 h 590551"/>
-                <a:gd name="csX9" fmla="*/ 646817 w 762069"/>
-                <a:gd name="csY9" fmla="*/ 470535 h 590551"/>
-                <a:gd name="csX10" fmla="*/ 591572 w 762069"/>
-                <a:gd name="csY10" fmla="*/ 324803 h 590551"/>
-                <a:gd name="csX11" fmla="*/ 647769 w 762069"/>
-                <a:gd name="csY11" fmla="*/ 275273 h 590551"/>
-                <a:gd name="csX12" fmla="*/ 743019 w 762069"/>
-                <a:gd name="csY12" fmla="*/ 229552 h 590551"/>
-                <a:gd name="csX13" fmla="*/ 762069 w 762069"/>
-                <a:gd name="csY13" fmla="*/ 200977 h 590551"/>
-                <a:gd name="csX14" fmla="*/ 684917 w 762069"/>
-                <a:gd name="csY14" fmla="*/ 191452 h 590551"/>
-                <a:gd name="csX15" fmla="*/ 599192 w 762069"/>
-                <a:gd name="csY15" fmla="*/ 171450 h 590551"/>
-                <a:gd name="csX16" fmla="*/ 570617 w 762069"/>
-                <a:gd name="csY16" fmla="*/ 142875 h 590551"/>
-                <a:gd name="csX17" fmla="*/ 599192 w 762069"/>
-                <a:gd name="csY17" fmla="*/ 114300 h 590551"/>
-                <a:gd name="csX18" fmla="*/ 627767 w 762069"/>
-                <a:gd name="csY18" fmla="*/ 142875 h 590551"/>
-                <a:gd name="csX19" fmla="*/ 599192 w 762069"/>
-                <a:gd name="csY19" fmla="*/ 171450 h 590551"/>
-              </a:gdLst>
-              <a:ahLst/>
-              <a:cxnLst>
-                <a:cxn ang="0">
-                  <a:pos x="csX0" y="csY0"/>
-                </a:cxn>
-                <a:cxn ang="0">
-                  <a:pos x="csX1" y="csY1"/>
-                </a:cxn>
-                <a:cxn ang="0">
-                  <a:pos x="csX2" y="csY2"/>
-                </a:cxn>
-                <a:cxn ang="0">
-                  <a:pos x="csX3" y="csY3"/>
-                </a:cxn>
-                <a:cxn ang="0">
-                  <a:pos x="csX4" y="csY4"/>
-                </a:cxn>
-                <a:cxn ang="0">
-                  <a:pos x="csX5" y="csY5"/>
-                </a:cxn>
-                <a:cxn ang="0">
-                  <a:pos x="csX6" y="csY6"/>
-                </a:cxn>
-                <a:cxn ang="0">
-                  <a:pos x="csX7" y="csY7"/>
-                </a:cxn>
-                <a:cxn ang="0">
-                  <a:pos x="csX8" y="csY8"/>
-                </a:cxn>
-                <a:cxn ang="0">
-                  <a:pos x="csX9" y="csY9"/>
-                </a:cxn>
-                <a:cxn ang="0">
-                  <a:pos x="csX10" y="csY10"/>
-                </a:cxn>
-                <a:cxn ang="0">
-                  <a:pos x="csX11" y="csY11"/>
-                </a:cxn>
-                <a:cxn ang="0">
-                  <a:pos x="csX12" y="csY12"/>
-                </a:cxn>
-                <a:cxn ang="0">
-                  <a:pos x="csX13" y="csY13"/>
-                </a:cxn>
-                <a:cxn ang="0">
-                  <a:pos x="csX14" y="csY14"/>
-                </a:cxn>
-                <a:cxn ang="0">
-                  <a:pos x="csX15" y="csY15"/>
-                </a:cxn>
-                <a:cxn ang="0">
-                  <a:pos x="csX16" y="csY16"/>
-                </a:cxn>
-                <a:cxn ang="0">
-                  <a:pos x="csX17" y="csY17"/>
-                </a:cxn>
-                <a:cxn ang="0">
-                  <a:pos x="csX18" y="csY18"/>
-                </a:cxn>
-                <a:cxn ang="0">
-                  <a:pos x="csX19" y="csY19"/>
-                </a:cxn>
-              </a:cxnLst>
-              <a:rect l="l" t="t" r="r" b="b"/>
-              <a:pathLst>
-                <a:path w="762069" h="590551" fill="none" extrusionOk="0">
-                  <a:moveTo>
-                    <a:pt x="684917" y="191452"/>
-                  </a:moveTo>
-                  <a:cubicBezTo>
-                    <a:pt x="686529" y="183923"/>
-                    <a:pt x="686640" y="178820"/>
-                    <a:pt x="685869" y="171450"/>
-                  </a:cubicBezTo>
-                  <a:cubicBezTo>
-                    <a:pt x="683743" y="84485"/>
-                    <a:pt x="604987" y="4173"/>
-                    <a:pt x="514419" y="0"/>
-                  </a:cubicBezTo>
-                  <a:cubicBezTo>
-                    <a:pt x="423533" y="2635"/>
-                    <a:pt x="354361" y="82566"/>
-                    <a:pt x="342969" y="171450"/>
-                  </a:cubicBezTo>
-                  <a:cubicBezTo>
-                    <a:pt x="340081" y="218790"/>
-                    <a:pt x="356030" y="252217"/>
-                    <a:pt x="383927" y="281940"/>
-                  </a:cubicBezTo>
-                  <a:cubicBezTo>
-                    <a:pt x="294596" y="298712"/>
-                    <a:pt x="238696" y="372406"/>
-                    <a:pt x="49599" y="247650"/>
-                  </a:cubicBezTo>
-                  <a:cubicBezTo>
-                    <a:pt x="37308" y="239355"/>
-                    <a:pt x="22270" y="245237"/>
-                    <a:pt x="21024" y="259080"/>
-                  </a:cubicBezTo>
-                  <a:cubicBezTo>
-                    <a:pt x="-8349" y="361053"/>
-                    <a:pt x="-18213" y="414211"/>
-                    <a:pt x="37217" y="490538"/>
-                  </a:cubicBezTo>
-                  <a:cubicBezTo>
-                    <a:pt x="109571" y="591285"/>
-                    <a:pt x="189170" y="599119"/>
-                    <a:pt x="366782" y="590550"/>
-                  </a:cubicBezTo>
-                  <a:cubicBezTo>
-                    <a:pt x="539277" y="585150"/>
-                    <a:pt x="645092" y="579446"/>
-                    <a:pt x="646817" y="470535"/>
-                  </a:cubicBezTo>
-                  <a:cubicBezTo>
-                    <a:pt x="641261" y="414042"/>
-                    <a:pt x="631389" y="363836"/>
-                    <a:pt x="591572" y="324803"/>
-                  </a:cubicBezTo>
-                  <a:cubicBezTo>
-                    <a:pt x="615092" y="311396"/>
-                    <a:pt x="640154" y="291694"/>
-                    <a:pt x="647769" y="275273"/>
-                  </a:cubicBezTo>
-                  <a:cubicBezTo>
-                    <a:pt x="692646" y="269658"/>
-                    <a:pt x="727531" y="246434"/>
-                    <a:pt x="743019" y="229552"/>
-                  </a:cubicBezTo>
-                  <a:cubicBezTo>
-                    <a:pt x="752399" y="220013"/>
-                    <a:pt x="759358" y="209240"/>
-                    <a:pt x="762069" y="200977"/>
-                  </a:cubicBezTo>
-                  <a:cubicBezTo>
-                    <a:pt x="745627" y="194088"/>
-                    <a:pt x="695688" y="198772"/>
-                    <a:pt x="684917" y="191452"/>
-                  </a:cubicBezTo>
-                  <a:close/>
-                  <a:moveTo>
-                    <a:pt x="599192" y="171450"/>
-                  </a:moveTo>
-                  <a:cubicBezTo>
-                    <a:pt x="583651" y="170782"/>
-                    <a:pt x="570585" y="160921"/>
-                    <a:pt x="570617" y="142875"/>
-                  </a:cubicBezTo>
-                  <a:cubicBezTo>
-                    <a:pt x="572158" y="124498"/>
-                    <a:pt x="585880" y="114364"/>
-                    <a:pt x="599192" y="114300"/>
-                  </a:cubicBezTo>
-                  <a:cubicBezTo>
-                    <a:pt x="615880" y="113919"/>
-                    <a:pt x="629293" y="128891"/>
-                    <a:pt x="627767" y="142875"/>
-                  </a:cubicBezTo>
-                  <a:cubicBezTo>
-                    <a:pt x="626784" y="157065"/>
-                    <a:pt x="613112" y="170781"/>
-                    <a:pt x="599192" y="171450"/>
-                  </a:cubicBezTo>
-                  <a:close/>
-                </a:path>
-                <a:path w="762069" h="590551" stroke="0" extrusionOk="0">
-                  <a:moveTo>
-                    <a:pt x="684917" y="191452"/>
-                  </a:moveTo>
-                  <a:cubicBezTo>
-                    <a:pt x="686415" y="184167"/>
-                    <a:pt x="685524" y="177772"/>
-                    <a:pt x="685869" y="171450"/>
-                  </a:cubicBezTo>
-                  <a:cubicBezTo>
-                    <a:pt x="698343" y="86625"/>
-                    <a:pt x="596259" y="-4113"/>
-                    <a:pt x="514419" y="0"/>
-                  </a:cubicBezTo>
-                  <a:cubicBezTo>
-                    <a:pt x="432977" y="-3073"/>
-                    <a:pt x="345322" y="76670"/>
-                    <a:pt x="342969" y="171450"/>
-                  </a:cubicBezTo>
-                  <a:cubicBezTo>
-                    <a:pt x="349343" y="214656"/>
-                    <a:pt x="354843" y="259063"/>
-                    <a:pt x="383927" y="281940"/>
-                  </a:cubicBezTo>
-                  <a:cubicBezTo>
-                    <a:pt x="305505" y="294551"/>
-                    <a:pt x="225574" y="357193"/>
-                    <a:pt x="49599" y="247650"/>
-                  </a:cubicBezTo>
-                  <a:cubicBezTo>
-                    <a:pt x="40551" y="243064"/>
-                    <a:pt x="24473" y="247875"/>
-                    <a:pt x="21024" y="259080"/>
-                  </a:cubicBezTo>
-                  <a:cubicBezTo>
-                    <a:pt x="-15955" y="361836"/>
-                    <a:pt x="-5372" y="411835"/>
-                    <a:pt x="37217" y="490538"/>
-                  </a:cubicBezTo>
-                  <a:cubicBezTo>
-                    <a:pt x="91752" y="590962"/>
-                    <a:pt x="189913" y="586195"/>
-                    <a:pt x="366782" y="590550"/>
-                  </a:cubicBezTo>
-                  <a:cubicBezTo>
-                    <a:pt x="556555" y="586367"/>
-                    <a:pt x="655777" y="597245"/>
-                    <a:pt x="646817" y="470535"/>
-                  </a:cubicBezTo>
-                  <a:cubicBezTo>
-                    <a:pt x="638907" y="409751"/>
-                    <a:pt x="628036" y="361721"/>
-                    <a:pt x="591572" y="324803"/>
-                  </a:cubicBezTo>
-                  <a:cubicBezTo>
-                    <a:pt x="614395" y="314560"/>
-                    <a:pt x="638206" y="288812"/>
-                    <a:pt x="647769" y="275273"/>
-                  </a:cubicBezTo>
-                  <a:cubicBezTo>
-                    <a:pt x="694334" y="275348"/>
-                    <a:pt x="723847" y="252066"/>
-                    <a:pt x="743019" y="229552"/>
-                  </a:cubicBezTo>
-                  <a:cubicBezTo>
-                    <a:pt x="752688" y="219986"/>
-                    <a:pt x="757311" y="209275"/>
-                    <a:pt x="762069" y="200977"/>
-                  </a:cubicBezTo>
-                  <a:cubicBezTo>
-                    <a:pt x="731883" y="190245"/>
-                    <a:pt x="702367" y="196676"/>
-                    <a:pt x="684917" y="191452"/>
-                  </a:cubicBezTo>
-                  <a:close/>
-                  <a:moveTo>
-                    <a:pt x="599192" y="171450"/>
-                  </a:moveTo>
-                  <a:cubicBezTo>
-                    <a:pt x="582341" y="170547"/>
-                    <a:pt x="570828" y="159674"/>
-                    <a:pt x="570617" y="142875"/>
-                  </a:cubicBezTo>
-                  <a:cubicBezTo>
-                    <a:pt x="569760" y="129104"/>
-                    <a:pt x="585657" y="114555"/>
-                    <a:pt x="599192" y="114300"/>
-                  </a:cubicBezTo>
-                  <a:cubicBezTo>
-                    <a:pt x="614994" y="116178"/>
-                    <a:pt x="628946" y="129355"/>
-                    <a:pt x="627767" y="142875"/>
-                  </a:cubicBezTo>
-                  <a:cubicBezTo>
-                    <a:pt x="625140" y="157645"/>
-                    <a:pt x="616830" y="173302"/>
-                    <a:pt x="599192" y="171450"/>
-                  </a:cubicBezTo>
-                  <a:close/>
-                </a:path>
-              </a:pathLst>
-            </a:custGeom>
-            <a:solidFill>
-              <a:srgbClr val="008C45"/>
-            </a:solidFill>
-            <a:ln w="9525" cap="flat">
-              <a:solidFill>
-                <a:srgbClr val="008C45"/>
-              </a:solidFill>
-              <a:prstDash val="solid"/>
-              <a:miter/>
-              <a:extLst>
-                <a:ext uri="{C807C97D-BFC1-408E-A445-0C87EB9F89A2}">
-                  <ask:lineSketchStyleProps xmlns:ask="http://schemas.microsoft.com/office/drawing/2018/sketchyshapes" sd="198506542">
-                    <a:custGeom>
-                      <a:avLst/>
-                      <a:gdLst>
-                        <a:gd name="csX0" fmla="*/ 684917 w 762069"/>
-                        <a:gd name="csY0" fmla="*/ 191452 h 590551"/>
-                        <a:gd name="csX1" fmla="*/ 685869 w 762069"/>
-                        <a:gd name="csY1" fmla="*/ 171450 h 590551"/>
-                        <a:gd name="csX2" fmla="*/ 514419 w 762069"/>
-                        <a:gd name="csY2" fmla="*/ 0 h 590551"/>
-                        <a:gd name="csX3" fmla="*/ 342969 w 762069"/>
-                        <a:gd name="csY3" fmla="*/ 171450 h 590551"/>
-                        <a:gd name="csX4" fmla="*/ 383927 w 762069"/>
-                        <a:gd name="csY4" fmla="*/ 281940 h 590551"/>
-                        <a:gd name="csX5" fmla="*/ 49599 w 762069"/>
-                        <a:gd name="csY5" fmla="*/ 247650 h 590551"/>
-                        <a:gd name="csX6" fmla="*/ 21024 w 762069"/>
-                        <a:gd name="csY6" fmla="*/ 259080 h 590551"/>
-                        <a:gd name="csX7" fmla="*/ 37217 w 762069"/>
-                        <a:gd name="csY7" fmla="*/ 490538 h 590551"/>
-                        <a:gd name="csX8" fmla="*/ 366782 w 762069"/>
-                        <a:gd name="csY8" fmla="*/ 590550 h 590551"/>
-                        <a:gd name="csX9" fmla="*/ 646817 w 762069"/>
-                        <a:gd name="csY9" fmla="*/ 470535 h 590551"/>
-                        <a:gd name="csX10" fmla="*/ 591572 w 762069"/>
-                        <a:gd name="csY10" fmla="*/ 324803 h 590551"/>
-                        <a:gd name="csX11" fmla="*/ 647769 w 762069"/>
-                        <a:gd name="csY11" fmla="*/ 275273 h 590551"/>
-                        <a:gd name="csX12" fmla="*/ 743019 w 762069"/>
-                        <a:gd name="csY12" fmla="*/ 229552 h 590551"/>
-                        <a:gd name="csX13" fmla="*/ 762069 w 762069"/>
-                        <a:gd name="csY13" fmla="*/ 200977 h 590551"/>
-                        <a:gd name="csX14" fmla="*/ 684917 w 762069"/>
-                        <a:gd name="csY14" fmla="*/ 191452 h 590551"/>
-                        <a:gd name="csX15" fmla="*/ 599192 w 762069"/>
-                        <a:gd name="csY15" fmla="*/ 171450 h 590551"/>
-                        <a:gd name="csX16" fmla="*/ 570617 w 762069"/>
-                        <a:gd name="csY16" fmla="*/ 142875 h 590551"/>
-                        <a:gd name="csX17" fmla="*/ 599192 w 762069"/>
-                        <a:gd name="csY17" fmla="*/ 114300 h 590551"/>
-                        <a:gd name="csX18" fmla="*/ 627767 w 762069"/>
-                        <a:gd name="csY18" fmla="*/ 142875 h 590551"/>
-                        <a:gd name="csX19" fmla="*/ 599192 w 762069"/>
-                        <a:gd name="csY19" fmla="*/ 171450 h 590551"/>
-                      </a:gdLst>
-                      <a:ahLst/>
-                      <a:cxnLst>
-                        <a:cxn ang="0">
-                          <a:pos x="csX0" y="csY0"/>
-                        </a:cxn>
-                        <a:cxn ang="0">
-                          <a:pos x="csX1" y="csY1"/>
-                        </a:cxn>
-                        <a:cxn ang="0">
-                          <a:pos x="csX2" y="csY2"/>
-                        </a:cxn>
-                        <a:cxn ang="0">
-                          <a:pos x="csX3" y="csY3"/>
-                        </a:cxn>
-                        <a:cxn ang="0">
-                          <a:pos x="csX4" y="csY4"/>
-                        </a:cxn>
-                        <a:cxn ang="0">
-                          <a:pos x="csX5" y="csY5"/>
-                        </a:cxn>
-                        <a:cxn ang="0">
-                          <a:pos x="csX6" y="csY6"/>
-                        </a:cxn>
-                        <a:cxn ang="0">
-                          <a:pos x="csX7" y="csY7"/>
-                        </a:cxn>
-                        <a:cxn ang="0">
-                          <a:pos x="csX8" y="csY8"/>
-                        </a:cxn>
-                        <a:cxn ang="0">
-                          <a:pos x="csX9" y="csY9"/>
-                        </a:cxn>
-                        <a:cxn ang="0">
-                          <a:pos x="csX10" y="csY10"/>
-                        </a:cxn>
-                        <a:cxn ang="0">
-                          <a:pos x="csX11" y="csY11"/>
-                        </a:cxn>
-                        <a:cxn ang="0">
-                          <a:pos x="csX12" y="csY12"/>
-                        </a:cxn>
-                        <a:cxn ang="0">
-                          <a:pos x="csX13" y="csY13"/>
-                        </a:cxn>
-                        <a:cxn ang="0">
-                          <a:pos x="csX14" y="csY14"/>
-                        </a:cxn>
-                        <a:cxn ang="0">
-                          <a:pos x="csX15" y="csY15"/>
-                        </a:cxn>
-                        <a:cxn ang="0">
-                          <a:pos x="csX16" y="csY16"/>
-                        </a:cxn>
-                        <a:cxn ang="0">
-                          <a:pos x="csX17" y="csY17"/>
-                        </a:cxn>
-                        <a:cxn ang="0">
-                          <a:pos x="csX18" y="csY18"/>
-                        </a:cxn>
-                        <a:cxn ang="0">
-                          <a:pos x="csX19" y="csY19"/>
-                        </a:cxn>
-                      </a:cxnLst>
-                      <a:rect l="l" t="t" r="r" b="b"/>
-                      <a:pathLst>
-                        <a:path w="762069" h="590551">
-                          <a:moveTo>
-                            <a:pt x="684917" y="191452"/>
-                          </a:moveTo>
-                          <a:cubicBezTo>
-                            <a:pt x="685869" y="184785"/>
-                            <a:pt x="685869" y="178118"/>
-                            <a:pt x="685869" y="171450"/>
-                          </a:cubicBezTo>
-                          <a:cubicBezTo>
-                            <a:pt x="685869" y="77153"/>
-                            <a:pt x="608717" y="0"/>
-                            <a:pt x="514419" y="0"/>
-                          </a:cubicBezTo>
-                          <a:cubicBezTo>
-                            <a:pt x="420122" y="0"/>
-                            <a:pt x="342969" y="77153"/>
-                            <a:pt x="342969" y="171450"/>
-                          </a:cubicBezTo>
-                          <a:cubicBezTo>
-                            <a:pt x="342969" y="213360"/>
-                            <a:pt x="358209" y="252413"/>
-                            <a:pt x="383927" y="281940"/>
-                          </a:cubicBezTo>
-                          <a:cubicBezTo>
-                            <a:pt x="295344" y="293370"/>
-                            <a:pt x="224859" y="359093"/>
-                            <a:pt x="49599" y="247650"/>
-                          </a:cubicBezTo>
-                          <a:cubicBezTo>
-                            <a:pt x="39122" y="240983"/>
-                            <a:pt x="23882" y="246698"/>
-                            <a:pt x="21024" y="259080"/>
-                          </a:cubicBezTo>
-                          <a:cubicBezTo>
-                            <a:pt x="-7551" y="360998"/>
-                            <a:pt x="-11361" y="419100"/>
-                            <a:pt x="37217" y="490538"/>
-                          </a:cubicBezTo>
-                          <a:cubicBezTo>
-                            <a:pt x="105797" y="589598"/>
-                            <a:pt x="179139" y="590550"/>
-                            <a:pt x="366782" y="590550"/>
-                          </a:cubicBezTo>
-                          <a:cubicBezTo>
-                            <a:pt x="554424" y="590550"/>
-                            <a:pt x="646817" y="592455"/>
-                            <a:pt x="646817" y="470535"/>
-                          </a:cubicBezTo>
-                          <a:cubicBezTo>
-                            <a:pt x="646817" y="406718"/>
-                            <a:pt x="632529" y="357188"/>
-                            <a:pt x="591572" y="324803"/>
-                          </a:cubicBezTo>
-                          <a:cubicBezTo>
-                            <a:pt x="614432" y="313373"/>
-                            <a:pt x="638244" y="290513"/>
-                            <a:pt x="647769" y="275273"/>
-                          </a:cubicBezTo>
-                          <a:cubicBezTo>
-                            <a:pt x="692537" y="270510"/>
-                            <a:pt x="724922" y="249555"/>
-                            <a:pt x="743019" y="229552"/>
-                          </a:cubicBezTo>
-                          <a:cubicBezTo>
-                            <a:pt x="752544" y="220027"/>
-                            <a:pt x="758259" y="208598"/>
-                            <a:pt x="762069" y="200977"/>
-                          </a:cubicBezTo>
-                          <a:lnTo>
-                            <a:pt x="684917" y="191452"/>
-                          </a:lnTo>
-                          <a:close/>
-                          <a:moveTo>
-                            <a:pt x="599192" y="171450"/>
-                          </a:moveTo>
-                          <a:cubicBezTo>
-                            <a:pt x="582999" y="171450"/>
-                            <a:pt x="570617" y="159068"/>
-                            <a:pt x="570617" y="142875"/>
-                          </a:cubicBezTo>
-                          <a:cubicBezTo>
-                            <a:pt x="570617" y="126682"/>
-                            <a:pt x="582999" y="114300"/>
-                            <a:pt x="599192" y="114300"/>
-                          </a:cubicBezTo>
-                          <a:cubicBezTo>
-                            <a:pt x="615384" y="114300"/>
-                            <a:pt x="627767" y="126682"/>
-                            <a:pt x="627767" y="142875"/>
-                          </a:cubicBezTo>
-                          <a:cubicBezTo>
-                            <a:pt x="627767" y="159068"/>
-                            <a:pt x="615384" y="171450"/>
-                            <a:pt x="599192" y="171450"/>
-                          </a:cubicBezTo>
-                          <a:close/>
-                        </a:path>
-                      </a:pathLst>
-                    </a:custGeom>
-                    <ask:type>
-                      <ask:lineSketchCurved/>
-                    </ask:type>
-                  </ask:lineSketchStyleProps>
-                </a:ext>
-              </a:extLst>
-            </a:ln>
-          </p:spPr>
-          <p:txBody>
-            <a:bodyPr/>
-            <a:lstStyle/>
-            <a:p>
-              <a:endParaRPr lang="de-DE"/>
-            </a:p>
-          </p:txBody>
-        </p:sp>
-        <p:sp>
-          <p:nvSpPr>
-            <p:cNvPr id="6" name="Ellipse 5">
-              <a:extLst>
-                <a:ext uri="{FF2B5EF4-FFF2-40B4-BE49-F238E27FC236}">
-                  <a16:creationId xmlns:a16="http://schemas.microsoft.com/office/drawing/2014/main" id="{7C527E64-9408-6C1E-95B9-A905C0164873}"/>
-                </a:ext>
-              </a:extLst>
-            </p:cNvPr>
-            <p:cNvSpPr/>
-            <p:nvPr/>
-          </p:nvSpPr>
-          <p:spPr>
-            <a:xfrm rot="16200000">
-              <a:off x="503465" y="302076"/>
-              <a:ext cx="1170213" cy="1197429"/>
-            </a:xfrm>
-            <a:custGeom>
-              <a:avLst/>
-              <a:gdLst>
-                <a:gd name="csX0" fmla="*/ 0 w 1170213"/>
-                <a:gd name="csY0" fmla="*/ 598715 h 1197429"/>
-                <a:gd name="csX1" fmla="*/ 585107 w 1170213"/>
-                <a:gd name="csY1" fmla="*/ 0 h 1197429"/>
-                <a:gd name="csX2" fmla="*/ 1170214 w 1170213"/>
-                <a:gd name="csY2" fmla="*/ 598715 h 1197429"/>
-                <a:gd name="csX3" fmla="*/ 585107 w 1170213"/>
-                <a:gd name="csY3" fmla="*/ 1197430 h 1197429"/>
-                <a:gd name="csX4" fmla="*/ 0 w 1170213"/>
-                <a:gd name="csY4" fmla="*/ 598715 h 1197429"/>
-              </a:gdLst>
-              <a:ahLst/>
-              <a:cxnLst>
-                <a:cxn ang="0">
-                  <a:pos x="csX0" y="csY0"/>
-                </a:cxn>
-                <a:cxn ang="0">
-                  <a:pos x="csX1" y="csY1"/>
-                </a:cxn>
-                <a:cxn ang="0">
-                  <a:pos x="csX2" y="csY2"/>
-                </a:cxn>
-                <a:cxn ang="0">
-                  <a:pos x="csX3" y="csY3"/>
-                </a:cxn>
-                <a:cxn ang="0">
-                  <a:pos x="csX4" y="csY4"/>
-                </a:cxn>
-              </a:cxnLst>
-              <a:rect l="l" t="t" r="r" b="b"/>
-              <a:pathLst>
-                <a:path w="1170213" h="1197429" extrusionOk="0">
-                  <a:moveTo>
-                    <a:pt x="0" y="598715"/>
-                  </a:moveTo>
-                  <a:cubicBezTo>
-                    <a:pt x="-22492" y="224295"/>
-                    <a:pt x="243509" y="19752"/>
-                    <a:pt x="585107" y="0"/>
-                  </a:cubicBezTo>
-                  <a:cubicBezTo>
-                    <a:pt x="974514" y="39891"/>
-                    <a:pt x="1145897" y="221904"/>
-                    <a:pt x="1170214" y="598715"/>
-                  </a:cubicBezTo>
-                  <a:cubicBezTo>
-                    <a:pt x="1156051" y="926400"/>
-                    <a:pt x="911355" y="1172585"/>
-                    <a:pt x="585107" y="1197430"/>
-                  </a:cubicBezTo>
-                  <a:cubicBezTo>
-                    <a:pt x="240532" y="1167894"/>
-                    <a:pt x="10216" y="915390"/>
-                    <a:pt x="0" y="598715"/>
-                  </a:cubicBezTo>
-                  <a:close/>
-                </a:path>
-              </a:pathLst>
-            </a:custGeom>
-            <a:noFill/>
-            <a:ln w="57150">
-              <a:solidFill>
-                <a:srgbClr val="008C45"/>
-              </a:solidFill>
-              <a:extLst>
-                <a:ext uri="{C807C97D-BFC1-408E-A445-0C87EB9F89A2}">
-                  <ask:lineSketchStyleProps xmlns:ask="http://schemas.microsoft.com/office/drawing/2018/sketchyshapes" sd="4172447036">
-                    <a:prstGeom prst="ellipse">
-                      <a:avLst/>
-                    </a:prstGeom>
-                    <ask:type>
-                      <ask:lineSketchFreehand/>
-                    </ask:type>
-                  </ask:lineSketchStyleProps>
-                </a:ext>
-              </a:extLst>
-            </a:ln>
-          </p:spPr>
-          <p:style>
-            <a:lnRef idx="2">
-              <a:schemeClr val="accent1">
-                <a:shade val="15000"/>
-              </a:schemeClr>
-            </a:lnRef>
-            <a:fillRef idx="1">
-              <a:schemeClr val="accent1"/>
-            </a:fillRef>
-            <a:effectRef idx="0">
-              <a:schemeClr val="accent1"/>
-            </a:effectRef>
-            <a:fontRef idx="minor">
-              <a:schemeClr val="lt1"/>
-            </a:fontRef>
-          </p:style>
-          <p:txBody>
-            <a:bodyPr rtlCol="0" anchor="ctr"/>
-            <a:lstStyle/>
-            <a:p>
-              <a:pPr algn="ctr"/>
-              <a:endParaRPr lang="de-DE"/>
-            </a:p>
-          </p:txBody>
-        </p:sp>
-      </p:grpSp>
+        </p:spPr>
+        <p:txBody>
+          <a:bodyPr>
+            <a:noAutofit/>
+          </a:bodyPr>
+          <a:lstStyle/>
+          <a:p>
+            <a:r>
+              <a:rPr lang="de-DE" sz="5400" dirty="0"/>
+              <a:t>BayWa </a:t>
+            </a:r>
+            <a:r>
+              <a:rPr lang="de-DE" sz="5400" dirty="0" err="1"/>
+              <a:t>r.e</a:t>
+            </a:r>
+            <a:r>
+              <a:rPr lang="de-DE" sz="5400" dirty="0"/>
+              <a:t>. Challenge</a:t>
+            </a:r>
+            <a:br>
+              <a:rPr lang="de-DE" sz="5400" dirty="0"/>
+            </a:br>
+            <a:br>
+              <a:rPr lang="de-DE" sz="5400" dirty="0"/>
+            </a:br>
+            <a:r>
+              <a:rPr lang="de-DE" sz="5400" dirty="0"/>
+              <a:t>Team </a:t>
+            </a:r>
+          </a:p>
+        </p:txBody>
+      </p:sp>
+      <p:sp>
+        <p:nvSpPr>
+          <p:cNvPr id="4" name="Datumsplatzhalter 3">
+            <a:extLst>
+              <a:ext uri="{FF2B5EF4-FFF2-40B4-BE49-F238E27FC236}">
+                <a16:creationId xmlns:a16="http://schemas.microsoft.com/office/drawing/2014/main" id="{22E538EA-3239-B0E3-82E3-81C0A7453A38}"/>
+              </a:ext>
+            </a:extLst>
+          </p:cNvPr>
+          <p:cNvSpPr>
+            <a:spLocks noGrp="1"/>
+          </p:cNvSpPr>
+          <p:nvPr>
+            <p:ph type="dt" sz="half" idx="10"/>
+          </p:nvPr>
+        </p:nvSpPr>
+        <p:spPr/>
+        <p:txBody>
+          <a:bodyPr/>
+          <a:lstStyle/>
+          <a:p>
+            <a:fld id="{F1DBF686-17EF-4B2F-B320-FDA5A791E320}" type="datetime1">
+              <a:rPr lang="de-DE" smtClean="0"/>
+              <a:t>24.10.2026</a:t>
+            </a:fld>
+            <a:endParaRPr lang="de-DE"/>
+          </a:p>
+        </p:txBody>
+      </p:sp>
+      <p:sp>
+        <p:nvSpPr>
+          <p:cNvPr id="5" name="Fußzeilenplatzhalter 4">
+            <a:extLst>
+              <a:ext uri="{FF2B5EF4-FFF2-40B4-BE49-F238E27FC236}">
+                <a16:creationId xmlns:a16="http://schemas.microsoft.com/office/drawing/2014/main" id="{8AFB7A98-3FCD-483D-B79B-B9898AD7230D}"/>
+              </a:ext>
+            </a:extLst>
+          </p:cNvPr>
+          <p:cNvSpPr>
+            <a:spLocks noGrp="1"/>
+          </p:cNvSpPr>
+          <p:nvPr>
+            <p:ph type="ftr" sz="quarter" idx="11"/>
+          </p:nvPr>
+        </p:nvSpPr>
+        <p:spPr/>
+        <p:txBody>
+          <a:bodyPr/>
+          <a:lstStyle/>
+          <a:p>
+            <a:r>
+              <a:rPr lang="de-DE"/>
+              <a:t>Munich Climate Week Hackathon - BayWa r.e. challenge - Lino &amp; Philip &amp; Thalea</a:t>
+            </a:r>
+          </a:p>
+        </p:txBody>
+      </p:sp>
+      <p:sp>
+        <p:nvSpPr>
+          <p:cNvPr id="6" name="Foliennummernplatzhalter 5">
+            <a:extLst>
+              <a:ext uri="{FF2B5EF4-FFF2-40B4-BE49-F238E27FC236}">
+                <a16:creationId xmlns:a16="http://schemas.microsoft.com/office/drawing/2014/main" id="{ADC467BC-20C4-95F6-278A-7694AB11065A}"/>
+              </a:ext>
+            </a:extLst>
+          </p:cNvPr>
+          <p:cNvSpPr>
+            <a:spLocks noGrp="1"/>
+          </p:cNvSpPr>
+          <p:nvPr>
+            <p:ph type="sldNum" sz="quarter" idx="12"/>
+          </p:nvPr>
+        </p:nvSpPr>
+        <p:spPr/>
+        <p:txBody>
+          <a:bodyPr/>
+          <a:lstStyle/>
+          <a:p>
+            <a:fld id="{376AFD4C-B87D-482E-9604-D457C6441148}" type="slidenum">
+              <a:rPr lang="de-DE" smtClean="0"/>
+              <a:t>1</a:t>
+            </a:fld>
+            <a:endParaRPr lang="de-DE"/>
+          </a:p>
+        </p:txBody>
+      </p:sp>
       <p:pic>
         <p:nvPicPr>
-          <p:cNvPr id="3" name="Grafik 2">
-            <a:extLst>
-              <a:ext uri="{FF2B5EF4-FFF2-40B4-BE49-F238E27FC236}">
-                <a16:creationId xmlns:a16="http://schemas.microsoft.com/office/drawing/2014/main" id="{B2481572-B02D-BF50-BD20-9EDE585A6EF8}"/>
+          <p:cNvPr id="11" name="Grafik 10">
+            <a:extLst>
+              <a:ext uri="{FF2B5EF4-FFF2-40B4-BE49-F238E27FC236}">
+                <a16:creationId xmlns:a16="http://schemas.microsoft.com/office/drawing/2014/main" id="{136C45CD-3007-239F-4786-FEE90CB1AC01}"/>
               </a:ext>
             </a:extLst>
           </p:cNvPr>
@@ -4792,8 +4749,8 @@
         </p:blipFill>
         <p:spPr>
           <a:xfrm>
-            <a:off x="0" y="1107281"/>
-            <a:ext cx="12192000" cy="4643438"/>
+            <a:off x="2659505" y="3475247"/>
+            <a:ext cx="1260776" cy="1233067"/>
           </a:xfrm>
           <a:prstGeom prst="rect">
             <a:avLst/>
@@ -4803,7 +4760,7 @@
     </p:spTree>
     <p:extLst>
       <p:ext uri="{BB962C8B-B14F-4D97-AF65-F5344CB8AC3E}">
-        <p14:creationId xmlns:p14="http://schemas.microsoft.com/office/powerpoint/2010/main" val="226131407"/>
+        <p14:creationId xmlns:p14="http://schemas.microsoft.com/office/powerpoint/2010/main" val="4217283603"/>
       </p:ext>
     </p:extLst>
   </p:cSld>
@@ -4830,20 +4787,55 @@
           <a:chExt cx="0" cy="0"/>
         </a:xfrm>
       </p:grpSpPr>
-      <p:sp>
-        <p:nvSpPr>
-          <p:cNvPr id="2" name="Titel 1">
-            <a:extLst>
-              <a:ext uri="{FF2B5EF4-FFF2-40B4-BE49-F238E27FC236}">
-                <a16:creationId xmlns:a16="http://schemas.microsoft.com/office/drawing/2014/main" id="{381754DE-94F1-FD20-E1D2-55204D47BCDF}"/>
-              </a:ext>
-            </a:extLst>
-          </p:cNvPr>
-          <p:cNvSpPr>
-            <a:spLocks noGrp="1"/>
-          </p:cNvSpPr>
-          <p:nvPr>
-            <p:ph type="title"/>
+      <p:pic>
+        <p:nvPicPr>
+          <p:cNvPr id="8" name="Inhaltsplatzhalter 7" descr="Ratlos mit einfarbiger Füllung">
+            <a:extLst>
+              <a:ext uri="{FF2B5EF4-FFF2-40B4-BE49-F238E27FC236}">
+                <a16:creationId xmlns:a16="http://schemas.microsoft.com/office/drawing/2014/main" id="{FAFCA354-D1E7-FCFC-3E7E-2B296BBD63FB}"/>
+              </a:ext>
+            </a:extLst>
+          </p:cNvPr>
+          <p:cNvPicPr>
+            <a:picLocks noGrp="1" noChangeAspect="1"/>
+          </p:cNvPicPr>
+          <p:nvPr>
+            <p:ph idx="1"/>
+          </p:nvPr>
+        </p:nvPicPr>
+        <p:blipFill>
+          <a:blip>
+            <a:extLst>
+              <a:ext uri="{96DAC541-7B7A-43D3-8B79-37D633B846F1}">
+                <asvg:svgBlip xmlns:asvg="http://schemas.microsoft.com/office/drawing/2016/SVG/main" r:embed="rId3"/>
+              </a:ext>
+            </a:extLst>
+          </a:blip>
+          <a:stretch>
+            <a:fillRect/>
+          </a:stretch>
+        </p:blipFill>
+        <p:spPr>
+          <a:xfrm>
+            <a:off x="885963" y="3568385"/>
+            <a:ext cx="914400" cy="914400"/>
+          </a:xfrm>
+        </p:spPr>
+      </p:pic>
+      <p:sp>
+        <p:nvSpPr>
+          <p:cNvPr id="4" name="Datumsplatzhalter 3">
+            <a:extLst>
+              <a:ext uri="{FF2B5EF4-FFF2-40B4-BE49-F238E27FC236}">
+                <a16:creationId xmlns:a16="http://schemas.microsoft.com/office/drawing/2014/main" id="{EC731925-413F-AB68-9FD9-A82F84827938}"/>
+              </a:ext>
+            </a:extLst>
+          </p:cNvPr>
+          <p:cNvSpPr>
+            <a:spLocks noGrp="1"/>
+          </p:cNvSpPr>
+          <p:nvPr>
+            <p:ph type="dt" sz="half" idx="10"/>
           </p:nvPr>
         </p:nvSpPr>
         <p:spPr/>
@@ -4851,24 +4843,28 @@
           <a:bodyPr/>
           <a:lstStyle/>
           <a:p>
+            <a:fld id="{F1DBF686-17EF-4B2F-B320-FDA5A791E320}" type="datetime1">
+              <a:rPr lang="de-DE" smtClean="0"/>
+              <a:t>24.10.2026</a:t>
+            </a:fld>
             <a:endParaRPr lang="de-DE"/>
           </a:p>
         </p:txBody>
       </p:sp>
       <p:sp>
         <p:nvSpPr>
-          <p:cNvPr id="3" name="Inhaltsplatzhalter 2">
-            <a:extLst>
-              <a:ext uri="{FF2B5EF4-FFF2-40B4-BE49-F238E27FC236}">
-                <a16:creationId xmlns:a16="http://schemas.microsoft.com/office/drawing/2014/main" id="{6E64D131-011B-9D8D-2240-8F21EFD5F028}"/>
-              </a:ext>
-            </a:extLst>
-          </p:cNvPr>
-          <p:cNvSpPr>
-            <a:spLocks noGrp="1"/>
-          </p:cNvSpPr>
-          <p:nvPr>
-            <p:ph idx="1"/>
+          <p:cNvPr id="5" name="Fußzeilenplatzhalter 4">
+            <a:extLst>
+              <a:ext uri="{FF2B5EF4-FFF2-40B4-BE49-F238E27FC236}">
+                <a16:creationId xmlns:a16="http://schemas.microsoft.com/office/drawing/2014/main" id="{0C98D968-F1D0-8F8D-9F78-E18AF083C0F9}"/>
+              </a:ext>
+            </a:extLst>
+          </p:cNvPr>
+          <p:cNvSpPr>
+            <a:spLocks noGrp="1"/>
+          </p:cNvSpPr>
+          <p:nvPr>
+            <p:ph type="ftr" sz="quarter" idx="11"/>
           </p:nvPr>
         </p:nvSpPr>
         <p:spPr/>
@@ -4876,14 +4872,1222 @@
           <a:bodyPr/>
           <a:lstStyle/>
           <a:p>
+            <a:r>
+              <a:rPr lang="de-DE" dirty="0"/>
+              <a:t>Munich Climate Week Hackathon - BayWa </a:t>
+            </a:r>
+            <a:r>
+              <a:rPr lang="de-DE" dirty="0" err="1"/>
+              <a:t>r.e</a:t>
+            </a:r>
+            <a:r>
+              <a:rPr lang="de-DE" dirty="0"/>
+              <a:t>. </a:t>
+            </a:r>
+            <a:r>
+              <a:rPr lang="de-DE" dirty="0" err="1"/>
+              <a:t>challenge</a:t>
+            </a:r>
+            <a:r>
+              <a:rPr lang="de-DE" dirty="0"/>
+              <a:t> - Lino &amp; Philip &amp; Thalea</a:t>
+            </a:r>
+          </a:p>
+        </p:txBody>
+      </p:sp>
+      <p:sp>
+        <p:nvSpPr>
+          <p:cNvPr id="6" name="Foliennummernplatzhalter 5">
+            <a:extLst>
+              <a:ext uri="{FF2B5EF4-FFF2-40B4-BE49-F238E27FC236}">
+                <a16:creationId xmlns:a16="http://schemas.microsoft.com/office/drawing/2014/main" id="{90A5B7FE-96BC-2EC1-66FA-EDBE69A50D52}"/>
+              </a:ext>
+            </a:extLst>
+          </p:cNvPr>
+          <p:cNvSpPr>
+            <a:spLocks noGrp="1"/>
+          </p:cNvSpPr>
+          <p:nvPr>
+            <p:ph type="sldNum" sz="quarter" idx="12"/>
+          </p:nvPr>
+        </p:nvSpPr>
+        <p:spPr/>
+        <p:txBody>
+          <a:bodyPr/>
+          <a:lstStyle/>
+          <a:p>
+            <a:fld id="{376AFD4C-B87D-482E-9604-D457C6441148}" type="slidenum">
+              <a:rPr lang="de-DE" smtClean="0"/>
+              <a:t>2</a:t>
+            </a:fld>
             <a:endParaRPr lang="de-DE"/>
+          </a:p>
+        </p:txBody>
+      </p:sp>
+      <p:pic>
+        <p:nvPicPr>
+          <p:cNvPr id="10" name="Grafik 9" descr="Uhr mit einfarbiger Füllung">
+            <a:extLst>
+              <a:ext uri="{FF2B5EF4-FFF2-40B4-BE49-F238E27FC236}">
+                <a16:creationId xmlns:a16="http://schemas.microsoft.com/office/drawing/2014/main" id="{F2262D26-D909-BF7E-76F4-EF640604EF84}"/>
+              </a:ext>
+            </a:extLst>
+          </p:cNvPr>
+          <p:cNvPicPr>
+            <a:picLocks noChangeAspect="1"/>
+          </p:cNvPicPr>
+          <p:nvPr/>
+        </p:nvPicPr>
+        <p:blipFill>
+          <a:blip>
+            <a:extLst>
+              <a:ext uri="{96DAC541-7B7A-43D3-8B79-37D633B846F1}">
+                <asvg:svgBlip xmlns:asvg="http://schemas.microsoft.com/office/drawing/2016/SVG/main" r:embed="rId4"/>
+              </a:ext>
+            </a:extLst>
+          </a:blip>
+          <a:stretch>
+            <a:fillRect/>
+          </a:stretch>
+        </p:blipFill>
+        <p:spPr>
+          <a:xfrm>
+            <a:off x="885963" y="2430549"/>
+            <a:ext cx="914400" cy="914400"/>
+          </a:xfrm>
+          <a:prstGeom prst="rect">
+            <a:avLst/>
+          </a:prstGeom>
+        </p:spPr>
+      </p:pic>
+      <p:pic>
+        <p:nvPicPr>
+          <p:cNvPr id="12" name="Grafik 11" descr="Windig mit einfarbiger Füllung">
+            <a:extLst>
+              <a:ext uri="{FF2B5EF4-FFF2-40B4-BE49-F238E27FC236}">
+                <a16:creationId xmlns:a16="http://schemas.microsoft.com/office/drawing/2014/main" id="{009DA069-BBD0-7C9A-CC30-9B28143BF39A}"/>
+              </a:ext>
+            </a:extLst>
+          </p:cNvPr>
+          <p:cNvPicPr>
+            <a:picLocks noChangeAspect="1"/>
+          </p:cNvPicPr>
+          <p:nvPr/>
+        </p:nvPicPr>
+        <p:blipFill>
+          <a:blip>
+            <a:extLst>
+              <a:ext uri="{96DAC541-7B7A-43D3-8B79-37D633B846F1}">
+                <asvg:svgBlip xmlns:asvg="http://schemas.microsoft.com/office/drawing/2016/SVG/main" r:embed="rId5"/>
+              </a:ext>
+            </a:extLst>
+          </a:blip>
+          <a:stretch>
+            <a:fillRect/>
+          </a:stretch>
+        </p:blipFill>
+        <p:spPr>
+          <a:xfrm>
+            <a:off x="940392" y="1392533"/>
+            <a:ext cx="914400" cy="914400"/>
+          </a:xfrm>
+          <a:prstGeom prst="rect">
+            <a:avLst/>
+          </a:prstGeom>
+        </p:spPr>
+      </p:pic>
+      <p:pic>
+        <p:nvPicPr>
+          <p:cNvPr id="19" name="Grafik 18" descr="Pfeil nach rechts mit einfarbiger Füllung">
+            <a:extLst>
+              <a:ext uri="{FF2B5EF4-FFF2-40B4-BE49-F238E27FC236}">
+                <a16:creationId xmlns:a16="http://schemas.microsoft.com/office/drawing/2014/main" id="{23D5CE2E-441C-300E-C5FE-B77ADAD504AE}"/>
+              </a:ext>
+            </a:extLst>
+          </p:cNvPr>
+          <p:cNvPicPr>
+            <a:picLocks noChangeAspect="1"/>
+          </p:cNvPicPr>
+          <p:nvPr/>
+        </p:nvPicPr>
+        <p:blipFill>
+          <a:blip>
+            <a:extLst>
+              <a:ext uri="{96DAC541-7B7A-43D3-8B79-37D633B846F1}">
+                <asvg:svgBlip xmlns:asvg="http://schemas.microsoft.com/office/drawing/2016/SVG/main" r:embed="rId6"/>
+              </a:ext>
+            </a:extLst>
+          </a:blip>
+          <a:stretch>
+            <a:fillRect/>
+          </a:stretch>
+        </p:blipFill>
+        <p:spPr>
+          <a:xfrm>
+            <a:off x="1854792" y="2524750"/>
+            <a:ext cx="914400" cy="914400"/>
+          </a:xfrm>
+          <a:prstGeom prst="rect">
+            <a:avLst/>
+          </a:prstGeom>
+        </p:spPr>
+      </p:pic>
+      <p:pic>
+        <p:nvPicPr>
+          <p:cNvPr id="21" name="Grafik 20" descr="Pfeil nach rechts mit einfarbiger Füllung">
+            <a:extLst>
+              <a:ext uri="{FF2B5EF4-FFF2-40B4-BE49-F238E27FC236}">
+                <a16:creationId xmlns:a16="http://schemas.microsoft.com/office/drawing/2014/main" id="{80DE6FB5-DCFA-9D77-207C-F4F84F29625D}"/>
+              </a:ext>
+            </a:extLst>
+          </p:cNvPr>
+          <p:cNvPicPr>
+            <a:picLocks noChangeAspect="1"/>
+          </p:cNvPicPr>
+          <p:nvPr/>
+        </p:nvPicPr>
+        <p:blipFill>
+          <a:blip>
+            <a:extLst>
+              <a:ext uri="{96DAC541-7B7A-43D3-8B79-37D633B846F1}">
+                <asvg:svgBlip xmlns:asvg="http://schemas.microsoft.com/office/drawing/2016/SVG/main" r:embed="rId6"/>
+              </a:ext>
+            </a:extLst>
+          </a:blip>
+          <a:stretch>
+            <a:fillRect/>
+          </a:stretch>
+        </p:blipFill>
+        <p:spPr>
+          <a:xfrm rot="1910170">
+            <a:off x="2027181" y="1809469"/>
+            <a:ext cx="914400" cy="914400"/>
+          </a:xfrm>
+          <a:prstGeom prst="rect">
+            <a:avLst/>
+          </a:prstGeom>
+        </p:spPr>
+      </p:pic>
+      <p:pic>
+        <p:nvPicPr>
+          <p:cNvPr id="23" name="Grafik 22" descr="Pfeil nach rechts mit einfarbiger Füllung">
+            <a:extLst>
+              <a:ext uri="{FF2B5EF4-FFF2-40B4-BE49-F238E27FC236}">
+                <a16:creationId xmlns:a16="http://schemas.microsoft.com/office/drawing/2014/main" id="{943C5879-38D6-69BA-9A16-BD0C858C7F41}"/>
+              </a:ext>
+            </a:extLst>
+          </p:cNvPr>
+          <p:cNvPicPr>
+            <a:picLocks noChangeAspect="1"/>
+          </p:cNvPicPr>
+          <p:nvPr/>
+        </p:nvPicPr>
+        <p:blipFill>
+          <a:blip>
+            <a:extLst>
+              <a:ext uri="{96DAC541-7B7A-43D3-8B79-37D633B846F1}">
+                <asvg:svgBlip xmlns:asvg="http://schemas.microsoft.com/office/drawing/2016/SVG/main" r:embed="rId6"/>
+              </a:ext>
+            </a:extLst>
+          </a:blip>
+          <a:stretch>
+            <a:fillRect/>
+          </a:stretch>
+        </p:blipFill>
+        <p:spPr>
+          <a:xfrm rot="19577860">
+            <a:off x="2020937" y="3182150"/>
+            <a:ext cx="914400" cy="914400"/>
+          </a:xfrm>
+          <a:prstGeom prst="rect">
+            <a:avLst/>
+          </a:prstGeom>
+        </p:spPr>
+      </p:pic>
+      <p:pic>
+        <p:nvPicPr>
+          <p:cNvPr id="25" name="Grafik 24" descr="Windkraftanlagen mit einfarbiger Füllung">
+            <a:extLst>
+              <a:ext uri="{FF2B5EF4-FFF2-40B4-BE49-F238E27FC236}">
+                <a16:creationId xmlns:a16="http://schemas.microsoft.com/office/drawing/2014/main" id="{73F73A4C-8F87-6281-F60F-ADF9EDC8543A}"/>
+              </a:ext>
+            </a:extLst>
+          </p:cNvPr>
+          <p:cNvPicPr>
+            <a:picLocks noChangeAspect="1"/>
+          </p:cNvPicPr>
+          <p:nvPr/>
+        </p:nvPicPr>
+        <p:blipFill>
+          <a:blip>
+            <a:extLst>
+              <a:ext uri="{96DAC541-7B7A-43D3-8B79-37D633B846F1}">
+                <asvg:svgBlip xmlns:asvg="http://schemas.microsoft.com/office/drawing/2016/SVG/main" r:embed="rId7"/>
+              </a:ext>
+            </a:extLst>
+          </a:blip>
+          <a:stretch>
+            <a:fillRect/>
+          </a:stretch>
+        </p:blipFill>
+        <p:spPr>
+          <a:xfrm>
+            <a:off x="4399157" y="2569687"/>
+            <a:ext cx="914400" cy="914400"/>
+          </a:xfrm>
+          <a:prstGeom prst="rect">
+            <a:avLst/>
+          </a:prstGeom>
+        </p:spPr>
+      </p:pic>
+      <p:sp>
+        <p:nvSpPr>
+          <p:cNvPr id="27" name="Textfeld 26">
+            <a:extLst>
+              <a:ext uri="{FF2B5EF4-FFF2-40B4-BE49-F238E27FC236}">
+                <a16:creationId xmlns:a16="http://schemas.microsoft.com/office/drawing/2014/main" id="{45544867-AFE6-5969-D711-D34F98597BFF}"/>
+              </a:ext>
+            </a:extLst>
+          </p:cNvPr>
+          <p:cNvSpPr txBox="1"/>
+          <p:nvPr/>
+        </p:nvSpPr>
+        <p:spPr>
+          <a:xfrm>
+            <a:off x="3505920" y="4797795"/>
+            <a:ext cx="2608214" cy="1015663"/>
+          </a:xfrm>
+          <a:prstGeom prst="rect">
+            <a:avLst/>
+          </a:prstGeom>
+          <a:noFill/>
+        </p:spPr>
+        <p:txBody>
+          <a:bodyPr wrap="none" rtlCol="0">
+            <a:spAutoFit/>
+          </a:bodyPr>
+          <a:lstStyle/>
+          <a:p>
+            <a:pPr algn="ctr"/>
+            <a:r>
+              <a:rPr lang="de-DE" sz="2000" b="1" dirty="0" err="1"/>
+              <a:t>estimate</a:t>
+            </a:r>
+            <a:r>
+              <a:rPr lang="de-DE" sz="2000" b="1" dirty="0"/>
+              <a:t> wind </a:t>
+            </a:r>
+            <a:r>
+              <a:rPr lang="de-DE" sz="2000" b="1" dirty="0" err="1"/>
+              <a:t>speed</a:t>
+            </a:r>
+            <a:endParaRPr lang="de-DE" sz="2000" b="1" dirty="0"/>
+          </a:p>
+          <a:p>
+            <a:pPr algn="ctr"/>
+            <a:r>
+              <a:rPr lang="de-DE" sz="2000" b="1" dirty="0"/>
+              <a:t>by </a:t>
+            </a:r>
+            <a:r>
+              <a:rPr lang="de-DE" sz="2000" b="1" dirty="0" err="1"/>
+              <a:t>weighted</a:t>
+            </a:r>
+            <a:r>
+              <a:rPr lang="de-DE" sz="2000" b="1" dirty="0"/>
+              <a:t> sums</a:t>
+            </a:r>
+          </a:p>
+          <a:p>
+            <a:pPr algn="ctr"/>
+            <a:r>
+              <a:rPr lang="de-DE" sz="2000" b="1" dirty="0"/>
+              <a:t>(OLS)</a:t>
+            </a:r>
+          </a:p>
+        </p:txBody>
+      </p:sp>
+      <p:pic>
+        <p:nvPicPr>
+          <p:cNvPr id="29" name="Grafik 28" descr="Pfeil nach rechts mit einfarbiger Füllung">
+            <a:extLst>
+              <a:ext uri="{FF2B5EF4-FFF2-40B4-BE49-F238E27FC236}">
+                <a16:creationId xmlns:a16="http://schemas.microsoft.com/office/drawing/2014/main" id="{2A63CFFB-66DD-7584-E644-89534A60BF21}"/>
+              </a:ext>
+            </a:extLst>
+          </p:cNvPr>
+          <p:cNvPicPr>
+            <a:picLocks noChangeAspect="1"/>
+          </p:cNvPicPr>
+          <p:nvPr/>
+        </p:nvPicPr>
+        <p:blipFill>
+          <a:blip>
+            <a:extLst>
+              <a:ext uri="{96DAC541-7B7A-43D3-8B79-37D633B846F1}">
+                <asvg:svgBlip xmlns:asvg="http://schemas.microsoft.com/office/drawing/2016/SVG/main" r:embed="rId6"/>
+              </a:ext>
+            </a:extLst>
+          </a:blip>
+          <a:stretch>
+            <a:fillRect/>
+          </a:stretch>
+        </p:blipFill>
+        <p:spPr>
+          <a:xfrm>
+            <a:off x="5681638" y="2531357"/>
+            <a:ext cx="914400" cy="914400"/>
+          </a:xfrm>
+          <a:prstGeom prst="rect">
+            <a:avLst/>
+          </a:prstGeom>
+        </p:spPr>
+      </p:pic>
+      <p:pic>
+        <p:nvPicPr>
+          <p:cNvPr id="30" name="Image 0" descr="Power curve of the turbine. Around a predicted wind of 6.5 m/s the plausible range is shaded; the average power over that range lies above the power at the best guess, because the curve bends upward.">
+            <a:extLst>
+              <a:ext uri="{FF2B5EF4-FFF2-40B4-BE49-F238E27FC236}">
+                <a16:creationId xmlns:a16="http://schemas.microsoft.com/office/drawing/2014/main" id="{CBFB9DF2-4CDE-D9C5-D897-2EF02E102624}"/>
+              </a:ext>
+            </a:extLst>
+          </p:cNvPr>
+          <p:cNvPicPr>
+            <a:picLocks noChangeAspect="1"/>
+          </p:cNvPicPr>
+          <p:nvPr/>
+        </p:nvPicPr>
+        <p:blipFill>
+          <a:blip r:embed="rId8"/>
+          <a:srcRect l="2121"/>
+          <a:stretch>
+            <a:fillRect/>
+          </a:stretch>
+        </p:blipFill>
+        <p:spPr>
+          <a:xfrm>
+            <a:off x="6596038" y="1365624"/>
+            <a:ext cx="4809558" cy="3057463"/>
+          </a:xfrm>
+          <a:prstGeom prst="rect">
+            <a:avLst/>
+          </a:prstGeom>
+        </p:spPr>
+      </p:pic>
+      <p:sp>
+        <p:nvSpPr>
+          <p:cNvPr id="32" name="Textfeld 31">
+            <a:extLst>
+              <a:ext uri="{FF2B5EF4-FFF2-40B4-BE49-F238E27FC236}">
+                <a16:creationId xmlns:a16="http://schemas.microsoft.com/office/drawing/2014/main" id="{17161680-E660-E4E6-579D-08957787DD75}"/>
+              </a:ext>
+            </a:extLst>
+          </p:cNvPr>
+          <p:cNvSpPr txBox="1"/>
+          <p:nvPr/>
+        </p:nvSpPr>
+        <p:spPr>
+          <a:xfrm>
+            <a:off x="781543" y="4797795"/>
+            <a:ext cx="2305183" cy="400110"/>
+          </a:xfrm>
+          <a:prstGeom prst="rect">
+            <a:avLst/>
+          </a:prstGeom>
+          <a:noFill/>
+        </p:spPr>
+        <p:txBody>
+          <a:bodyPr wrap="none" rtlCol="0">
+            <a:spAutoFit/>
+          </a:bodyPr>
+          <a:lstStyle/>
+          <a:p>
+            <a:pPr algn="ctr"/>
+            <a:r>
+              <a:rPr lang="de-DE" sz="2000" b="1" dirty="0" err="1"/>
+              <a:t>calculate</a:t>
+            </a:r>
+            <a:r>
+              <a:rPr lang="de-DE" sz="2000" b="1" dirty="0"/>
+              <a:t> </a:t>
+            </a:r>
+            <a:r>
+              <a:rPr lang="de-DE" sz="2000" b="1" dirty="0" err="1"/>
+              <a:t>features</a:t>
+            </a:r>
+            <a:endParaRPr lang="de-DE" sz="2000" b="1" dirty="0"/>
+          </a:p>
+        </p:txBody>
+      </p:sp>
+      <p:sp>
+        <p:nvSpPr>
+          <p:cNvPr id="34" name="Textfeld 33">
+            <a:extLst>
+              <a:ext uri="{FF2B5EF4-FFF2-40B4-BE49-F238E27FC236}">
+                <a16:creationId xmlns:a16="http://schemas.microsoft.com/office/drawing/2014/main" id="{E7E7F713-92AF-C17E-4B7F-E441F79CFC54}"/>
+              </a:ext>
+            </a:extLst>
+          </p:cNvPr>
+          <p:cNvSpPr txBox="1"/>
+          <p:nvPr/>
+        </p:nvSpPr>
+        <p:spPr>
+          <a:xfrm>
+            <a:off x="6968387" y="4797795"/>
+            <a:ext cx="2781146" cy="707886"/>
+          </a:xfrm>
+          <a:prstGeom prst="rect">
+            <a:avLst/>
+          </a:prstGeom>
+          <a:noFill/>
+        </p:spPr>
+        <p:txBody>
+          <a:bodyPr wrap="none" rtlCol="0">
+            <a:spAutoFit/>
+          </a:bodyPr>
+          <a:lstStyle/>
+          <a:p>
+            <a:pPr algn="ctr"/>
+            <a:r>
+              <a:rPr lang="de-DE" sz="2000" b="1" dirty="0" err="1"/>
+              <a:t>account</a:t>
+            </a:r>
+            <a:r>
+              <a:rPr lang="de-DE" sz="2000" b="1" dirty="0"/>
+              <a:t> for non-linear</a:t>
+            </a:r>
+          </a:p>
+          <a:p>
+            <a:pPr algn="ctr"/>
+            <a:r>
+              <a:rPr lang="de-DE" sz="2000" b="1" dirty="0"/>
+              <a:t>power </a:t>
+            </a:r>
+            <a:r>
+              <a:rPr lang="de-DE" sz="2000" b="1" dirty="0" err="1"/>
+              <a:t>curve</a:t>
+            </a:r>
+            <a:endParaRPr lang="de-DE" sz="2000" b="1" dirty="0"/>
           </a:p>
         </p:txBody>
       </p:sp>
     </p:spTree>
     <p:extLst>
       <p:ext uri="{BB962C8B-B14F-4D97-AF65-F5344CB8AC3E}">
-        <p14:creationId xmlns:p14="http://schemas.microsoft.com/office/powerpoint/2010/main" val="3477277844"/>
+        <p14:creationId xmlns:p14="http://schemas.microsoft.com/office/powerpoint/2010/main" val="2085831630"/>
+      </p:ext>
+    </p:extLst>
+  </p:cSld>
+  <p:clrMapOvr>
+    <a:masterClrMapping/>
+  </p:clrMapOvr>
+  <p:timing>
+    <p:tnLst>
+      <p:par>
+        <p:cTn id="1" dur="indefinite" restart="never" nodeType="tmRoot">
+          <p:childTnLst>
+            <p:seq concurrent="1" nextAc="seek">
+              <p:cTn id="2" dur="indefinite" nodeType="mainSeq">
+                <p:childTnLst>
+                  <p:par>
+                    <p:cTn id="3" fill="hold">
+                      <p:stCondLst>
+                        <p:cond delay="indefinite"/>
+                      </p:stCondLst>
+                      <p:childTnLst>
+                        <p:par>
+                          <p:cTn id="4" fill="hold">
+                            <p:stCondLst>
+                              <p:cond delay="0"/>
+                            </p:stCondLst>
+                            <p:childTnLst>
+                              <p:par>
+                                <p:cTn id="5" presetID="1" presetClass="entr" presetSubtype="0" fill="hold" nodeType="clickEffect">
+                                  <p:stCondLst>
+                                    <p:cond delay="0"/>
+                                  </p:stCondLst>
+                                  <p:childTnLst>
+                                    <p:set>
+                                      <p:cBhvr>
+                                        <p:cTn id="6" dur="1" fill="hold">
+                                          <p:stCondLst>
+                                            <p:cond delay="0"/>
+                                          </p:stCondLst>
+                                        </p:cTn>
+                                        <p:tgtEl>
+                                          <p:spTgt spid="8"/>
+                                        </p:tgtEl>
+                                        <p:attrNameLst>
+                                          <p:attrName>style.visibility</p:attrName>
+                                        </p:attrNameLst>
+                                      </p:cBhvr>
+                                      <p:to>
+                                        <p:strVal val="visible"/>
+                                      </p:to>
+                                    </p:set>
+                                  </p:childTnLst>
+                                </p:cTn>
+                              </p:par>
+                              <p:par>
+                                <p:cTn id="7" presetID="1" presetClass="entr" presetSubtype="0" fill="hold" nodeType="withEffect">
+                                  <p:stCondLst>
+                                    <p:cond delay="0"/>
+                                  </p:stCondLst>
+                                  <p:childTnLst>
+                                    <p:set>
+                                      <p:cBhvr>
+                                        <p:cTn id="8" dur="1" fill="hold">
+                                          <p:stCondLst>
+                                            <p:cond delay="0"/>
+                                          </p:stCondLst>
+                                        </p:cTn>
+                                        <p:tgtEl>
+                                          <p:spTgt spid="10"/>
+                                        </p:tgtEl>
+                                        <p:attrNameLst>
+                                          <p:attrName>style.visibility</p:attrName>
+                                        </p:attrNameLst>
+                                      </p:cBhvr>
+                                      <p:to>
+                                        <p:strVal val="visible"/>
+                                      </p:to>
+                                    </p:set>
+                                  </p:childTnLst>
+                                </p:cTn>
+                              </p:par>
+                              <p:par>
+                                <p:cTn id="9" presetID="1" presetClass="entr" presetSubtype="0" fill="hold" nodeType="withEffect">
+                                  <p:stCondLst>
+                                    <p:cond delay="0"/>
+                                  </p:stCondLst>
+                                  <p:childTnLst>
+                                    <p:set>
+                                      <p:cBhvr>
+                                        <p:cTn id="10" dur="1" fill="hold">
+                                          <p:stCondLst>
+                                            <p:cond delay="0"/>
+                                          </p:stCondLst>
+                                        </p:cTn>
+                                        <p:tgtEl>
+                                          <p:spTgt spid="12"/>
+                                        </p:tgtEl>
+                                        <p:attrNameLst>
+                                          <p:attrName>style.visibility</p:attrName>
+                                        </p:attrNameLst>
+                                      </p:cBhvr>
+                                      <p:to>
+                                        <p:strVal val="visible"/>
+                                      </p:to>
+                                    </p:set>
+                                  </p:childTnLst>
+                                </p:cTn>
+                              </p:par>
+                              <p:par>
+                                <p:cTn id="11" presetID="1" presetClass="entr" presetSubtype="0" fill="hold" nodeType="withEffect">
+                                  <p:stCondLst>
+                                    <p:cond delay="0"/>
+                                  </p:stCondLst>
+                                  <p:childTnLst>
+                                    <p:set>
+                                      <p:cBhvr>
+                                        <p:cTn id="12" dur="1" fill="hold">
+                                          <p:stCondLst>
+                                            <p:cond delay="0"/>
+                                          </p:stCondLst>
+                                        </p:cTn>
+                                        <p:tgtEl>
+                                          <p:spTgt spid="19"/>
+                                        </p:tgtEl>
+                                        <p:attrNameLst>
+                                          <p:attrName>style.visibility</p:attrName>
+                                        </p:attrNameLst>
+                                      </p:cBhvr>
+                                      <p:to>
+                                        <p:strVal val="visible"/>
+                                      </p:to>
+                                    </p:set>
+                                  </p:childTnLst>
+                                </p:cTn>
+                              </p:par>
+                              <p:par>
+                                <p:cTn id="13" presetID="1" presetClass="entr" presetSubtype="0" fill="hold" nodeType="withEffect">
+                                  <p:stCondLst>
+                                    <p:cond delay="0"/>
+                                  </p:stCondLst>
+                                  <p:childTnLst>
+                                    <p:set>
+                                      <p:cBhvr>
+                                        <p:cTn id="14" dur="1" fill="hold">
+                                          <p:stCondLst>
+                                            <p:cond delay="0"/>
+                                          </p:stCondLst>
+                                        </p:cTn>
+                                        <p:tgtEl>
+                                          <p:spTgt spid="21"/>
+                                        </p:tgtEl>
+                                        <p:attrNameLst>
+                                          <p:attrName>style.visibility</p:attrName>
+                                        </p:attrNameLst>
+                                      </p:cBhvr>
+                                      <p:to>
+                                        <p:strVal val="visible"/>
+                                      </p:to>
+                                    </p:set>
+                                  </p:childTnLst>
+                                </p:cTn>
+                              </p:par>
+                              <p:par>
+                                <p:cTn id="15" presetID="1" presetClass="entr" presetSubtype="0" fill="hold" nodeType="withEffect">
+                                  <p:stCondLst>
+                                    <p:cond delay="0"/>
+                                  </p:stCondLst>
+                                  <p:childTnLst>
+                                    <p:set>
+                                      <p:cBhvr>
+                                        <p:cTn id="16" dur="1" fill="hold">
+                                          <p:stCondLst>
+                                            <p:cond delay="0"/>
+                                          </p:stCondLst>
+                                        </p:cTn>
+                                        <p:tgtEl>
+                                          <p:spTgt spid="23"/>
+                                        </p:tgtEl>
+                                        <p:attrNameLst>
+                                          <p:attrName>style.visibility</p:attrName>
+                                        </p:attrNameLst>
+                                      </p:cBhvr>
+                                      <p:to>
+                                        <p:strVal val="visible"/>
+                                      </p:to>
+                                    </p:set>
+                                  </p:childTnLst>
+                                </p:cTn>
+                              </p:par>
+                              <p:par>
+                                <p:cTn id="17" presetID="1" presetClass="entr" presetSubtype="0" fill="hold" grpId="0" nodeType="withEffect">
+                                  <p:stCondLst>
+                                    <p:cond delay="0"/>
+                                  </p:stCondLst>
+                                  <p:childTnLst>
+                                    <p:set>
+                                      <p:cBhvr>
+                                        <p:cTn id="18" dur="1" fill="hold">
+                                          <p:stCondLst>
+                                            <p:cond delay="0"/>
+                                          </p:stCondLst>
+                                        </p:cTn>
+                                        <p:tgtEl>
+                                          <p:spTgt spid="32"/>
+                                        </p:tgtEl>
+                                        <p:attrNameLst>
+                                          <p:attrName>style.visibility</p:attrName>
+                                        </p:attrNameLst>
+                                      </p:cBhvr>
+                                      <p:to>
+                                        <p:strVal val="visible"/>
+                                      </p:to>
+                                    </p:set>
+                                  </p:childTnLst>
+                                </p:cTn>
+                              </p:par>
+                            </p:childTnLst>
+                          </p:cTn>
+                        </p:par>
+                      </p:childTnLst>
+                    </p:cTn>
+                  </p:par>
+                  <p:par>
+                    <p:cTn id="19" fill="hold">
+                      <p:stCondLst>
+                        <p:cond delay="indefinite"/>
+                      </p:stCondLst>
+                      <p:childTnLst>
+                        <p:par>
+                          <p:cTn id="20" fill="hold">
+                            <p:stCondLst>
+                              <p:cond delay="0"/>
+                            </p:stCondLst>
+                            <p:childTnLst>
+                              <p:par>
+                                <p:cTn id="21" presetID="1" presetClass="entr" presetSubtype="0" fill="hold" nodeType="clickEffect">
+                                  <p:stCondLst>
+                                    <p:cond delay="0"/>
+                                  </p:stCondLst>
+                                  <p:childTnLst>
+                                    <p:set>
+                                      <p:cBhvr>
+                                        <p:cTn id="22" dur="1" fill="hold">
+                                          <p:stCondLst>
+                                            <p:cond delay="0"/>
+                                          </p:stCondLst>
+                                        </p:cTn>
+                                        <p:tgtEl>
+                                          <p:spTgt spid="25"/>
+                                        </p:tgtEl>
+                                        <p:attrNameLst>
+                                          <p:attrName>style.visibility</p:attrName>
+                                        </p:attrNameLst>
+                                      </p:cBhvr>
+                                      <p:to>
+                                        <p:strVal val="visible"/>
+                                      </p:to>
+                                    </p:set>
+                                  </p:childTnLst>
+                                </p:cTn>
+                              </p:par>
+                              <p:par>
+                                <p:cTn id="23" presetID="1" presetClass="entr" presetSubtype="0" fill="hold" grpId="0" nodeType="withEffect">
+                                  <p:stCondLst>
+                                    <p:cond delay="0"/>
+                                  </p:stCondLst>
+                                  <p:childTnLst>
+                                    <p:set>
+                                      <p:cBhvr>
+                                        <p:cTn id="24" dur="1" fill="hold">
+                                          <p:stCondLst>
+                                            <p:cond delay="0"/>
+                                          </p:stCondLst>
+                                        </p:cTn>
+                                        <p:tgtEl>
+                                          <p:spTgt spid="27"/>
+                                        </p:tgtEl>
+                                        <p:attrNameLst>
+                                          <p:attrName>style.visibility</p:attrName>
+                                        </p:attrNameLst>
+                                      </p:cBhvr>
+                                      <p:to>
+                                        <p:strVal val="visible"/>
+                                      </p:to>
+                                    </p:set>
+                                  </p:childTnLst>
+                                </p:cTn>
+                              </p:par>
+                              <p:par>
+                                <p:cTn id="25" presetID="1" presetClass="entr" presetSubtype="0" fill="hold" nodeType="withEffect">
+                                  <p:stCondLst>
+                                    <p:cond delay="0"/>
+                                  </p:stCondLst>
+                                  <p:childTnLst>
+                                    <p:set>
+                                      <p:cBhvr>
+                                        <p:cTn id="26" dur="1" fill="hold">
+                                          <p:stCondLst>
+                                            <p:cond delay="0"/>
+                                          </p:stCondLst>
+                                        </p:cTn>
+                                        <p:tgtEl>
+                                          <p:spTgt spid="29"/>
+                                        </p:tgtEl>
+                                        <p:attrNameLst>
+                                          <p:attrName>style.visibility</p:attrName>
+                                        </p:attrNameLst>
+                                      </p:cBhvr>
+                                      <p:to>
+                                        <p:strVal val="visible"/>
+                                      </p:to>
+                                    </p:set>
+                                  </p:childTnLst>
+                                </p:cTn>
+                              </p:par>
+                            </p:childTnLst>
+                          </p:cTn>
+                        </p:par>
+                      </p:childTnLst>
+                    </p:cTn>
+                  </p:par>
+                  <p:par>
+                    <p:cTn id="27" fill="hold">
+                      <p:stCondLst>
+                        <p:cond delay="indefinite"/>
+                      </p:stCondLst>
+                      <p:childTnLst>
+                        <p:par>
+                          <p:cTn id="28" fill="hold">
+                            <p:stCondLst>
+                              <p:cond delay="0"/>
+                            </p:stCondLst>
+                            <p:childTnLst>
+                              <p:par>
+                                <p:cTn id="29" presetID="1" presetClass="entr" presetSubtype="0" fill="hold" nodeType="clickEffect">
+                                  <p:stCondLst>
+                                    <p:cond delay="0"/>
+                                  </p:stCondLst>
+                                  <p:childTnLst>
+                                    <p:set>
+                                      <p:cBhvr>
+                                        <p:cTn id="30" dur="1" fill="hold">
+                                          <p:stCondLst>
+                                            <p:cond delay="0"/>
+                                          </p:stCondLst>
+                                        </p:cTn>
+                                        <p:tgtEl>
+                                          <p:spTgt spid="30"/>
+                                        </p:tgtEl>
+                                        <p:attrNameLst>
+                                          <p:attrName>style.visibility</p:attrName>
+                                        </p:attrNameLst>
+                                      </p:cBhvr>
+                                      <p:to>
+                                        <p:strVal val="visible"/>
+                                      </p:to>
+                                    </p:set>
+                                  </p:childTnLst>
+                                </p:cTn>
+                              </p:par>
+                              <p:par>
+                                <p:cTn id="31" presetID="1" presetClass="entr" presetSubtype="0" fill="hold" grpId="0" nodeType="withEffect">
+                                  <p:stCondLst>
+                                    <p:cond delay="0"/>
+                                  </p:stCondLst>
+                                  <p:childTnLst>
+                                    <p:set>
+                                      <p:cBhvr>
+                                        <p:cTn id="32" dur="1" fill="hold">
+                                          <p:stCondLst>
+                                            <p:cond delay="0"/>
+                                          </p:stCondLst>
+                                        </p:cTn>
+                                        <p:tgtEl>
+                                          <p:spTgt spid="34"/>
+                                        </p:tgtEl>
+                                        <p:attrNameLst>
+                                          <p:attrName>style.visibility</p:attrName>
+                                        </p:attrNameLst>
+                                      </p:cBhvr>
+                                      <p:to>
+                                        <p:strVal val="visible"/>
+                                      </p:to>
+                                    </p:set>
+                                  </p:childTnLst>
+                                </p:cTn>
+                              </p:par>
+                            </p:childTnLst>
+                          </p:cTn>
+                        </p:par>
+                      </p:childTnLst>
+                    </p:cTn>
+                  </p:par>
+                </p:childTnLst>
+              </p:cTn>
+              <p:prevCondLst>
+                <p:cond evt="onPrev" delay="0">
+                  <p:tgtEl>
+                    <p:sldTgt/>
+                  </p:tgtEl>
+                </p:cond>
+              </p:prevCondLst>
+              <p:nextCondLst>
+                <p:cond evt="onNext" delay="0">
+                  <p:tgtEl>
+                    <p:sldTgt/>
+                  </p:tgtEl>
+                </p:cond>
+              </p:nextCondLst>
+            </p:seq>
+          </p:childTnLst>
+        </p:cTn>
+      </p:par>
+    </p:tnLst>
+    <p:bldLst>
+      <p:bldP spid="27" grpId="0"/>
+      <p:bldP spid="32" grpId="0"/>
+      <p:bldP spid="34" grpId="0"/>
+    </p:bldLst>
+  </p:timing>
+</p:sld>
+</file>
+
+<file path=ppt/slides/slide3.xml><?xml version="1.0" encoding="utf-8"?>
+<p:sld xmlns:a="http://schemas.openxmlformats.org/drawingml/2006/main" xmlns:r="http://schemas.openxmlformats.org/officeDocument/2006/relationships" xmlns:p="http://schemas.openxmlformats.org/presentationml/2006/main">
+  <p:cSld>
+    <p:spTree>
+      <p:nvGrpSpPr>
+        <p:cNvPr id="1" name=""/>
+        <p:cNvGrpSpPr/>
+        <p:nvPr/>
+      </p:nvGrpSpPr>
+      <p:grpSpPr>
+        <a:xfrm>
+          <a:off x="0" y="0"/>
+          <a:ext cx="0" cy="0"/>
+          <a:chOff x="0" y="0"/>
+          <a:chExt cx="0" cy="0"/>
+        </a:xfrm>
+      </p:grpSpPr>
+      <p:pic>
+        <p:nvPicPr>
+          <p:cNvPr id="8" name="Inhaltsplatzhalter 7">
+            <a:extLst>
+              <a:ext uri="{FF2B5EF4-FFF2-40B4-BE49-F238E27FC236}">
+                <a16:creationId xmlns:a16="http://schemas.microsoft.com/office/drawing/2014/main" id="{F0765812-13E2-1084-DEA8-82452F5ED969}"/>
+              </a:ext>
+            </a:extLst>
+          </p:cNvPr>
+          <p:cNvPicPr>
+            <a:picLocks noGrp="1" noChangeAspect="1"/>
+          </p:cNvPicPr>
+          <p:nvPr>
+            <p:ph idx="1"/>
+          </p:nvPr>
+        </p:nvPicPr>
+        <p:blipFill>
+          <a:blip r:embed="rId3">
+            <a:extLst>
+              <a:ext uri="{28A0092B-C50C-407E-A947-70E740481C1C}">
+                <a14:useLocalDpi xmlns:a14="http://schemas.microsoft.com/office/drawing/2010/main" val="0"/>
+              </a:ext>
+            </a:extLst>
+          </a:blip>
+          <a:stretch>
+            <a:fillRect/>
+          </a:stretch>
+        </p:blipFill>
+        <p:spPr>
+          <a:xfrm>
+            <a:off x="533627" y="862818"/>
+            <a:ext cx="11124745" cy="5132364"/>
+          </a:xfrm>
+          <a:prstGeom prst="rect">
+            <a:avLst/>
+          </a:prstGeom>
+        </p:spPr>
+      </p:pic>
+      <p:sp>
+        <p:nvSpPr>
+          <p:cNvPr id="4" name="Datumsplatzhalter 3">
+            <a:extLst>
+              <a:ext uri="{FF2B5EF4-FFF2-40B4-BE49-F238E27FC236}">
+                <a16:creationId xmlns:a16="http://schemas.microsoft.com/office/drawing/2014/main" id="{3E2B68C5-1929-BCF8-F8FB-4606C79CAC51}"/>
+              </a:ext>
+            </a:extLst>
+          </p:cNvPr>
+          <p:cNvSpPr>
+            <a:spLocks noGrp="1"/>
+          </p:cNvSpPr>
+          <p:nvPr>
+            <p:ph type="dt" sz="half" idx="10"/>
+          </p:nvPr>
+        </p:nvSpPr>
+        <p:spPr/>
+        <p:txBody>
+          <a:bodyPr/>
+          <a:lstStyle/>
+          <a:p>
+            <a:fld id="{F1DBF686-17EF-4B2F-B320-FDA5A791E320}" type="datetime1">
+              <a:rPr lang="de-DE" smtClean="0"/>
+              <a:t>24.10.2026</a:t>
+            </a:fld>
+            <a:endParaRPr lang="de-DE"/>
+          </a:p>
+        </p:txBody>
+      </p:sp>
+      <p:sp>
+        <p:nvSpPr>
+          <p:cNvPr id="5" name="Fußzeilenplatzhalter 4">
+            <a:extLst>
+              <a:ext uri="{FF2B5EF4-FFF2-40B4-BE49-F238E27FC236}">
+                <a16:creationId xmlns:a16="http://schemas.microsoft.com/office/drawing/2014/main" id="{0C19FB44-728E-A4CF-DE05-62EC73436D33}"/>
+              </a:ext>
+            </a:extLst>
+          </p:cNvPr>
+          <p:cNvSpPr>
+            <a:spLocks noGrp="1"/>
+          </p:cNvSpPr>
+          <p:nvPr>
+            <p:ph type="ftr" sz="quarter" idx="11"/>
+          </p:nvPr>
+        </p:nvSpPr>
+        <p:spPr/>
+        <p:txBody>
+          <a:bodyPr/>
+          <a:lstStyle/>
+          <a:p>
+            <a:r>
+              <a:rPr lang="de-DE"/>
+              <a:t>Munich Climate Week Hackathon - BayWa r.e. challenge - Lino &amp; Philip &amp; Thalea</a:t>
+            </a:r>
+          </a:p>
+        </p:txBody>
+      </p:sp>
+      <p:sp>
+        <p:nvSpPr>
+          <p:cNvPr id="6" name="Foliennummernplatzhalter 5">
+            <a:extLst>
+              <a:ext uri="{FF2B5EF4-FFF2-40B4-BE49-F238E27FC236}">
+                <a16:creationId xmlns:a16="http://schemas.microsoft.com/office/drawing/2014/main" id="{237F2538-0DEB-6C73-AFCD-93C59B39F623}"/>
+              </a:ext>
+            </a:extLst>
+          </p:cNvPr>
+          <p:cNvSpPr>
+            <a:spLocks noGrp="1"/>
+          </p:cNvSpPr>
+          <p:nvPr>
+            <p:ph type="sldNum" sz="quarter" idx="12"/>
+          </p:nvPr>
+        </p:nvSpPr>
+        <p:spPr/>
+        <p:txBody>
+          <a:bodyPr/>
+          <a:lstStyle/>
+          <a:p>
+            <a:fld id="{376AFD4C-B87D-482E-9604-D457C6441148}" type="slidenum">
+              <a:rPr lang="de-DE" smtClean="0"/>
+              <a:t>3</a:t>
+            </a:fld>
+            <a:endParaRPr lang="de-DE"/>
+          </a:p>
+        </p:txBody>
+      </p:sp>
+    </p:spTree>
+    <p:extLst>
+      <p:ext uri="{BB962C8B-B14F-4D97-AF65-F5344CB8AC3E}">
+        <p14:creationId xmlns:p14="http://schemas.microsoft.com/office/powerpoint/2010/main" val="3305117297"/>
+      </p:ext>
+    </p:extLst>
+  </p:cSld>
+  <p:clrMapOvr>
+    <a:masterClrMapping/>
+  </p:clrMapOvr>
+</p:sld>
+</file>
+
+<file path=ppt/slides/slide4.xml><?xml version="1.0" encoding="utf-8"?>
+<p:sld xmlns:a="http://schemas.openxmlformats.org/drawingml/2006/main" xmlns:r="http://schemas.openxmlformats.org/officeDocument/2006/relationships" xmlns:p="http://schemas.openxmlformats.org/presentationml/2006/main">
+  <p:cSld>
+    <p:spTree>
+      <p:nvGrpSpPr>
+        <p:cNvPr id="1" name=""/>
+        <p:cNvGrpSpPr/>
+        <p:nvPr/>
+      </p:nvGrpSpPr>
+      <p:grpSpPr>
+        <a:xfrm>
+          <a:off x="0" y="0"/>
+          <a:ext cx="0" cy="0"/>
+          <a:chOff x="0" y="0"/>
+          <a:chExt cx="0" cy="0"/>
+        </a:xfrm>
+      </p:grpSpPr>
+      <p:sp>
+        <p:nvSpPr>
+          <p:cNvPr id="4" name="Datumsplatzhalter 3">
+            <a:extLst>
+              <a:ext uri="{FF2B5EF4-FFF2-40B4-BE49-F238E27FC236}">
+                <a16:creationId xmlns:a16="http://schemas.microsoft.com/office/drawing/2014/main" id="{BC6D8B47-41CE-6A23-A808-30EB34968180}"/>
+              </a:ext>
+            </a:extLst>
+          </p:cNvPr>
+          <p:cNvSpPr>
+            <a:spLocks noGrp="1"/>
+          </p:cNvSpPr>
+          <p:nvPr>
+            <p:ph type="dt" sz="half" idx="10"/>
+          </p:nvPr>
+        </p:nvSpPr>
+        <p:spPr/>
+        <p:txBody>
+          <a:bodyPr/>
+          <a:lstStyle/>
+          <a:p>
+            <a:fld id="{F1DBF686-17EF-4B2F-B320-FDA5A791E320}" type="datetime1">
+              <a:rPr lang="de-DE" smtClean="0"/>
+              <a:t>24.10.2026</a:t>
+            </a:fld>
+            <a:endParaRPr lang="de-DE"/>
+          </a:p>
+        </p:txBody>
+      </p:sp>
+      <p:sp>
+        <p:nvSpPr>
+          <p:cNvPr id="5" name="Fußzeilenplatzhalter 4">
+            <a:extLst>
+              <a:ext uri="{FF2B5EF4-FFF2-40B4-BE49-F238E27FC236}">
+                <a16:creationId xmlns:a16="http://schemas.microsoft.com/office/drawing/2014/main" id="{9F78EE66-159F-11F9-672C-30197FB8780F}"/>
+              </a:ext>
+            </a:extLst>
+          </p:cNvPr>
+          <p:cNvSpPr>
+            <a:spLocks noGrp="1"/>
+          </p:cNvSpPr>
+          <p:nvPr>
+            <p:ph type="ftr" sz="quarter" idx="11"/>
+          </p:nvPr>
+        </p:nvSpPr>
+        <p:spPr/>
+        <p:txBody>
+          <a:bodyPr/>
+          <a:lstStyle/>
+          <a:p>
+            <a:r>
+              <a:rPr lang="de-DE"/>
+              <a:t>Munich Climate Week Hackathon - BayWa r.e. challenge - Lino &amp; Philip &amp; Thalea</a:t>
+            </a:r>
+          </a:p>
+        </p:txBody>
+      </p:sp>
+      <p:sp>
+        <p:nvSpPr>
+          <p:cNvPr id="6" name="Foliennummernplatzhalter 5">
+            <a:extLst>
+              <a:ext uri="{FF2B5EF4-FFF2-40B4-BE49-F238E27FC236}">
+                <a16:creationId xmlns:a16="http://schemas.microsoft.com/office/drawing/2014/main" id="{24B66739-5B51-F1D4-408B-1330740A9A69}"/>
+              </a:ext>
+            </a:extLst>
+          </p:cNvPr>
+          <p:cNvSpPr>
+            <a:spLocks noGrp="1"/>
+          </p:cNvSpPr>
+          <p:nvPr>
+            <p:ph type="sldNum" sz="quarter" idx="12"/>
+          </p:nvPr>
+        </p:nvSpPr>
+        <p:spPr/>
+        <p:txBody>
+          <a:bodyPr/>
+          <a:lstStyle/>
+          <a:p>
+            <a:fld id="{376AFD4C-B87D-482E-9604-D457C6441148}" type="slidenum">
+              <a:rPr lang="de-DE" smtClean="0"/>
+              <a:t>4</a:t>
+            </a:fld>
+            <a:endParaRPr lang="de-DE"/>
+          </a:p>
+        </p:txBody>
+      </p:sp>
+      <p:pic>
+        <p:nvPicPr>
+          <p:cNvPr id="48" name="Grafik 47">
+            <a:extLst>
+              <a:ext uri="{FF2B5EF4-FFF2-40B4-BE49-F238E27FC236}">
+                <a16:creationId xmlns:a16="http://schemas.microsoft.com/office/drawing/2014/main" id="{CB343B32-4529-D25A-9997-E8C277087411}"/>
+              </a:ext>
+            </a:extLst>
+          </p:cNvPr>
+          <p:cNvPicPr>
+            <a:picLocks noChangeAspect="1"/>
+          </p:cNvPicPr>
+          <p:nvPr/>
+        </p:nvPicPr>
+        <p:blipFill>
+          <a:blip r:embed="rId3"/>
+          <a:stretch>
+            <a:fillRect/>
+          </a:stretch>
+        </p:blipFill>
+        <p:spPr>
+          <a:xfrm>
+            <a:off x="301082" y="1061543"/>
+            <a:ext cx="11589836" cy="2997044"/>
+          </a:xfrm>
+          <a:prstGeom prst="rect">
+            <a:avLst/>
+          </a:prstGeom>
+        </p:spPr>
+      </p:pic>
+    </p:spTree>
+    <p:extLst>
+      <p:ext uri="{BB962C8B-B14F-4D97-AF65-F5344CB8AC3E}">
+        <p14:creationId xmlns:p14="http://schemas.microsoft.com/office/powerpoint/2010/main" val="2449662755"/>
       </p:ext>
     </p:extLst>
   </p:cSld>
@@ -5206,4 +6410,319 @@
     </a:ext>
   </a:extLst>
 </a:theme>
+</file>
+
+<file path=ppt/theme/theme2.xml><?xml version="1.0" encoding="utf-8"?>
+<a:theme xmlns:a="http://schemas.openxmlformats.org/drawingml/2006/main" name="Office">
+  <a:themeElements>
+    <a:clrScheme name="Office">
+      <a:dk1>
+        <a:sysClr val="windowText" lastClr="000000"/>
+      </a:dk1>
+      <a:lt1>
+        <a:sysClr val="window" lastClr="FFFFFF"/>
+      </a:lt1>
+      <a:dk2>
+        <a:srgbClr val="0E2841"/>
+      </a:dk2>
+      <a:lt2>
+        <a:srgbClr val="E8E8E8"/>
+      </a:lt2>
+      <a:accent1>
+        <a:srgbClr val="156082"/>
+      </a:accent1>
+      <a:accent2>
+        <a:srgbClr val="E97132"/>
+      </a:accent2>
+      <a:accent3>
+        <a:srgbClr val="196B24"/>
+      </a:accent3>
+      <a:accent4>
+        <a:srgbClr val="0F9ED5"/>
+      </a:accent4>
+      <a:accent5>
+        <a:srgbClr val="A02B93"/>
+      </a:accent5>
+      <a:accent6>
+        <a:srgbClr val="4EA72E"/>
+      </a:accent6>
+      <a:hlink>
+        <a:srgbClr val="467886"/>
+      </a:hlink>
+      <a:folHlink>
+        <a:srgbClr val="96607D"/>
+      </a:folHlink>
+    </a:clrScheme>
+    <a:fontScheme name="Office">
+      <a:majorFont>
+        <a:latin typeface="Aptos Display" panose="02110004020202020204"/>
+        <a:ea typeface=""/>
+        <a:cs typeface=""/>
+        <a:font script="Jpan" typeface="游ゴシック Light"/>
+        <a:font script="Hang" typeface="맑은 고딕"/>
+        <a:font script="Hans" typeface="等线 Light"/>
+        <a:font script="Hant" typeface="新細明體"/>
+        <a:font script="Arab" typeface="Times New Roman"/>
+        <a:font script="Hebr" typeface="Times New Roman"/>
+        <a:font script="Thai" typeface="Angsana New"/>
+        <a:font script="Ethi" typeface="Nyala"/>
+        <a:font script="Beng" typeface="Vrinda"/>
+        <a:font script="Gujr" typeface="Shruti"/>
+        <a:font script="Khmr" typeface="MoolBoran"/>
+        <a:font script="Knda" typeface="Tunga"/>
+        <a:font script="Guru" typeface="Raavi"/>
+        <a:font script="Cans" typeface="Euphemia"/>
+        <a:font script="Cher" typeface="Plantagenet Cherokee"/>
+        <a:font script="Yiii" typeface="Microsoft Yi Baiti"/>
+        <a:font script="Tibt" typeface="Microsoft Himalaya"/>
+        <a:font script="Thaa" typeface="MV Boli"/>
+        <a:font script="Deva" typeface="Mangal"/>
+        <a:font script="Telu" typeface="Gautami"/>
+        <a:font script="Taml" typeface="Latha"/>
+        <a:font script="Syrc" typeface="Estrangelo Edessa"/>
+        <a:font script="Orya" typeface="Kalinga"/>
+        <a:font script="Mlym" typeface="Kartika"/>
+        <a:font script="Laoo" typeface="DokChampa"/>
+        <a:font script="Sinh" typeface="Iskoola Pota"/>
+        <a:font script="Mong" typeface="Mongolian Baiti"/>
+        <a:font script="Viet" typeface="Times New Roman"/>
+        <a:font script="Uigh" typeface="Microsoft Uighur"/>
+        <a:font script="Geor" typeface="Sylfaen"/>
+        <a:font script="Armn" typeface="Arial"/>
+        <a:font script="Bugi" typeface="Leelawadee UI"/>
+        <a:font script="Bopo" typeface="Microsoft JhengHei"/>
+        <a:font script="Java" typeface="Javanese Text"/>
+        <a:font script="Lisu" typeface="Segoe UI"/>
+        <a:font script="Mymr" typeface="Myanmar Text"/>
+        <a:font script="Nkoo" typeface="Ebrima"/>
+        <a:font script="Olck" typeface="Nirmala UI"/>
+        <a:font script="Osma" typeface="Ebrima"/>
+        <a:font script="Phag" typeface="Phagspa"/>
+        <a:font script="Syrn" typeface="Estrangelo Edessa"/>
+        <a:font script="Syrj" typeface="Estrangelo Edessa"/>
+        <a:font script="Syre" typeface="Estrangelo Edessa"/>
+        <a:font script="Sora" typeface="Nirmala UI"/>
+        <a:font script="Tale" typeface="Microsoft Tai Le"/>
+        <a:font script="Talu" typeface="Microsoft New Tai Lue"/>
+        <a:font script="Tfng" typeface="Ebrima"/>
+      </a:majorFont>
+      <a:minorFont>
+        <a:latin typeface="Aptos" panose="02110004020202020204"/>
+        <a:ea typeface=""/>
+        <a:cs typeface=""/>
+        <a:font script="Jpan" typeface="游ゴシック"/>
+        <a:font script="Hang" typeface="맑은 고딕"/>
+        <a:font script="Hans" typeface="等线"/>
+        <a:font script="Hant" typeface="新細明體"/>
+        <a:font script="Arab" typeface="Arial"/>
+        <a:font script="Hebr" typeface="Arial"/>
+        <a:font script="Thai" typeface="Cordia New"/>
+        <a:font script="Ethi" typeface="Nyala"/>
+        <a:font script="Beng" typeface="Vrinda"/>
+        <a:font script="Gujr" typeface="Shruti"/>
+        <a:font script="Khmr" typeface="DaunPenh"/>
+        <a:font script="Knda" typeface="Tunga"/>
+        <a:font script="Guru" typeface="Raavi"/>
+        <a:font script="Cans" typeface="Euphemia"/>
+        <a:font script="Cher" typeface="Plantagenet Cherokee"/>
+        <a:font script="Yiii" typeface="Microsoft Yi Baiti"/>
+        <a:font script="Tibt" typeface="Microsoft Himalaya"/>
+        <a:font script="Thaa" typeface="MV Boli"/>
+        <a:font script="Deva" typeface="Mangal"/>
+        <a:font script="Telu" typeface="Gautami"/>
+        <a:font script="Taml" typeface="Latha"/>
+        <a:font script="Syrc" typeface="Estrangelo Edessa"/>
+        <a:font script="Orya" typeface="Kalinga"/>
+        <a:font script="Mlym" typeface="Kartika"/>
+        <a:font script="Laoo" typeface="DokChampa"/>
+        <a:font script="Sinh" typeface="Iskoola Pota"/>
+        <a:font script="Mong" typeface="Mongolian Baiti"/>
+        <a:font script="Viet" typeface="Arial"/>
+        <a:font script="Uigh" typeface="Microsoft Uighur"/>
+        <a:font script="Geor" typeface="Sylfaen"/>
+        <a:font script="Armn" typeface="Arial"/>
+        <a:font script="Bugi" typeface="Leelawadee UI"/>
+        <a:font script="Bopo" typeface="Microsoft JhengHei"/>
+        <a:font script="Java" typeface="Javanese Text"/>
+        <a:font script="Lisu" typeface="Segoe UI"/>
+        <a:font script="Mymr" typeface="Myanmar Text"/>
+        <a:font script="Nkoo" typeface="Ebrima"/>
+        <a:font script="Olck" typeface="Nirmala UI"/>
+        <a:font script="Osma" typeface="Ebrima"/>
+        <a:font script="Phag" typeface="Phagspa"/>
+        <a:font script="Syrn" typeface="Estrangelo Edessa"/>
+        <a:font script="Syrj" typeface="Estrangelo Edessa"/>
+        <a:font script="Syre" typeface="Estrangelo Edessa"/>
+        <a:font script="Sora" typeface="Nirmala UI"/>
+        <a:font script="Tale" typeface="Microsoft Tai Le"/>
+        <a:font script="Talu" typeface="Microsoft New Tai Lue"/>
+        <a:font script="Tfng" typeface="Ebrima"/>
+      </a:minorFont>
+    </a:fontScheme>
+    <a:fmtScheme name="Office">
+      <a:fillStyleLst>
+        <a:solidFill>
+          <a:schemeClr val="phClr"/>
+        </a:solidFill>
+        <a:gradFill rotWithShape="1">
+          <a:gsLst>
+            <a:gs pos="0">
+              <a:schemeClr val="phClr">
+                <a:lumMod val="110000"/>
+                <a:satMod val="105000"/>
+                <a:tint val="67000"/>
+              </a:schemeClr>
+            </a:gs>
+            <a:gs pos="50000">
+              <a:schemeClr val="phClr">
+                <a:lumMod val="105000"/>
+                <a:satMod val="103000"/>
+                <a:tint val="73000"/>
+              </a:schemeClr>
+            </a:gs>
+            <a:gs pos="100000">
+              <a:schemeClr val="phClr">
+                <a:lumMod val="105000"/>
+                <a:satMod val="109000"/>
+                <a:tint val="81000"/>
+              </a:schemeClr>
+            </a:gs>
+          </a:gsLst>
+          <a:lin ang="5400000" scaled="0"/>
+        </a:gradFill>
+        <a:gradFill rotWithShape="1">
+          <a:gsLst>
+            <a:gs pos="0">
+              <a:schemeClr val="phClr">
+                <a:satMod val="103000"/>
+                <a:lumMod val="102000"/>
+                <a:tint val="94000"/>
+              </a:schemeClr>
+            </a:gs>
+            <a:gs pos="50000">
+              <a:schemeClr val="phClr">
+                <a:satMod val="110000"/>
+                <a:lumMod val="100000"/>
+                <a:shade val="100000"/>
+              </a:schemeClr>
+            </a:gs>
+            <a:gs pos="100000">
+              <a:schemeClr val="phClr">
+                <a:lumMod val="99000"/>
+                <a:satMod val="120000"/>
+                <a:shade val="78000"/>
+              </a:schemeClr>
+            </a:gs>
+          </a:gsLst>
+          <a:lin ang="5400000" scaled="0"/>
+        </a:gradFill>
+      </a:fillStyleLst>
+      <a:lnStyleLst>
+        <a:ln w="12700" cap="flat" cmpd="sng" algn="ctr">
+          <a:solidFill>
+            <a:schemeClr val="phClr"/>
+          </a:solidFill>
+          <a:prstDash val="solid"/>
+          <a:miter lim="800000"/>
+        </a:ln>
+        <a:ln w="19050" cap="flat" cmpd="sng" algn="ctr">
+          <a:solidFill>
+            <a:schemeClr val="phClr"/>
+          </a:solidFill>
+          <a:prstDash val="solid"/>
+          <a:miter lim="800000"/>
+        </a:ln>
+        <a:ln w="25400" cap="flat" cmpd="sng" algn="ctr">
+          <a:solidFill>
+            <a:schemeClr val="phClr"/>
+          </a:solidFill>
+          <a:prstDash val="solid"/>
+          <a:miter lim="800000"/>
+        </a:ln>
+      </a:lnStyleLst>
+      <a:effectStyleLst>
+        <a:effectStyle>
+          <a:effectLst/>
+        </a:effectStyle>
+        <a:effectStyle>
+          <a:effectLst/>
+        </a:effectStyle>
+        <a:effectStyle>
+          <a:effectLst>
+            <a:outerShdw blurRad="57150" dist="19050" dir="5400000" algn="ctr" rotWithShape="0">
+              <a:srgbClr val="000000">
+                <a:alpha val="63000"/>
+              </a:srgbClr>
+            </a:outerShdw>
+          </a:effectLst>
+        </a:effectStyle>
+      </a:effectStyleLst>
+      <a:bgFillStyleLst>
+        <a:solidFill>
+          <a:schemeClr val="phClr"/>
+        </a:solidFill>
+        <a:solidFill>
+          <a:schemeClr val="phClr">
+            <a:tint val="95000"/>
+            <a:satMod val="170000"/>
+          </a:schemeClr>
+        </a:solidFill>
+        <a:gradFill rotWithShape="1">
+          <a:gsLst>
+            <a:gs pos="0">
+              <a:schemeClr val="phClr">
+                <a:tint val="93000"/>
+                <a:satMod val="150000"/>
+                <a:shade val="98000"/>
+                <a:lumMod val="102000"/>
+              </a:schemeClr>
+            </a:gs>
+            <a:gs pos="50000">
+              <a:schemeClr val="phClr">
+                <a:tint val="98000"/>
+                <a:satMod val="130000"/>
+                <a:shade val="90000"/>
+                <a:lumMod val="103000"/>
+              </a:schemeClr>
+            </a:gs>
+            <a:gs pos="100000">
+              <a:schemeClr val="phClr">
+                <a:shade val="63000"/>
+                <a:satMod val="120000"/>
+              </a:schemeClr>
+            </a:gs>
+          </a:gsLst>
+          <a:lin ang="5400000" scaled="0"/>
+        </a:gradFill>
+      </a:bgFillStyleLst>
+    </a:fmtScheme>
+  </a:themeElements>
+  <a:objectDefaults>
+    <a:lnDef>
+      <a:spPr/>
+      <a:bodyPr/>
+      <a:lstStyle/>
+      <a:style>
+        <a:lnRef idx="2">
+          <a:schemeClr val="accent1"/>
+        </a:lnRef>
+        <a:fillRef idx="0">
+          <a:schemeClr val="accent1"/>
+        </a:fillRef>
+        <a:effectRef idx="1">
+          <a:schemeClr val="accent1"/>
+        </a:effectRef>
+        <a:fontRef idx="minor">
+          <a:schemeClr val="tx1"/>
+        </a:fontRef>
+      </a:style>
+    </a:lnDef>
+  </a:objectDefaults>
+  <a:extraClrSchemeLst/>
+  <a:extLst>
+    <a:ext uri="{05A4C25C-085E-4340-85A3-A5531E510DB2}">
+      <thm15:themeFamily xmlns:thm15="http://schemas.microsoft.com/office/thememl/2012/main" name="Office Theme" id="{2E142A2C-CD16-42D6-873A-C26D2A0506FA}" vid="{1BDDFF52-6CD6-40A5-AB3C-68EB2F1E4D0A}"/>
+    </a:ext>
+  </a:extLst>
+</a:theme>
 </file>
</xml_diff>

<commit_message>
Add presentation file for Munich Climate Week Hackathon with project insights
</commit_message>
<xml_diff>
--- a/presi.pptx
+++ b/presi.pptx
@@ -553,6 +553,14 @@
             <a:r>
               <a:rPr lang="de-DE" dirty="0" err="1"/>
               <a:t>speed</a:t>
+            </a:r>
+            <a:r>
+              <a:rPr lang="de-DE" dirty="0"/>
+              <a:t> to smooth out </a:t>
+            </a:r>
+            <a:r>
+              <a:rPr lang="de-DE" dirty="0" err="1"/>
+              <a:t>gusts</a:t>
             </a:r>
             <a:endParaRPr lang="de-DE" dirty="0"/>
           </a:p>
@@ -5814,130 +5822,147 @@
           <a:chExt cx="0" cy="0"/>
         </a:xfrm>
       </p:grpSpPr>
+      <p:sp>
+        <p:nvSpPr>
+          <p:cNvPr id="4" name="Datumsplatzhalter 3">
+            <a:extLst>
+              <a:ext uri="{FF2B5EF4-FFF2-40B4-BE49-F238E27FC236}">
+                <a16:creationId xmlns:a16="http://schemas.microsoft.com/office/drawing/2014/main" id="{3E2B68C5-1929-BCF8-F8FB-4606C79CAC51}"/>
+              </a:ext>
+            </a:extLst>
+          </p:cNvPr>
+          <p:cNvSpPr>
+            <a:spLocks noGrp="1"/>
+          </p:cNvSpPr>
+          <p:nvPr>
+            <p:ph type="dt" sz="half" idx="10"/>
+          </p:nvPr>
+        </p:nvSpPr>
+        <p:spPr/>
+        <p:txBody>
+          <a:bodyPr/>
+          <a:lstStyle/>
+          <a:p>
+            <a:fld id="{F1DBF686-17EF-4B2F-B320-FDA5A791E320}" type="datetime1">
+              <a:rPr lang="de-DE" smtClean="0"/>
+              <a:t>24.10.2026</a:t>
+            </a:fld>
+            <a:endParaRPr lang="de-DE"/>
+          </a:p>
+        </p:txBody>
+      </p:sp>
+      <p:sp>
+        <p:nvSpPr>
+          <p:cNvPr id="5" name="Fußzeilenplatzhalter 4">
+            <a:extLst>
+              <a:ext uri="{FF2B5EF4-FFF2-40B4-BE49-F238E27FC236}">
+                <a16:creationId xmlns:a16="http://schemas.microsoft.com/office/drawing/2014/main" id="{0C19FB44-728E-A4CF-DE05-62EC73436D33}"/>
+              </a:ext>
+            </a:extLst>
+          </p:cNvPr>
+          <p:cNvSpPr>
+            <a:spLocks noGrp="1"/>
+          </p:cNvSpPr>
+          <p:nvPr>
+            <p:ph type="ftr" sz="quarter" idx="11"/>
+          </p:nvPr>
+        </p:nvSpPr>
+        <p:spPr/>
+        <p:txBody>
+          <a:bodyPr/>
+          <a:lstStyle/>
+          <a:p>
+            <a:r>
+              <a:rPr lang="de-DE"/>
+              <a:t>Munich Climate Week Hackathon - BayWa r.e. challenge - Lino &amp; Philip &amp; Thalea</a:t>
+            </a:r>
+          </a:p>
+        </p:txBody>
+      </p:sp>
+      <p:sp>
+        <p:nvSpPr>
+          <p:cNvPr id="6" name="Foliennummernplatzhalter 5">
+            <a:extLst>
+              <a:ext uri="{FF2B5EF4-FFF2-40B4-BE49-F238E27FC236}">
+                <a16:creationId xmlns:a16="http://schemas.microsoft.com/office/drawing/2014/main" id="{237F2538-0DEB-6C73-AFCD-93C59B39F623}"/>
+              </a:ext>
+            </a:extLst>
+          </p:cNvPr>
+          <p:cNvSpPr>
+            <a:spLocks noGrp="1"/>
+          </p:cNvSpPr>
+          <p:nvPr>
+            <p:ph type="sldNum" sz="quarter" idx="12"/>
+          </p:nvPr>
+        </p:nvSpPr>
+        <p:spPr/>
+        <p:txBody>
+          <a:bodyPr/>
+          <a:lstStyle/>
+          <a:p>
+            <a:fld id="{376AFD4C-B87D-482E-9604-D457C6441148}" type="slidenum">
+              <a:rPr lang="de-DE" smtClean="0"/>
+              <a:t>3</a:t>
+            </a:fld>
+            <a:endParaRPr lang="de-DE"/>
+          </a:p>
+        </p:txBody>
+      </p:sp>
+      <p:sp>
+        <p:nvSpPr>
+          <p:cNvPr id="10" name="Inhaltsplatzhalter 9">
+            <a:extLst>
+              <a:ext uri="{FF2B5EF4-FFF2-40B4-BE49-F238E27FC236}">
+                <a16:creationId xmlns:a16="http://schemas.microsoft.com/office/drawing/2014/main" id="{A2AD8D3B-9042-AA99-050B-262E836CA8B3}"/>
+              </a:ext>
+            </a:extLst>
+          </p:cNvPr>
+          <p:cNvSpPr>
+            <a:spLocks noGrp="1"/>
+          </p:cNvSpPr>
+          <p:nvPr>
+            <p:ph idx="1"/>
+          </p:nvPr>
+        </p:nvSpPr>
+        <p:spPr/>
+        <p:txBody>
+          <a:bodyPr/>
+          <a:lstStyle/>
+          <a:p>
+            <a:endParaRPr lang="de-DE"/>
+          </a:p>
+        </p:txBody>
+      </p:sp>
       <p:pic>
         <p:nvPicPr>
-          <p:cNvPr id="8" name="Inhaltsplatzhalter 7">
-            <a:extLst>
-              <a:ext uri="{FF2B5EF4-FFF2-40B4-BE49-F238E27FC236}">
-                <a16:creationId xmlns:a16="http://schemas.microsoft.com/office/drawing/2014/main" id="{F0765812-13E2-1084-DEA8-82452F5ED969}"/>
+          <p:cNvPr id="12" name="Grafik 11">
+            <a:extLst>
+              <a:ext uri="{FF2B5EF4-FFF2-40B4-BE49-F238E27FC236}">
+                <a16:creationId xmlns:a16="http://schemas.microsoft.com/office/drawing/2014/main" id="{9B6D5566-061F-0CAA-14A0-254828E3EAE0}"/>
               </a:ext>
             </a:extLst>
           </p:cNvPr>
           <p:cNvPicPr>
-            <a:picLocks noGrp="1" noChangeAspect="1"/>
+            <a:picLocks noChangeAspect="1"/>
           </p:cNvPicPr>
-          <p:nvPr>
-            <p:ph idx="1"/>
-          </p:nvPr>
+          <p:nvPr/>
         </p:nvPicPr>
         <p:blipFill>
-          <a:blip r:embed="rId3">
-            <a:extLst>
-              <a:ext uri="{28A0092B-C50C-407E-A947-70E740481C1C}">
-                <a14:useLocalDpi xmlns:a14="http://schemas.microsoft.com/office/drawing/2010/main" val="0"/>
-              </a:ext>
-            </a:extLst>
-          </a:blip>
+          <a:blip r:embed="rId3"/>
           <a:stretch>
             <a:fillRect/>
           </a:stretch>
         </p:blipFill>
         <p:spPr>
           <a:xfrm>
-            <a:off x="533627" y="862818"/>
-            <a:ext cx="11124745" cy="5132364"/>
+            <a:off x="225123" y="1071301"/>
+            <a:ext cx="11741753" cy="5105662"/>
           </a:xfrm>
           <a:prstGeom prst="rect">
             <a:avLst/>
           </a:prstGeom>
         </p:spPr>
       </p:pic>
-      <p:sp>
-        <p:nvSpPr>
-          <p:cNvPr id="4" name="Datumsplatzhalter 3">
-            <a:extLst>
-              <a:ext uri="{FF2B5EF4-FFF2-40B4-BE49-F238E27FC236}">
-                <a16:creationId xmlns:a16="http://schemas.microsoft.com/office/drawing/2014/main" id="{3E2B68C5-1929-BCF8-F8FB-4606C79CAC51}"/>
-              </a:ext>
-            </a:extLst>
-          </p:cNvPr>
-          <p:cNvSpPr>
-            <a:spLocks noGrp="1"/>
-          </p:cNvSpPr>
-          <p:nvPr>
-            <p:ph type="dt" sz="half" idx="10"/>
-          </p:nvPr>
-        </p:nvSpPr>
-        <p:spPr/>
-        <p:txBody>
-          <a:bodyPr/>
-          <a:lstStyle/>
-          <a:p>
-            <a:fld id="{F1DBF686-17EF-4B2F-B320-FDA5A791E320}" type="datetime1">
-              <a:rPr lang="de-DE" smtClean="0"/>
-              <a:t>24.10.2026</a:t>
-            </a:fld>
-            <a:endParaRPr lang="de-DE"/>
-          </a:p>
-        </p:txBody>
-      </p:sp>
-      <p:sp>
-        <p:nvSpPr>
-          <p:cNvPr id="5" name="Fußzeilenplatzhalter 4">
-            <a:extLst>
-              <a:ext uri="{FF2B5EF4-FFF2-40B4-BE49-F238E27FC236}">
-                <a16:creationId xmlns:a16="http://schemas.microsoft.com/office/drawing/2014/main" id="{0C19FB44-728E-A4CF-DE05-62EC73436D33}"/>
-              </a:ext>
-            </a:extLst>
-          </p:cNvPr>
-          <p:cNvSpPr>
-            <a:spLocks noGrp="1"/>
-          </p:cNvSpPr>
-          <p:nvPr>
-            <p:ph type="ftr" sz="quarter" idx="11"/>
-          </p:nvPr>
-        </p:nvSpPr>
-        <p:spPr/>
-        <p:txBody>
-          <a:bodyPr/>
-          <a:lstStyle/>
-          <a:p>
-            <a:r>
-              <a:rPr lang="de-DE"/>
-              <a:t>Munich Climate Week Hackathon - BayWa r.e. challenge - Lino &amp; Philip &amp; Thalea</a:t>
-            </a:r>
-          </a:p>
-        </p:txBody>
-      </p:sp>
-      <p:sp>
-        <p:nvSpPr>
-          <p:cNvPr id="6" name="Foliennummernplatzhalter 5">
-            <a:extLst>
-              <a:ext uri="{FF2B5EF4-FFF2-40B4-BE49-F238E27FC236}">
-                <a16:creationId xmlns:a16="http://schemas.microsoft.com/office/drawing/2014/main" id="{237F2538-0DEB-6C73-AFCD-93C59B39F623}"/>
-              </a:ext>
-            </a:extLst>
-          </p:cNvPr>
-          <p:cNvSpPr>
-            <a:spLocks noGrp="1"/>
-          </p:cNvSpPr>
-          <p:nvPr>
-            <p:ph type="sldNum" sz="quarter" idx="12"/>
-          </p:nvPr>
-        </p:nvSpPr>
-        <p:spPr/>
-        <p:txBody>
-          <a:bodyPr/>
-          <a:lstStyle/>
-          <a:p>
-            <a:fld id="{376AFD4C-B87D-482E-9604-D457C6441148}" type="slidenum">
-              <a:rPr lang="de-DE" smtClean="0"/>
-              <a:t>3</a:t>
-            </a:fld>
-            <a:endParaRPr lang="de-DE"/>
-          </a:p>
-        </p:txBody>
-      </p:sp>
     </p:spTree>
     <p:extLst>
       <p:ext uri="{BB962C8B-B14F-4D97-AF65-F5344CB8AC3E}">
@@ -6076,7 +6101,7 @@
         </p:blipFill>
         <p:spPr>
           <a:xfrm>
-            <a:off x="301082" y="1061543"/>
+            <a:off x="301082" y="1463315"/>
             <a:ext cx="11589836" cy="2997044"/>
           </a:xfrm>
           <a:prstGeom prst="rect">
@@ -6084,6 +6109,78 @@
           </a:prstGeom>
         </p:spPr>
       </p:pic>
+      <p:sp>
+        <p:nvSpPr>
+          <p:cNvPr id="51" name="Textfeld 50">
+            <a:extLst>
+              <a:ext uri="{FF2B5EF4-FFF2-40B4-BE49-F238E27FC236}">
+                <a16:creationId xmlns:a16="http://schemas.microsoft.com/office/drawing/2014/main" id="{FA8E8B25-D000-D64F-19DC-8CAF2DAB32A5}"/>
+              </a:ext>
+            </a:extLst>
+          </p:cNvPr>
+          <p:cNvSpPr txBox="1"/>
+          <p:nvPr/>
+        </p:nvSpPr>
+        <p:spPr>
+          <a:xfrm>
+            <a:off x="1108320" y="5040742"/>
+            <a:ext cx="9975359" cy="707886"/>
+          </a:xfrm>
+          <a:prstGeom prst="rect">
+            <a:avLst/>
+          </a:prstGeom>
+          <a:noFill/>
+        </p:spPr>
+        <p:txBody>
+          <a:bodyPr wrap="none" rtlCol="0">
+            <a:spAutoFit/>
+          </a:bodyPr>
+          <a:lstStyle/>
+          <a:p>
+            <a:pPr algn="ctr"/>
+            <a:r>
+              <a:rPr lang="de-DE" sz="4000" b="1" dirty="0" err="1"/>
+              <a:t>summed</a:t>
+            </a:r>
+            <a:r>
+              <a:rPr lang="de-DE" sz="4000" b="1" dirty="0"/>
+              <a:t> </a:t>
+            </a:r>
+            <a:r>
+              <a:rPr lang="de-DE" sz="4000" b="1" dirty="0" err="1"/>
+              <a:t>energy</a:t>
+            </a:r>
+            <a:r>
+              <a:rPr lang="de-DE" sz="4000" b="1" dirty="0"/>
+              <a:t> </a:t>
+            </a:r>
+            <a:r>
+              <a:rPr lang="de-DE" sz="4000" b="1" dirty="0" err="1"/>
+              <a:t>deviation</a:t>
+            </a:r>
+            <a:r>
+              <a:rPr lang="de-DE" sz="4000" b="1" dirty="0"/>
+              <a:t> on </a:t>
+            </a:r>
+            <a:r>
+              <a:rPr lang="de-DE" sz="4000" b="1" dirty="0" err="1"/>
+              <a:t>test</a:t>
+            </a:r>
+            <a:r>
+              <a:rPr lang="de-DE" sz="4000" b="1" dirty="0"/>
+              <a:t> </a:t>
+            </a:r>
+            <a:r>
+              <a:rPr lang="de-DE" sz="4000" b="1" dirty="0" err="1"/>
+              <a:t>set</a:t>
+            </a:r>
+            <a:r>
+              <a:rPr lang="de-DE" sz="4000" b="1" dirty="0"/>
+              <a:t> 2.5%</a:t>
+            </a:r>
+          </a:p>
+        </p:txBody>
+      </p:sp>
     </p:spTree>
     <p:extLst>
       <p:ext uri="{BB962C8B-B14F-4D97-AF65-F5344CB8AC3E}">
@@ -6094,6 +6191,87 @@
   <p:clrMapOvr>
     <a:masterClrMapping/>
   </p:clrMapOvr>
+  <p:timing>
+    <p:tnLst>
+      <p:par>
+        <p:cTn id="1" dur="indefinite" restart="never" nodeType="tmRoot">
+          <p:childTnLst>
+            <p:seq concurrent="1" nextAc="seek">
+              <p:cTn id="2" dur="indefinite" nodeType="mainSeq">
+                <p:childTnLst>
+                  <p:par>
+                    <p:cTn id="3" fill="hold">
+                      <p:stCondLst>
+                        <p:cond delay="indefinite"/>
+                        <p:cond evt="onBegin" delay="0">
+                          <p:tn val="2"/>
+                        </p:cond>
+                      </p:stCondLst>
+                      <p:childTnLst>
+                        <p:par>
+                          <p:cTn id="4" fill="hold">
+                            <p:stCondLst>
+                              <p:cond delay="0"/>
+                            </p:stCondLst>
+                            <p:childTnLst>
+                              <p:par>
+                                <p:cTn id="5" presetID="1" presetClass="entr" presetSubtype="0" fill="hold" grpId="0" nodeType="withEffect">
+                                  <p:stCondLst>
+                                    <p:cond delay="0"/>
+                                  </p:stCondLst>
+                                  <p:childTnLst>
+                                    <p:set>
+                                      <p:cBhvr>
+                                        <p:cTn id="6" dur="1" fill="hold">
+                                          <p:stCondLst>
+                                            <p:cond delay="0"/>
+                                          </p:stCondLst>
+                                        </p:cTn>
+                                        <p:tgtEl>
+                                          <p:spTgt spid="51"/>
+                                        </p:tgtEl>
+                                        <p:attrNameLst>
+                                          <p:attrName>style.visibility</p:attrName>
+                                        </p:attrNameLst>
+                                      </p:cBhvr>
+                                      <p:to>
+                                        <p:strVal val="visible"/>
+                                      </p:to>
+                                    </p:set>
+                                  </p:childTnLst>
+                                </p:cTn>
+                              </p:par>
+                            </p:childTnLst>
+                          </p:cTn>
+                        </p:par>
+                      </p:childTnLst>
+                    </p:cTn>
+                  </p:par>
+                </p:childTnLst>
+              </p:cTn>
+              <p:prevCondLst>
+                <p:cond evt="onPrev" delay="0">
+                  <p:tgtEl>
+                    <p:sldTgt/>
+                  </p:tgtEl>
+                </p:cond>
+              </p:prevCondLst>
+              <p:nextCondLst>
+                <p:cond evt="onNext" delay="0">
+                  <p:tgtEl>
+                    <p:sldTgt/>
+                  </p:tgtEl>
+                </p:cond>
+              </p:nextCondLst>
+            </p:seq>
+          </p:childTnLst>
+        </p:cTn>
+      </p:par>
+    </p:tnLst>
+    <p:bldLst>
+      <p:bldP spid="51" grpId="0"/>
+    </p:bldLst>
+  </p:timing>
 </p:sld>
 </file>
 

</xml_diff>